<commit_message>
Update topic 1.1 cover infographic
</commit_message>
<xml_diff>
--- a/05_Outputs/Air Conditioning/English Slides/Air Con Chapter 1 Topic 1.1 - Visual Lecture Deck CLEAN with TA Figures.pptx
+++ b/05_Outputs/Air Conditioning/English Slides/Air Con Chapter 1 Topic 1.1 - Visual Lecture Deck CLEAN with TA Figures.pptx
@@ -3119,7 +3119,7 @@
         <p:spPr>
           <a:xfrm>
             <a:off x="0" y="0"/>
-            <a:ext cx="12191999" cy="201168"/>
+            <a:ext cx="12191999" cy="182880"/>
           </a:xfrm>
           <a:prstGeom prst="rect">
             <a:avLst/>
@@ -3155,62 +3155,182 @@
       </p:sp>
       <p:sp>
         <p:nvSpPr>
-          <p:cNvPr id="3" name="TextBox 2"/>
-          <p:cNvSpPr txBox="1"/>
-          <p:nvPr/>
-        </p:nvSpPr>
-        <p:spPr>
-          <a:xfrm>
-            <a:off x="502920" y="457200"/>
-            <a:ext cx="11064240" cy="640080"/>
-          </a:xfrm>
-          <a:prstGeom prst="rect">
-            <a:avLst/>
-          </a:prstGeom>
-          <a:noFill/>
-        </p:spPr>
-        <p:txBody>
-          <a:bodyPr wrap="square">
-            <a:spAutoFit/>
-          </a:bodyPr>
-          <a:lstStyle/>
-          <a:p>
-            <a:r>
-              <a:rPr sz="3000" b="1" i="0">
+          <p:cNvPr id="3" name="Right Triangle 2"/>
+          <p:cNvSpPr/>
+          <p:nvPr/>
+        </p:nvSpPr>
+        <p:spPr>
+          <a:xfrm>
+            <a:off x="8778240" y="182880"/>
+            <a:ext cx="3429000" cy="2194560"/>
+          </a:xfrm>
+          <a:prstGeom prst="rtTriangle">
+            <a:avLst/>
+          </a:prstGeom>
+          <a:solidFill>
+            <a:srgbClr val="E7F4F7"/>
+          </a:solidFill>
+          <a:ln>
+            <a:noFill/>
+          </a:ln>
+        </p:spPr>
+        <p:style>
+          <a:lnRef idx="1">
+            <a:schemeClr val="accent1"/>
+          </a:lnRef>
+          <a:fillRef idx="3">
+            <a:schemeClr val="accent1"/>
+          </a:fillRef>
+          <a:effectRef idx="2">
+            <a:schemeClr val="accent1"/>
+          </a:effectRef>
+          <a:fontRef idx="minor">
+            <a:schemeClr val="lt1"/>
+          </a:fontRef>
+        </p:style>
+        <p:txBody>
+          <a:bodyPr rtlCol="0" anchor="ctr"/>
+          <a:lstStyle/>
+          <a:p>
+            <a:pPr algn="ctr"/>
+          </a:p>
+        </p:txBody>
+      </p:sp>
+      <p:sp>
+        <p:nvSpPr>
+          <p:cNvPr id="4" name="Right Triangle 3"/>
+          <p:cNvSpPr/>
+          <p:nvPr/>
+        </p:nvSpPr>
+        <p:spPr>
+          <a:xfrm>
+            <a:off x="9646920" y="4160520"/>
+            <a:ext cx="2560320" cy="2514600"/>
+          </a:xfrm>
+          <a:prstGeom prst="rtTriangle">
+            <a:avLst/>
+          </a:prstGeom>
+          <a:solidFill>
+            <a:srgbClr val="FFEFE6"/>
+          </a:solidFill>
+          <a:ln>
+            <a:noFill/>
+          </a:ln>
+        </p:spPr>
+        <p:style>
+          <a:lnRef idx="1">
+            <a:schemeClr val="accent1"/>
+          </a:lnRef>
+          <a:fillRef idx="3">
+            <a:schemeClr val="accent1"/>
+          </a:fillRef>
+          <a:effectRef idx="2">
+            <a:schemeClr val="accent1"/>
+          </a:effectRef>
+          <a:fontRef idx="minor">
+            <a:schemeClr val="lt1"/>
+          </a:fontRef>
+        </p:style>
+        <p:txBody>
+          <a:bodyPr rtlCol="0" anchor="ctr"/>
+          <a:lstStyle/>
+          <a:p>
+            <a:pPr algn="ctr"/>
+          </a:p>
+        </p:txBody>
+      </p:sp>
+      <p:sp>
+        <p:nvSpPr>
+          <p:cNvPr id="5" name="TextBox 4"/>
+          <p:cNvSpPr txBox="1"/>
+          <p:nvPr/>
+        </p:nvSpPr>
+        <p:spPr>
+          <a:xfrm>
+            <a:off x="621792" y="749808"/>
+            <a:ext cx="5394960" cy="320040"/>
+          </a:xfrm>
+          <a:prstGeom prst="rect">
+            <a:avLst/>
+          </a:prstGeom>
+          <a:noFill/>
+        </p:spPr>
+        <p:txBody>
+          <a:bodyPr wrap="square">
+            <a:spAutoFit/>
+          </a:bodyPr>
+          <a:lstStyle/>
+          <a:p>
+            <a:r>
+              <a:rPr sz="1300" b="1" i="0">
+                <a:solidFill>
+                  <a:srgbClr val="2A9D8F"/>
+                </a:solidFill>
+                <a:latin typeface="Aptos"/>
+              </a:rPr>
+              <a:t>AIR CONDITIONING · CHAPTER 1</a:t>
+            </a:r>
+          </a:p>
+        </p:txBody>
+      </p:sp>
+      <p:sp>
+        <p:nvSpPr>
+          <p:cNvPr id="6" name="TextBox 5"/>
+          <p:cNvSpPr txBox="1"/>
+          <p:nvPr/>
+        </p:nvSpPr>
+        <p:spPr>
+          <a:xfrm>
+            <a:off x="594360" y="1170432"/>
+            <a:ext cx="5760720" cy="868680"/>
+          </a:xfrm>
+          <a:prstGeom prst="rect">
+            <a:avLst/>
+          </a:prstGeom>
+          <a:noFill/>
+        </p:spPr>
+        <p:txBody>
+          <a:bodyPr wrap="square">
+            <a:spAutoFit/>
+          </a:bodyPr>
+          <a:lstStyle/>
+          <a:p>
+            <a:r>
+              <a:rPr sz="3700" b="1" i="0">
                 <a:solidFill>
                   <a:srgbClr val="11374B"/>
                 </a:solidFill>
                 <a:latin typeface="Aptos"/>
               </a:rPr>
-              <a:t>1.1 | Air Conditioning</a:t>
-            </a:r>
-          </a:p>
-        </p:txBody>
-      </p:sp>
-      <p:sp>
-        <p:nvSpPr>
-          <p:cNvPr id="4" name="TextBox 3"/>
-          <p:cNvSpPr txBox="1"/>
-          <p:nvPr/>
-        </p:nvSpPr>
-        <p:spPr>
-          <a:xfrm>
-            <a:off x="530352" y="1060704"/>
-            <a:ext cx="10972800" cy="365760"/>
-          </a:xfrm>
-          <a:prstGeom prst="rect">
-            <a:avLst/>
-          </a:prstGeom>
-          <a:noFill/>
-        </p:spPr>
-        <p:txBody>
-          <a:bodyPr wrap="square">
-            <a:spAutoFit/>
-          </a:bodyPr>
-          <a:lstStyle/>
-          <a:p>
-            <a:r>
-              <a:rPr sz="1400" b="0" i="0">
+              <a:t>1.1 Air Conditioning</a:t>
+            </a:r>
+          </a:p>
+        </p:txBody>
+      </p:sp>
+      <p:sp>
+        <p:nvSpPr>
+          <p:cNvPr id="7" name="TextBox 6"/>
+          <p:cNvSpPr txBox="1"/>
+          <p:nvPr/>
+        </p:nvSpPr>
+        <p:spPr>
+          <a:xfrm>
+            <a:off x="621792" y="1975104"/>
+            <a:ext cx="5669280" cy="384048"/>
+          </a:xfrm>
+          <a:prstGeom prst="rect">
+            <a:avLst/>
+          </a:prstGeom>
+          <a:noFill/>
+        </p:spPr>
+        <p:txBody>
+          <a:bodyPr wrap="square">
+            <a:spAutoFit/>
+          </a:bodyPr>
+          <a:lstStyle/>
+          <a:p>
+            <a:r>
+              <a:rPr sz="1800" b="0" i="0">
                 <a:solidFill>
                   <a:srgbClr val="5A6973"/>
                 </a:solidFill>
@@ -3223,118 +3343,128 @@
       </p:sp>
       <p:sp>
         <p:nvSpPr>
-          <p:cNvPr id="5" name="TextBox 4"/>
-          <p:cNvSpPr txBox="1"/>
-          <p:nvPr/>
-        </p:nvSpPr>
-        <p:spPr>
-          <a:xfrm>
-            <a:off x="11292840" y="502920"/>
-            <a:ext cx="548640" cy="274320"/>
-          </a:xfrm>
-          <a:prstGeom prst="rect">
-            <a:avLst/>
-          </a:prstGeom>
-          <a:noFill/>
-        </p:spPr>
-        <p:txBody>
-          <a:bodyPr wrap="square">
-            <a:spAutoFit/>
-          </a:bodyPr>
-          <a:lstStyle/>
-          <a:p>
-            <a:pPr algn="r"/>
-            <a:r>
-              <a:rPr sz="1100" b="0" i="0">
-                <a:solidFill>
-                  <a:srgbClr val="78828C"/>
-                </a:solidFill>
-                <a:latin typeface="Aptos"/>
-              </a:rPr>
-              <a:t>1</a:t>
-            </a:r>
-          </a:p>
-        </p:txBody>
-      </p:sp>
-      <p:sp>
-        <p:nvSpPr>
-          <p:cNvPr id="6" name="TextBox 5"/>
-          <p:cNvSpPr txBox="1"/>
-          <p:nvPr/>
-        </p:nvSpPr>
-        <p:spPr>
-          <a:xfrm>
-            <a:off x="365760" y="6446520"/>
-            <a:ext cx="8229600" cy="228600"/>
-          </a:xfrm>
-          <a:prstGeom prst="rect">
-            <a:avLst/>
-          </a:prstGeom>
-          <a:noFill/>
-        </p:spPr>
-        <p:txBody>
-          <a:bodyPr wrap="square">
-            <a:spAutoFit/>
-          </a:bodyPr>
-          <a:lstStyle/>
-          <a:p>
-            <a:r>
-              <a:rPr sz="900" b="0" i="0">
-                <a:solidFill>
-                  <a:srgbClr val="78828C"/>
-                </a:solidFill>
-                <a:latin typeface="Aptos"/>
-              </a:rPr>
-              <a:t>Air Conditioning · Chapter 1 · Topic 1.1</a:t>
-            </a:r>
-          </a:p>
-        </p:txBody>
-      </p:sp>
-      <p:sp>
-        <p:nvSpPr>
-          <p:cNvPr id="7" name="TextBox 6"/>
-          <p:cNvSpPr txBox="1"/>
-          <p:nvPr/>
-        </p:nvSpPr>
-        <p:spPr>
-          <a:xfrm>
-            <a:off x="11292840" y="6446520"/>
-            <a:ext cx="502920" cy="228600"/>
-          </a:xfrm>
-          <a:prstGeom prst="rect">
-            <a:avLst/>
-          </a:prstGeom>
-          <a:noFill/>
-        </p:spPr>
-        <p:txBody>
-          <a:bodyPr wrap="square">
-            <a:spAutoFit/>
-          </a:bodyPr>
-          <a:lstStyle/>
-          <a:p>
-            <a:pPr algn="r"/>
-            <a:r>
-              <a:rPr sz="900" b="0" i="0">
-                <a:solidFill>
-                  <a:srgbClr val="78828C"/>
-                </a:solidFill>
-                <a:latin typeface="Aptos"/>
-              </a:rPr>
-              <a:t>1</a:t>
-            </a:r>
-          </a:p>
-        </p:txBody>
-      </p:sp>
-      <p:sp>
-        <p:nvSpPr>
-          <p:cNvPr id="8" name="Rounded Rectangle 7"/>
+          <p:cNvPr id="8" name="TextBox 7"/>
+          <p:cNvSpPr txBox="1"/>
+          <p:nvPr/>
+        </p:nvSpPr>
+        <p:spPr>
+          <a:xfrm>
+            <a:off x="640080" y="2578608"/>
+            <a:ext cx="5257800" cy="749808"/>
+          </a:xfrm>
+          <a:prstGeom prst="rect">
+            <a:avLst/>
+          </a:prstGeom>
+          <a:noFill/>
+        </p:spPr>
+        <p:txBody>
+          <a:bodyPr wrap="square">
+            <a:spAutoFit/>
+          </a:bodyPr>
+          <a:lstStyle/>
+          <a:p>
+            <a:r>
+              <a:rPr sz="2000" b="1" i="0">
+                <a:solidFill>
+                  <a:srgbClr val="232D37"/>
+                </a:solidFill>
+                <a:latin typeface="Aptos"/>
+              </a:rPr>
+              <a:t>Air conditioning is not simply cooling. It is the simultaneous control of the indoor environment.</a:t>
+            </a:r>
+          </a:p>
+        </p:txBody>
+      </p:sp>
+      <p:sp>
+        <p:nvSpPr>
+          <p:cNvPr id="9" name="Rounded Rectangle 8"/>
           <p:cNvSpPr/>
           <p:nvPr/>
         </p:nvSpPr>
         <p:spPr>
           <a:xfrm>
-            <a:off x="822960" y="1554480"/>
-            <a:ext cx="10561320" cy="4434840"/>
+            <a:off x="658368" y="3749039"/>
+            <a:ext cx="5074920" cy="658368"/>
+          </a:xfrm>
+          <a:prstGeom prst="roundRect">
+            <a:avLst/>
+          </a:prstGeom>
+          <a:solidFill>
+            <a:srgbClr val="E6F4F7"/>
+          </a:solidFill>
+          <a:ln w="12700">
+            <a:solidFill>
+              <a:srgbClr val="B9D9E0"/>
+            </a:solidFill>
+          </a:ln>
+        </p:spPr>
+        <p:style>
+          <a:lnRef idx="1">
+            <a:schemeClr val="accent1"/>
+          </a:lnRef>
+          <a:fillRef idx="3">
+            <a:schemeClr val="accent1"/>
+          </a:fillRef>
+          <a:effectRef idx="2">
+            <a:schemeClr val="accent1"/>
+          </a:effectRef>
+          <a:fontRef idx="minor">
+            <a:schemeClr val="lt1"/>
+          </a:fontRef>
+        </p:style>
+        <p:txBody>
+          <a:bodyPr rtlCol="0" anchor="ctr"/>
+          <a:lstStyle/>
+          <a:p>
+            <a:pPr algn="ctr"/>
+          </a:p>
+        </p:txBody>
+      </p:sp>
+      <p:sp>
+        <p:nvSpPr>
+          <p:cNvPr id="10" name="TextBox 9"/>
+          <p:cNvSpPr txBox="1"/>
+          <p:nvPr/>
+        </p:nvSpPr>
+        <p:spPr>
+          <a:xfrm>
+            <a:off x="914400" y="3931920"/>
+            <a:ext cx="4572000" cy="228600"/>
+          </a:xfrm>
+          <a:prstGeom prst="rect">
+            <a:avLst/>
+          </a:prstGeom>
+          <a:noFill/>
+        </p:spPr>
+        <p:txBody>
+          <a:bodyPr wrap="square">
+            <a:spAutoFit/>
+          </a:bodyPr>
+          <a:lstStyle/>
+          <a:p>
+            <a:pPr algn="ctr"/>
+            <a:r>
+              <a:rPr sz="1400" b="1" i="0">
+                <a:solidFill>
+                  <a:srgbClr val="11374B"/>
+                </a:solidFill>
+                <a:latin typeface="Aptos"/>
+              </a:rPr>
+              <a:t>Teaching focus: cooling-mode AC for Thailand</a:t>
+            </a:r>
+          </a:p>
+        </p:txBody>
+      </p:sp>
+      <p:sp>
+        <p:nvSpPr>
+          <p:cNvPr id="11" name="Rounded Rectangle 10"/>
+          <p:cNvSpPr/>
+          <p:nvPr/>
+        </p:nvSpPr>
+        <p:spPr>
+          <a:xfrm>
+            <a:off x="6400800" y="1051560"/>
+            <a:ext cx="4983480" cy="4434840"/>
           </a:xfrm>
           <a:prstGeom prst="roundRect">
             <a:avLst/>
@@ -3372,24 +3502,24 @@
       </p:sp>
       <p:sp>
         <p:nvSpPr>
-          <p:cNvPr id="9" name="Rounded Rectangle 8"/>
+          <p:cNvPr id="12" name="Rounded Rectangle 11"/>
           <p:cNvSpPr/>
           <p:nvPr/>
         </p:nvSpPr>
         <p:spPr>
           <a:xfrm>
-            <a:off x="3886200" y="2148840"/>
-            <a:ext cx="4389120" cy="2103120"/>
+            <a:off x="7178040" y="2057400"/>
+            <a:ext cx="3429000" cy="2057400"/>
           </a:xfrm>
           <a:prstGeom prst="roundRect">
             <a:avLst/>
           </a:prstGeom>
           <a:solidFill>
-            <a:srgbClr val="E6F4F7"/>
+            <a:srgbClr val="ECF7F9"/>
           </a:solidFill>
           <a:ln w="12700">
             <a:solidFill>
-              <a:srgbClr val="B4D2DC"/>
+              <a:srgbClr val="B2D2DB"/>
             </a:solidFill>
           </a:ln>
         </p:spPr>
@@ -3417,29 +3547,29 @@
       </p:sp>
       <p:sp>
         <p:nvSpPr>
-          <p:cNvPr id="10" name="TextBox 9"/>
-          <p:cNvSpPr txBox="1"/>
-          <p:nvPr/>
-        </p:nvSpPr>
-        <p:spPr>
-          <a:xfrm>
-            <a:off x="4343400" y="2788920"/>
-            <a:ext cx="3474720" cy="320040"/>
-          </a:xfrm>
-          <a:prstGeom prst="rect">
-            <a:avLst/>
-          </a:prstGeom>
-          <a:noFill/>
-        </p:spPr>
-        <p:txBody>
-          <a:bodyPr wrap="square">
-            <a:spAutoFit/>
-          </a:bodyPr>
-          <a:lstStyle/>
-          <a:p>
-            <a:pPr algn="ctr"/>
-            <a:r>
-              <a:rPr sz="2400" b="1" i="0">
+          <p:cNvPr id="13" name="TextBox 12"/>
+          <p:cNvSpPr txBox="1"/>
+          <p:nvPr/>
+        </p:nvSpPr>
+        <p:spPr>
+          <a:xfrm>
+            <a:off x="7516368" y="2697480"/>
+            <a:ext cx="2743200" cy="320040"/>
+          </a:xfrm>
+          <a:prstGeom prst="rect">
+            <a:avLst/>
+          </a:prstGeom>
+          <a:noFill/>
+        </p:spPr>
+        <p:txBody>
+          <a:bodyPr wrap="square">
+            <a:spAutoFit/>
+          </a:bodyPr>
+          <a:lstStyle/>
+          <a:p>
+            <a:pPr algn="ctr"/>
+            <a:r>
+              <a:rPr sz="2300" b="1" i="0">
                 <a:solidFill>
                   <a:srgbClr val="11374B"/>
                 </a:solidFill>
@@ -3452,14 +3582,345 @@
       </p:sp>
       <p:sp>
         <p:nvSpPr>
-          <p:cNvPr id="11" name="Oval 10"/>
+          <p:cNvPr id="14" name="TextBox 13"/>
+          <p:cNvSpPr txBox="1"/>
+          <p:nvPr/>
+        </p:nvSpPr>
+        <p:spPr>
+          <a:xfrm>
+            <a:off x="7616952" y="3145536"/>
+            <a:ext cx="2514600" cy="274320"/>
+          </a:xfrm>
+          <a:prstGeom prst="rect">
+            <a:avLst/>
+          </a:prstGeom>
+          <a:noFill/>
+        </p:spPr>
+        <p:txBody>
+          <a:bodyPr wrap="square">
+            <a:spAutoFit/>
+          </a:bodyPr>
+          <a:lstStyle/>
+          <a:p>
+            <a:pPr algn="ctr"/>
+            <a:r>
+              <a:rPr sz="1200" b="0" i="0">
+                <a:solidFill>
+                  <a:srgbClr val="5A6973"/>
+                </a:solidFill>
+                <a:latin typeface="Aptos"/>
+              </a:rPr>
+              <a:t>controlled indoor air</a:t>
+            </a:r>
+          </a:p>
+        </p:txBody>
+      </p:sp>
+      <p:cxnSp>
+        <p:nvCxnSpPr>
+          <p:cNvPr id="15" name="Connector 14"/>
+          <p:cNvCxnSpPr/>
+          <p:nvPr/>
+        </p:nvCxnSpPr>
+        <p:spPr>
+          <a:xfrm>
+            <a:off x="6812280" y="1828800"/>
+            <a:ext cx="4160520" cy="0"/>
+          </a:xfrm>
+          <a:prstGeom prst="line">
+            <a:avLst/>
+          </a:prstGeom>
+          <a:ln w="22860">
+            <a:solidFill>
+              <a:srgbClr val="2A9D8F"/>
+            </a:solidFill>
+          </a:ln>
+        </p:spPr>
+        <p:style>
+          <a:lnRef idx="2">
+            <a:schemeClr val="accent1"/>
+          </a:lnRef>
+          <a:fillRef idx="0">
+            <a:schemeClr val="accent1"/>
+          </a:fillRef>
+          <a:effectRef idx="1">
+            <a:schemeClr val="accent1"/>
+          </a:effectRef>
+          <a:fontRef idx="minor">
+            <a:schemeClr val="tx1"/>
+          </a:fontRef>
+        </p:style>
+      </p:cxnSp>
+      <p:cxnSp>
+        <p:nvCxnSpPr>
+          <p:cNvPr id="16" name="Connector 15"/>
+          <p:cNvCxnSpPr/>
+          <p:nvPr/>
+        </p:nvCxnSpPr>
+        <p:spPr>
+          <a:xfrm>
+            <a:off x="6812280" y="2148840"/>
+            <a:ext cx="4160520" cy="0"/>
+          </a:xfrm>
+          <a:prstGeom prst="line">
+            <a:avLst/>
+          </a:prstGeom>
+          <a:ln w="22860">
+            <a:solidFill>
+              <a:srgbClr val="2A9D8F"/>
+            </a:solidFill>
+          </a:ln>
+        </p:spPr>
+        <p:style>
+          <a:lnRef idx="2">
+            <a:schemeClr val="accent1"/>
+          </a:lnRef>
+          <a:fillRef idx="0">
+            <a:schemeClr val="accent1"/>
+          </a:fillRef>
+          <a:effectRef idx="1">
+            <a:schemeClr val="accent1"/>
+          </a:effectRef>
+          <a:fontRef idx="minor">
+            <a:schemeClr val="tx1"/>
+          </a:fontRef>
+        </p:style>
+      </p:cxnSp>
+      <p:cxnSp>
+        <p:nvCxnSpPr>
+          <p:cNvPr id="17" name="Connector 16"/>
+          <p:cNvCxnSpPr/>
+          <p:nvPr/>
+        </p:nvCxnSpPr>
+        <p:spPr>
+          <a:xfrm>
+            <a:off x="6812280" y="4389120"/>
+            <a:ext cx="4160520" cy="0"/>
+          </a:xfrm>
+          <a:prstGeom prst="line">
+            <a:avLst/>
+          </a:prstGeom>
+          <a:ln w="22860">
+            <a:solidFill>
+              <a:srgbClr val="2A9D8F"/>
+            </a:solidFill>
+          </a:ln>
+        </p:spPr>
+        <p:style>
+          <a:lnRef idx="2">
+            <a:schemeClr val="accent1"/>
+          </a:lnRef>
+          <a:fillRef idx="0">
+            <a:schemeClr val="accent1"/>
+          </a:fillRef>
+          <a:effectRef idx="1">
+            <a:schemeClr val="accent1"/>
+          </a:effectRef>
+          <a:fontRef idx="minor">
+            <a:schemeClr val="tx1"/>
+          </a:fontRef>
+        </p:style>
+      </p:cxnSp>
+      <p:cxnSp>
+        <p:nvCxnSpPr>
+          <p:cNvPr id="18" name="Connector 17"/>
+          <p:cNvCxnSpPr/>
+          <p:nvPr/>
+        </p:nvCxnSpPr>
+        <p:spPr>
+          <a:xfrm>
+            <a:off x="6812280" y="4709160"/>
+            <a:ext cx="4160520" cy="0"/>
+          </a:xfrm>
+          <a:prstGeom prst="line">
+            <a:avLst/>
+          </a:prstGeom>
+          <a:ln w="22860">
+            <a:solidFill>
+              <a:srgbClr val="2A9D8F"/>
+            </a:solidFill>
+          </a:ln>
+        </p:spPr>
+        <p:style>
+          <a:lnRef idx="2">
+            <a:schemeClr val="accent1"/>
+          </a:lnRef>
+          <a:fillRef idx="0">
+            <a:schemeClr val="accent1"/>
+          </a:fillRef>
+          <a:effectRef idx="1">
+            <a:schemeClr val="accent1"/>
+          </a:effectRef>
+          <a:fontRef idx="minor">
+            <a:schemeClr val="tx1"/>
+          </a:fontRef>
+        </p:style>
+      </p:cxnSp>
+      <p:sp>
+        <p:nvSpPr>
+          <p:cNvPr id="19" name="Rectangle 18"/>
           <p:cNvSpPr/>
           <p:nvPr/>
         </p:nvSpPr>
         <p:spPr>
           <a:xfrm>
-            <a:off x="1828800" y="1828800"/>
-            <a:ext cx="914400" cy="914400"/>
+            <a:off x="6656832" y="1828800"/>
+            <a:ext cx="228600" cy="2880360"/>
+          </a:xfrm>
+          <a:prstGeom prst="rect">
+            <a:avLst/>
+          </a:prstGeom>
+          <a:solidFill>
+            <a:srgbClr val="2A9D8F"/>
+          </a:solidFill>
+          <a:ln>
+            <a:noFill/>
+          </a:ln>
+        </p:spPr>
+        <p:style>
+          <a:lnRef idx="1">
+            <a:schemeClr val="accent1"/>
+          </a:lnRef>
+          <a:fillRef idx="3">
+            <a:schemeClr val="accent1"/>
+          </a:fillRef>
+          <a:effectRef idx="2">
+            <a:schemeClr val="accent1"/>
+          </a:effectRef>
+          <a:fontRef idx="minor">
+            <a:schemeClr val="lt1"/>
+          </a:fontRef>
+        </p:style>
+        <p:txBody>
+          <a:bodyPr rtlCol="0" anchor="ctr"/>
+          <a:lstStyle/>
+          <a:p>
+            <a:pPr algn="ctr"/>
+          </a:p>
+        </p:txBody>
+      </p:sp>
+      <p:sp>
+        <p:nvSpPr>
+          <p:cNvPr id="20" name="Rectangle 19"/>
+          <p:cNvSpPr/>
+          <p:nvPr/>
+        </p:nvSpPr>
+        <p:spPr>
+          <a:xfrm>
+            <a:off x="10917936" y="1828800"/>
+            <a:ext cx="228600" cy="2880360"/>
+          </a:xfrm>
+          <a:prstGeom prst="rect">
+            <a:avLst/>
+          </a:prstGeom>
+          <a:solidFill>
+            <a:srgbClr val="457B9D"/>
+          </a:solidFill>
+          <a:ln>
+            <a:noFill/>
+          </a:ln>
+        </p:spPr>
+        <p:style>
+          <a:lnRef idx="1">
+            <a:schemeClr val="accent1"/>
+          </a:lnRef>
+          <a:fillRef idx="3">
+            <a:schemeClr val="accent1"/>
+          </a:fillRef>
+          <a:effectRef idx="2">
+            <a:schemeClr val="accent1"/>
+          </a:effectRef>
+          <a:fontRef idx="minor">
+            <a:schemeClr val="lt1"/>
+          </a:fontRef>
+        </p:style>
+        <p:txBody>
+          <a:bodyPr rtlCol="0" anchor="ctr"/>
+          <a:lstStyle/>
+          <a:p>
+            <a:pPr algn="ctr"/>
+          </a:p>
+        </p:txBody>
+      </p:sp>
+      <p:sp>
+        <p:nvSpPr>
+          <p:cNvPr id="21" name="TextBox 20"/>
+          <p:cNvSpPr txBox="1"/>
+          <p:nvPr/>
+        </p:nvSpPr>
+        <p:spPr>
+          <a:xfrm>
+            <a:off x="6446520" y="4956048"/>
+            <a:ext cx="685800" cy="201168"/>
+          </a:xfrm>
+          <a:prstGeom prst="rect">
+            <a:avLst/>
+          </a:prstGeom>
+          <a:noFill/>
+        </p:spPr>
+        <p:txBody>
+          <a:bodyPr wrap="square">
+            <a:spAutoFit/>
+          </a:bodyPr>
+          <a:lstStyle/>
+          <a:p>
+            <a:pPr algn="ctr"/>
+            <a:r>
+              <a:rPr sz="800" b="1" i="0">
+                <a:solidFill>
+                  <a:srgbClr val="2A9D8F"/>
+                </a:solidFill>
+                <a:latin typeface="Aptos"/>
+              </a:rPr>
+              <a:t>Supply</a:t>
+            </a:r>
+          </a:p>
+        </p:txBody>
+      </p:sp>
+      <p:sp>
+        <p:nvSpPr>
+          <p:cNvPr id="22" name="TextBox 21"/>
+          <p:cNvSpPr txBox="1"/>
+          <p:nvPr/>
+        </p:nvSpPr>
+        <p:spPr>
+          <a:xfrm>
+            <a:off x="10698480" y="4956048"/>
+            <a:ext cx="685800" cy="201168"/>
+          </a:xfrm>
+          <a:prstGeom prst="rect">
+            <a:avLst/>
+          </a:prstGeom>
+          <a:noFill/>
+        </p:spPr>
+        <p:txBody>
+          <a:bodyPr wrap="square">
+            <a:spAutoFit/>
+          </a:bodyPr>
+          <a:lstStyle/>
+          <a:p>
+            <a:pPr algn="ctr"/>
+            <a:r>
+              <a:rPr sz="800" b="1" i="0">
+                <a:solidFill>
+                  <a:srgbClr val="457B9D"/>
+                </a:solidFill>
+                <a:latin typeface="Aptos"/>
+              </a:rPr>
+              <a:t>Return</a:t>
+            </a:r>
+          </a:p>
+        </p:txBody>
+      </p:sp>
+      <p:sp>
+        <p:nvSpPr>
+          <p:cNvPr id="23" name="Oval 22"/>
+          <p:cNvSpPr/>
+          <p:nvPr/>
+        </p:nvSpPr>
+        <p:spPr>
+          <a:xfrm>
+            <a:off x="5989320" y="1325880"/>
+            <a:ext cx="749808" cy="749808"/>
           </a:xfrm>
           <a:prstGeom prst="ellipse">
             <a:avLst/>
@@ -3495,29 +3956,29 @@
       </p:sp>
       <p:sp>
         <p:nvSpPr>
-          <p:cNvPr id="12" name="TextBox 11"/>
-          <p:cNvSpPr txBox="1"/>
-          <p:nvPr/>
-        </p:nvSpPr>
-        <p:spPr>
-          <a:xfrm>
-            <a:off x="1828800" y="2084832"/>
-            <a:ext cx="914400" cy="228600"/>
-          </a:xfrm>
-          <a:prstGeom prst="rect">
-            <a:avLst/>
-          </a:prstGeom>
-          <a:noFill/>
-        </p:spPr>
-        <p:txBody>
-          <a:bodyPr wrap="square">
-            <a:spAutoFit/>
-          </a:bodyPr>
-          <a:lstStyle/>
-          <a:p>
-            <a:pPr algn="ctr"/>
-            <a:r>
-              <a:rPr sz="1600" b="1" i="0">
+          <p:cNvPr id="24" name="TextBox 23"/>
+          <p:cNvSpPr txBox="1"/>
+          <p:nvPr/>
+        </p:nvSpPr>
+        <p:spPr>
+          <a:xfrm>
+            <a:off x="5989320" y="1536192"/>
+            <a:ext cx="749808" cy="201168"/>
+          </a:xfrm>
+          <a:prstGeom prst="rect">
+            <a:avLst/>
+          </a:prstGeom>
+          <a:noFill/>
+        </p:spPr>
+        <p:txBody>
+          <a:bodyPr wrap="square">
+            <a:spAutoFit/>
+          </a:bodyPr>
+          <a:lstStyle/>
+          <a:p>
+            <a:pPr algn="ctr"/>
+            <a:r>
+              <a:rPr sz="1300" b="1" i="0">
                 <a:solidFill>
                   <a:srgbClr val="FFFFFF"/>
                 </a:solidFill>
@@ -3530,29 +3991,29 @@
       </p:sp>
       <p:sp>
         <p:nvSpPr>
-          <p:cNvPr id="13" name="TextBox 12"/>
-          <p:cNvSpPr txBox="1"/>
-          <p:nvPr/>
-        </p:nvSpPr>
-        <p:spPr>
-          <a:xfrm>
-            <a:off x="1280160" y="2816352"/>
-            <a:ext cx="2011680" cy="228600"/>
-          </a:xfrm>
-          <a:prstGeom prst="rect">
-            <a:avLst/>
-          </a:prstGeom>
-          <a:noFill/>
-        </p:spPr>
-        <p:txBody>
-          <a:bodyPr wrap="square">
-            <a:spAutoFit/>
-          </a:bodyPr>
-          <a:lstStyle/>
-          <a:p>
-            <a:pPr algn="ctr"/>
-            <a:r>
-              <a:rPr sz="1200" b="1" i="0">
+          <p:cNvPr id="25" name="TextBox 24"/>
+          <p:cNvSpPr txBox="1"/>
+          <p:nvPr/>
+        </p:nvSpPr>
+        <p:spPr>
+          <a:xfrm>
+            <a:off x="5605272" y="2130552"/>
+            <a:ext cx="1554480" cy="237744"/>
+          </a:xfrm>
+          <a:prstGeom prst="rect">
+            <a:avLst/>
+          </a:prstGeom>
+          <a:noFill/>
+        </p:spPr>
+        <p:txBody>
+          <a:bodyPr wrap="square">
+            <a:spAutoFit/>
+          </a:bodyPr>
+          <a:lstStyle/>
+          <a:p>
+            <a:pPr algn="ctr"/>
+            <a:r>
+              <a:rPr sz="950" b="1" i="0">
                 <a:solidFill>
                   <a:srgbClr val="E76F51"/>
                 </a:solidFill>
@@ -3565,19 +4026,19 @@
       </p:sp>
       <p:cxnSp>
         <p:nvCxnSpPr>
-          <p:cNvPr id="14" name="Connector 13"/>
+          <p:cNvPr id="26" name="Connector 25"/>
           <p:cNvCxnSpPr/>
           <p:nvPr/>
         </p:nvCxnSpPr>
         <p:spPr>
           <a:xfrm>
-            <a:off x="2286000" y="2286000"/>
-            <a:ext cx="3794760" cy="914400"/>
+            <a:off x="6364224" y="1700784"/>
+            <a:ext cx="2523744" cy="1389888"/>
           </a:xfrm>
           <a:prstGeom prst="line">
             <a:avLst/>
           </a:prstGeom>
-          <a:ln w="25400">
+          <a:ln w="16510">
             <a:solidFill>
               <a:srgbClr val="E76F51"/>
             </a:solidFill>
@@ -3600,14 +4061,14 @@
       </p:cxnSp>
       <p:sp>
         <p:nvSpPr>
-          <p:cNvPr id="15" name="Oval 14"/>
+          <p:cNvPr id="27" name="Oval 26"/>
           <p:cNvSpPr/>
           <p:nvPr/>
         </p:nvSpPr>
         <p:spPr>
           <a:xfrm>
-            <a:off x="9555480" y="1828800"/>
-            <a:ext cx="914400" cy="914400"/>
+            <a:off x="10927080" y="1325880"/>
+            <a:ext cx="749808" cy="749808"/>
           </a:xfrm>
           <a:prstGeom prst="ellipse">
             <a:avLst/>
@@ -3643,29 +4104,29 @@
       </p:sp>
       <p:sp>
         <p:nvSpPr>
-          <p:cNvPr id="16" name="TextBox 15"/>
-          <p:cNvSpPr txBox="1"/>
-          <p:nvPr/>
-        </p:nvSpPr>
-        <p:spPr>
-          <a:xfrm>
-            <a:off x="9555480" y="2084832"/>
-            <a:ext cx="914400" cy="228600"/>
-          </a:xfrm>
-          <a:prstGeom prst="rect">
-            <a:avLst/>
-          </a:prstGeom>
-          <a:noFill/>
-        </p:spPr>
-        <p:txBody>
-          <a:bodyPr wrap="square">
-            <a:spAutoFit/>
-          </a:bodyPr>
-          <a:lstStyle/>
-          <a:p>
-            <a:pPr algn="ctr"/>
-            <a:r>
-              <a:rPr sz="1600" b="1" i="0">
+          <p:cNvPr id="28" name="TextBox 27"/>
+          <p:cNvSpPr txBox="1"/>
+          <p:nvPr/>
+        </p:nvSpPr>
+        <p:spPr>
+          <a:xfrm>
+            <a:off x="10927080" y="1536192"/>
+            <a:ext cx="749808" cy="201168"/>
+          </a:xfrm>
+          <a:prstGeom prst="rect">
+            <a:avLst/>
+          </a:prstGeom>
+          <a:noFill/>
+        </p:spPr>
+        <p:txBody>
+          <a:bodyPr wrap="square">
+            <a:spAutoFit/>
+          </a:bodyPr>
+          <a:lstStyle/>
+          <a:p>
+            <a:pPr algn="ctr"/>
+            <a:r>
+              <a:rPr sz="1300" b="1" i="0">
                 <a:solidFill>
                   <a:srgbClr val="FFFFFF"/>
                 </a:solidFill>
@@ -3678,29 +4139,29 @@
       </p:sp>
       <p:sp>
         <p:nvSpPr>
-          <p:cNvPr id="17" name="TextBox 16"/>
-          <p:cNvSpPr txBox="1"/>
-          <p:nvPr/>
-        </p:nvSpPr>
-        <p:spPr>
-          <a:xfrm>
-            <a:off x="9006840" y="2816352"/>
-            <a:ext cx="2011680" cy="228600"/>
-          </a:xfrm>
-          <a:prstGeom prst="rect">
-            <a:avLst/>
-          </a:prstGeom>
-          <a:noFill/>
-        </p:spPr>
-        <p:txBody>
-          <a:bodyPr wrap="square">
-            <a:spAutoFit/>
-          </a:bodyPr>
-          <a:lstStyle/>
-          <a:p>
-            <a:pPr algn="ctr"/>
-            <a:r>
-              <a:rPr sz="1200" b="1" i="0">
+          <p:cNvPr id="29" name="TextBox 28"/>
+          <p:cNvSpPr txBox="1"/>
+          <p:nvPr/>
+        </p:nvSpPr>
+        <p:spPr>
+          <a:xfrm>
+            <a:off x="10543032" y="2130552"/>
+            <a:ext cx="1554480" cy="237744"/>
+          </a:xfrm>
+          <a:prstGeom prst="rect">
+            <a:avLst/>
+          </a:prstGeom>
+          <a:noFill/>
+        </p:spPr>
+        <p:txBody>
+          <a:bodyPr wrap="square">
+            <a:spAutoFit/>
+          </a:bodyPr>
+          <a:lstStyle/>
+          <a:p>
+            <a:pPr algn="ctr"/>
+            <a:r>
+              <a:rPr sz="950" b="1" i="0">
                 <a:solidFill>
                   <a:srgbClr val="457B9D"/>
                 </a:solidFill>
@@ -3713,19 +4174,19 @@
       </p:sp>
       <p:cxnSp>
         <p:nvCxnSpPr>
-          <p:cNvPr id="18" name="Connector 17"/>
+          <p:cNvPr id="30" name="Connector 29"/>
           <p:cNvCxnSpPr/>
           <p:nvPr/>
         </p:nvCxnSpPr>
         <p:spPr>
           <a:xfrm flipH="1">
-            <a:off x="6080760" y="2286000"/>
-            <a:ext cx="3931920" cy="914400"/>
+            <a:off x="8887968" y="1700784"/>
+            <a:ext cx="2414016" cy="1389888"/>
           </a:xfrm>
           <a:prstGeom prst="line">
             <a:avLst/>
           </a:prstGeom>
-          <a:ln w="25400">
+          <a:ln w="16510">
             <a:solidFill>
               <a:srgbClr val="457B9D"/>
             </a:solidFill>
@@ -3748,14 +4209,14 @@
       </p:cxnSp>
       <p:sp>
         <p:nvSpPr>
-          <p:cNvPr id="19" name="Oval 18"/>
+          <p:cNvPr id="31" name="Oval 30"/>
           <p:cNvSpPr/>
           <p:nvPr/>
         </p:nvSpPr>
         <p:spPr>
           <a:xfrm>
-            <a:off x="1828800" y="4709160"/>
-            <a:ext cx="914400" cy="914400"/>
+            <a:off x="5989320" y="4709160"/>
+            <a:ext cx="749808" cy="749808"/>
           </a:xfrm>
           <a:prstGeom prst="ellipse">
             <a:avLst/>
@@ -3791,29 +4252,29 @@
       </p:sp>
       <p:sp>
         <p:nvSpPr>
-          <p:cNvPr id="20" name="TextBox 19"/>
-          <p:cNvSpPr txBox="1"/>
-          <p:nvPr/>
-        </p:nvSpPr>
-        <p:spPr>
-          <a:xfrm>
-            <a:off x="1828800" y="4965192"/>
-            <a:ext cx="914400" cy="228600"/>
-          </a:xfrm>
-          <a:prstGeom prst="rect">
-            <a:avLst/>
-          </a:prstGeom>
-          <a:noFill/>
-        </p:spPr>
-        <p:txBody>
-          <a:bodyPr wrap="square">
-            <a:spAutoFit/>
-          </a:bodyPr>
-          <a:lstStyle/>
-          <a:p>
-            <a:pPr algn="ctr"/>
-            <a:r>
-              <a:rPr sz="1600" b="1" i="0">
+          <p:cNvPr id="32" name="TextBox 31"/>
+          <p:cNvSpPr txBox="1"/>
+          <p:nvPr/>
+        </p:nvSpPr>
+        <p:spPr>
+          <a:xfrm>
+            <a:off x="5989320" y="4919472"/>
+            <a:ext cx="749808" cy="201168"/>
+          </a:xfrm>
+          <a:prstGeom prst="rect">
+            <a:avLst/>
+          </a:prstGeom>
+          <a:noFill/>
+        </p:spPr>
+        <p:txBody>
+          <a:bodyPr wrap="square">
+            <a:spAutoFit/>
+          </a:bodyPr>
+          <a:lstStyle/>
+          <a:p>
+            <a:pPr algn="ctr"/>
+            <a:r>
+              <a:rPr sz="1300" b="1" i="0">
                 <a:solidFill>
                   <a:srgbClr val="FFFFFF"/>
                 </a:solidFill>
@@ -3826,29 +4287,29 @@
       </p:sp>
       <p:sp>
         <p:nvSpPr>
-          <p:cNvPr id="21" name="TextBox 20"/>
-          <p:cNvSpPr txBox="1"/>
-          <p:nvPr/>
-        </p:nvSpPr>
-        <p:spPr>
-          <a:xfrm>
-            <a:off x="1280160" y="5696712"/>
-            <a:ext cx="2011680" cy="228600"/>
-          </a:xfrm>
-          <a:prstGeom prst="rect">
-            <a:avLst/>
-          </a:prstGeom>
-          <a:noFill/>
-        </p:spPr>
-        <p:txBody>
-          <a:bodyPr wrap="square">
-            <a:spAutoFit/>
-          </a:bodyPr>
-          <a:lstStyle/>
-          <a:p>
-            <a:pPr algn="ctr"/>
-            <a:r>
-              <a:rPr sz="1200" b="1" i="0">
+          <p:cNvPr id="33" name="TextBox 32"/>
+          <p:cNvSpPr txBox="1"/>
+          <p:nvPr/>
+        </p:nvSpPr>
+        <p:spPr>
+          <a:xfrm>
+            <a:off x="5605272" y="5513832"/>
+            <a:ext cx="1554480" cy="237744"/>
+          </a:xfrm>
+          <a:prstGeom prst="rect">
+            <a:avLst/>
+          </a:prstGeom>
+          <a:noFill/>
+        </p:spPr>
+        <p:txBody>
+          <a:bodyPr wrap="square">
+            <a:spAutoFit/>
+          </a:bodyPr>
+          <a:lstStyle/>
+          <a:p>
+            <a:pPr algn="ctr"/>
+            <a:r>
+              <a:rPr sz="950" b="1" i="0">
                 <a:solidFill>
                   <a:srgbClr val="2A9D8F"/>
                 </a:solidFill>
@@ -3861,19 +4322,19 @@
       </p:sp>
       <p:cxnSp>
         <p:nvCxnSpPr>
-          <p:cNvPr id="22" name="Connector 21"/>
+          <p:cNvPr id="34" name="Connector 33"/>
           <p:cNvCxnSpPr/>
           <p:nvPr/>
         </p:nvCxnSpPr>
         <p:spPr>
           <a:xfrm flipV="1">
-            <a:off x="2286000" y="3200400"/>
-            <a:ext cx="3794760" cy="1965960"/>
+            <a:off x="6364224" y="3090672"/>
+            <a:ext cx="2523744" cy="1993392"/>
           </a:xfrm>
           <a:prstGeom prst="line">
             <a:avLst/>
           </a:prstGeom>
-          <a:ln w="25400">
+          <a:ln w="16510">
             <a:solidFill>
               <a:srgbClr val="2A9D8F"/>
             </a:solidFill>
@@ -3896,14 +4357,14 @@
       </p:cxnSp>
       <p:sp>
         <p:nvSpPr>
-          <p:cNvPr id="23" name="Oval 22"/>
+          <p:cNvPr id="35" name="Oval 34"/>
           <p:cNvSpPr/>
           <p:nvPr/>
         </p:nvSpPr>
         <p:spPr>
           <a:xfrm>
-            <a:off x="9555480" y="4709160"/>
-            <a:ext cx="914400" cy="914400"/>
+            <a:off x="10927080" y="4709160"/>
+            <a:ext cx="749808" cy="749808"/>
           </a:xfrm>
           <a:prstGeom prst="ellipse">
             <a:avLst/>
@@ -3939,29 +4400,29 @@
       </p:sp>
       <p:sp>
         <p:nvSpPr>
-          <p:cNvPr id="24" name="TextBox 23"/>
-          <p:cNvSpPr txBox="1"/>
-          <p:nvPr/>
-        </p:nvSpPr>
-        <p:spPr>
-          <a:xfrm>
-            <a:off x="9555480" y="4965192"/>
-            <a:ext cx="914400" cy="228600"/>
-          </a:xfrm>
-          <a:prstGeom prst="rect">
-            <a:avLst/>
-          </a:prstGeom>
-          <a:noFill/>
-        </p:spPr>
-        <p:txBody>
-          <a:bodyPr wrap="square">
-            <a:spAutoFit/>
-          </a:bodyPr>
-          <a:lstStyle/>
-          <a:p>
-            <a:pPr algn="ctr"/>
-            <a:r>
-              <a:rPr sz="1600" b="1" i="0">
+          <p:cNvPr id="36" name="TextBox 35"/>
+          <p:cNvSpPr txBox="1"/>
+          <p:nvPr/>
+        </p:nvSpPr>
+        <p:spPr>
+          <a:xfrm>
+            <a:off x="10927080" y="4919472"/>
+            <a:ext cx="749808" cy="201168"/>
+          </a:xfrm>
+          <a:prstGeom prst="rect">
+            <a:avLst/>
+          </a:prstGeom>
+          <a:noFill/>
+        </p:spPr>
+        <p:txBody>
+          <a:bodyPr wrap="square">
+            <a:spAutoFit/>
+          </a:bodyPr>
+          <a:lstStyle/>
+          <a:p>
+            <a:pPr algn="ctr"/>
+            <a:r>
+              <a:rPr sz="1300" b="1" i="0">
                 <a:solidFill>
                   <a:srgbClr val="FFFFFF"/>
                 </a:solidFill>
@@ -3974,29 +4435,29 @@
       </p:sp>
       <p:sp>
         <p:nvSpPr>
-          <p:cNvPr id="25" name="TextBox 24"/>
-          <p:cNvSpPr txBox="1"/>
-          <p:nvPr/>
-        </p:nvSpPr>
-        <p:spPr>
-          <a:xfrm>
-            <a:off x="9006840" y="5696712"/>
-            <a:ext cx="2011680" cy="228600"/>
-          </a:xfrm>
-          <a:prstGeom prst="rect">
-            <a:avLst/>
-          </a:prstGeom>
-          <a:noFill/>
-        </p:spPr>
-        <p:txBody>
-          <a:bodyPr wrap="square">
-            <a:spAutoFit/>
-          </a:bodyPr>
-          <a:lstStyle/>
-          <a:p>
-            <a:pPr algn="ctr"/>
-            <a:r>
-              <a:rPr sz="1200" b="1" i="0">
+          <p:cNvPr id="37" name="TextBox 36"/>
+          <p:cNvSpPr txBox="1"/>
+          <p:nvPr/>
+        </p:nvSpPr>
+        <p:spPr>
+          <a:xfrm>
+            <a:off x="10543032" y="5513832"/>
+            <a:ext cx="1554480" cy="237744"/>
+          </a:xfrm>
+          <a:prstGeom prst="rect">
+            <a:avLst/>
+          </a:prstGeom>
+          <a:noFill/>
+        </p:spPr>
+        <p:txBody>
+          <a:bodyPr wrap="square">
+            <a:spAutoFit/>
+          </a:bodyPr>
+          <a:lstStyle/>
+          <a:p>
+            <a:pPr algn="ctr"/>
+            <a:r>
+              <a:rPr sz="950" b="1" i="0">
                 <a:solidFill>
                   <a:srgbClr val="4CAF50"/>
                 </a:solidFill>
@@ -4009,19 +4470,19 @@
       </p:sp>
       <p:cxnSp>
         <p:nvCxnSpPr>
-          <p:cNvPr id="26" name="Connector 25"/>
+          <p:cNvPr id="38" name="Connector 37"/>
           <p:cNvCxnSpPr/>
           <p:nvPr/>
         </p:nvCxnSpPr>
         <p:spPr>
           <a:xfrm flipH="1" flipV="1">
-            <a:off x="6080760" y="3200400"/>
-            <a:ext cx="3931920" cy="1965960"/>
+            <a:off x="8887968" y="3090672"/>
+            <a:ext cx="2414016" cy="1993392"/>
           </a:xfrm>
           <a:prstGeom prst="line">
             <a:avLst/>
           </a:prstGeom>
-          <a:ln w="25400">
+          <a:ln w="16510">
             <a:solidFill>
               <a:srgbClr val="4CAF50"/>
             </a:solidFill>
@@ -4042,6 +4503,513 @@
           </a:fontRef>
         </p:style>
       </p:cxnSp>
+      <p:sp>
+        <p:nvSpPr>
+          <p:cNvPr id="39" name="Oval 38"/>
+          <p:cNvSpPr/>
+          <p:nvPr/>
+        </p:nvSpPr>
+        <p:spPr>
+          <a:xfrm>
+            <a:off x="685800" y="5074920"/>
+            <a:ext cx="384048" cy="384048"/>
+          </a:xfrm>
+          <a:prstGeom prst="ellipse">
+            <a:avLst/>
+          </a:prstGeom>
+          <a:solidFill>
+            <a:srgbClr val="2A9D8F"/>
+          </a:solidFill>
+          <a:ln>
+            <a:noFill/>
+          </a:ln>
+        </p:spPr>
+        <p:style>
+          <a:lnRef idx="1">
+            <a:schemeClr val="accent1"/>
+          </a:lnRef>
+          <a:fillRef idx="3">
+            <a:schemeClr val="accent1"/>
+          </a:fillRef>
+          <a:effectRef idx="2">
+            <a:schemeClr val="accent1"/>
+          </a:effectRef>
+          <a:fontRef idx="minor">
+            <a:schemeClr val="lt1"/>
+          </a:fontRef>
+        </p:style>
+        <p:txBody>
+          <a:bodyPr rtlCol="0" anchor="ctr"/>
+          <a:lstStyle/>
+          <a:p>
+            <a:pPr algn="ctr"/>
+          </a:p>
+        </p:txBody>
+      </p:sp>
+      <p:sp>
+        <p:nvSpPr>
+          <p:cNvPr id="40" name="TextBox 39"/>
+          <p:cNvSpPr txBox="1"/>
+          <p:nvPr/>
+        </p:nvSpPr>
+        <p:spPr>
+          <a:xfrm>
+            <a:off x="685800" y="5184648"/>
+            <a:ext cx="384048" cy="100584"/>
+          </a:xfrm>
+          <a:prstGeom prst="rect">
+            <a:avLst/>
+          </a:prstGeom>
+          <a:noFill/>
+        </p:spPr>
+        <p:txBody>
+          <a:bodyPr wrap="square">
+            <a:spAutoFit/>
+          </a:bodyPr>
+          <a:lstStyle/>
+          <a:p>
+            <a:pPr algn="ctr"/>
+            <a:r>
+              <a:rPr sz="800" b="1" i="0">
+                <a:solidFill>
+                  <a:srgbClr val="FFFFFF"/>
+                </a:solidFill>
+                <a:latin typeface="Aptos"/>
+              </a:rPr>
+              <a:t>1</a:t>
+            </a:r>
+          </a:p>
+        </p:txBody>
+      </p:sp>
+      <p:sp>
+        <p:nvSpPr>
+          <p:cNvPr id="41" name="TextBox 40"/>
+          <p:cNvSpPr txBox="1"/>
+          <p:nvPr/>
+        </p:nvSpPr>
+        <p:spPr>
+          <a:xfrm>
+            <a:off x="1161288" y="5001768"/>
+            <a:ext cx="1097280" cy="219456"/>
+          </a:xfrm>
+          <a:prstGeom prst="rect">
+            <a:avLst/>
+          </a:prstGeom>
+          <a:noFill/>
+        </p:spPr>
+        <p:txBody>
+          <a:bodyPr wrap="square">
+            <a:spAutoFit/>
+          </a:bodyPr>
+          <a:lstStyle/>
+          <a:p>
+            <a:r>
+              <a:rPr sz="1100" b="1" i="0">
+                <a:solidFill>
+                  <a:srgbClr val="232D37"/>
+                </a:solidFill>
+                <a:latin typeface="Aptos"/>
+              </a:rPr>
+              <a:t>Comfort</a:t>
+            </a:r>
+          </a:p>
+        </p:txBody>
+      </p:sp>
+      <p:sp>
+        <p:nvSpPr>
+          <p:cNvPr id="42" name="TextBox 41"/>
+          <p:cNvSpPr txBox="1"/>
+          <p:nvPr/>
+        </p:nvSpPr>
+        <p:spPr>
+          <a:xfrm>
+            <a:off x="1161288" y="5276088"/>
+            <a:ext cx="1188720" cy="219456"/>
+          </a:xfrm>
+          <a:prstGeom prst="rect">
+            <a:avLst/>
+          </a:prstGeom>
+          <a:noFill/>
+        </p:spPr>
+        <p:txBody>
+          <a:bodyPr wrap="square">
+            <a:spAutoFit/>
+          </a:bodyPr>
+          <a:lstStyle/>
+          <a:p>
+            <a:r>
+              <a:rPr sz="750" b="0" i="0">
+                <a:solidFill>
+                  <a:srgbClr val="5A6973"/>
+                </a:solidFill>
+                <a:latin typeface="Aptos"/>
+              </a:rPr>
+              <a:t>human thermal comfort</a:t>
+            </a:r>
+          </a:p>
+        </p:txBody>
+      </p:sp>
+      <p:sp>
+        <p:nvSpPr>
+          <p:cNvPr id="43" name="Oval 42"/>
+          <p:cNvSpPr/>
+          <p:nvPr/>
+        </p:nvSpPr>
+        <p:spPr>
+          <a:xfrm>
+            <a:off x="2377440" y="5074920"/>
+            <a:ext cx="384048" cy="384048"/>
+          </a:xfrm>
+          <a:prstGeom prst="ellipse">
+            <a:avLst/>
+          </a:prstGeom>
+          <a:solidFill>
+            <a:srgbClr val="457B9D"/>
+          </a:solidFill>
+          <a:ln>
+            <a:noFill/>
+          </a:ln>
+        </p:spPr>
+        <p:style>
+          <a:lnRef idx="1">
+            <a:schemeClr val="accent1"/>
+          </a:lnRef>
+          <a:fillRef idx="3">
+            <a:schemeClr val="accent1"/>
+          </a:fillRef>
+          <a:effectRef idx="2">
+            <a:schemeClr val="accent1"/>
+          </a:effectRef>
+          <a:fontRef idx="minor">
+            <a:schemeClr val="lt1"/>
+          </a:fontRef>
+        </p:style>
+        <p:txBody>
+          <a:bodyPr rtlCol="0" anchor="ctr"/>
+          <a:lstStyle/>
+          <a:p>
+            <a:pPr algn="ctr"/>
+          </a:p>
+        </p:txBody>
+      </p:sp>
+      <p:sp>
+        <p:nvSpPr>
+          <p:cNvPr id="44" name="TextBox 43"/>
+          <p:cNvSpPr txBox="1"/>
+          <p:nvPr/>
+        </p:nvSpPr>
+        <p:spPr>
+          <a:xfrm>
+            <a:off x="2377440" y="5184648"/>
+            <a:ext cx="384048" cy="100584"/>
+          </a:xfrm>
+          <a:prstGeom prst="rect">
+            <a:avLst/>
+          </a:prstGeom>
+          <a:noFill/>
+        </p:spPr>
+        <p:txBody>
+          <a:bodyPr wrap="square">
+            <a:spAutoFit/>
+          </a:bodyPr>
+          <a:lstStyle/>
+          <a:p>
+            <a:pPr algn="ctr"/>
+            <a:r>
+              <a:rPr sz="800" b="1" i="0">
+                <a:solidFill>
+                  <a:srgbClr val="FFFFFF"/>
+                </a:solidFill>
+                <a:latin typeface="Aptos"/>
+              </a:rPr>
+              <a:t>2</a:t>
+            </a:r>
+          </a:p>
+        </p:txBody>
+      </p:sp>
+      <p:sp>
+        <p:nvSpPr>
+          <p:cNvPr id="45" name="TextBox 44"/>
+          <p:cNvSpPr txBox="1"/>
+          <p:nvPr/>
+        </p:nvSpPr>
+        <p:spPr>
+          <a:xfrm>
+            <a:off x="2852928" y="5001768"/>
+            <a:ext cx="1097280" cy="219456"/>
+          </a:xfrm>
+          <a:prstGeom prst="rect">
+            <a:avLst/>
+          </a:prstGeom>
+          <a:noFill/>
+        </p:spPr>
+        <p:txBody>
+          <a:bodyPr wrap="square">
+            <a:spAutoFit/>
+          </a:bodyPr>
+          <a:lstStyle/>
+          <a:p>
+            <a:r>
+              <a:rPr sz="1100" b="1" i="0">
+                <a:solidFill>
+                  <a:srgbClr val="232D37"/>
+                </a:solidFill>
+                <a:latin typeface="Aptos"/>
+              </a:rPr>
+              <a:t>Process</a:t>
+            </a:r>
+          </a:p>
+        </p:txBody>
+      </p:sp>
+      <p:sp>
+        <p:nvSpPr>
+          <p:cNvPr id="46" name="TextBox 45"/>
+          <p:cNvSpPr txBox="1"/>
+          <p:nvPr/>
+        </p:nvSpPr>
+        <p:spPr>
+          <a:xfrm>
+            <a:off x="2852928" y="5276088"/>
+            <a:ext cx="1188720" cy="219456"/>
+          </a:xfrm>
+          <a:prstGeom prst="rect">
+            <a:avLst/>
+          </a:prstGeom>
+          <a:noFill/>
+        </p:spPr>
+        <p:txBody>
+          <a:bodyPr wrap="square">
+            <a:spAutoFit/>
+          </a:bodyPr>
+          <a:lstStyle/>
+          <a:p>
+            <a:r>
+              <a:rPr sz="750" b="0" i="0">
+                <a:solidFill>
+                  <a:srgbClr val="5A6973"/>
+                </a:solidFill>
+                <a:latin typeface="Aptos"/>
+              </a:rPr>
+              <a:t>material / product need</a:t>
+            </a:r>
+          </a:p>
+        </p:txBody>
+      </p:sp>
+      <p:sp>
+        <p:nvSpPr>
+          <p:cNvPr id="47" name="Oval 46"/>
+          <p:cNvSpPr/>
+          <p:nvPr/>
+        </p:nvSpPr>
+        <p:spPr>
+          <a:xfrm>
+            <a:off x="4069080" y="5074920"/>
+            <a:ext cx="384048" cy="384048"/>
+          </a:xfrm>
+          <a:prstGeom prst="ellipse">
+            <a:avLst/>
+          </a:prstGeom>
+          <a:solidFill>
+            <a:srgbClr val="E76F51"/>
+          </a:solidFill>
+          <a:ln>
+            <a:noFill/>
+          </a:ln>
+        </p:spPr>
+        <p:style>
+          <a:lnRef idx="1">
+            <a:schemeClr val="accent1"/>
+          </a:lnRef>
+          <a:fillRef idx="3">
+            <a:schemeClr val="accent1"/>
+          </a:fillRef>
+          <a:effectRef idx="2">
+            <a:schemeClr val="accent1"/>
+          </a:effectRef>
+          <a:fontRef idx="minor">
+            <a:schemeClr val="lt1"/>
+          </a:fontRef>
+        </p:style>
+        <p:txBody>
+          <a:bodyPr rtlCol="0" anchor="ctr"/>
+          <a:lstStyle/>
+          <a:p>
+            <a:pPr algn="ctr"/>
+          </a:p>
+        </p:txBody>
+      </p:sp>
+      <p:sp>
+        <p:nvSpPr>
+          <p:cNvPr id="48" name="TextBox 47"/>
+          <p:cNvSpPr txBox="1"/>
+          <p:nvPr/>
+        </p:nvSpPr>
+        <p:spPr>
+          <a:xfrm>
+            <a:off x="4069080" y="5184648"/>
+            <a:ext cx="384048" cy="100584"/>
+          </a:xfrm>
+          <a:prstGeom prst="rect">
+            <a:avLst/>
+          </a:prstGeom>
+          <a:noFill/>
+        </p:spPr>
+        <p:txBody>
+          <a:bodyPr wrap="square">
+            <a:spAutoFit/>
+          </a:bodyPr>
+          <a:lstStyle/>
+          <a:p>
+            <a:pPr algn="ctr"/>
+            <a:r>
+              <a:rPr sz="800" b="1" i="0">
+                <a:solidFill>
+                  <a:srgbClr val="FFFFFF"/>
+                </a:solidFill>
+                <a:latin typeface="Aptos"/>
+              </a:rPr>
+              <a:t>3</a:t>
+            </a:r>
+          </a:p>
+        </p:txBody>
+      </p:sp>
+      <p:sp>
+        <p:nvSpPr>
+          <p:cNvPr id="49" name="TextBox 48"/>
+          <p:cNvSpPr txBox="1"/>
+          <p:nvPr/>
+        </p:nvSpPr>
+        <p:spPr>
+          <a:xfrm>
+            <a:off x="4544568" y="5001768"/>
+            <a:ext cx="1097280" cy="219456"/>
+          </a:xfrm>
+          <a:prstGeom prst="rect">
+            <a:avLst/>
+          </a:prstGeom>
+          <a:noFill/>
+        </p:spPr>
+        <p:txBody>
+          <a:bodyPr wrap="square">
+            <a:spAutoFit/>
+          </a:bodyPr>
+          <a:lstStyle/>
+          <a:p>
+            <a:r>
+              <a:rPr sz="1100" b="1" i="0">
+                <a:solidFill>
+                  <a:srgbClr val="232D37"/>
+                </a:solidFill>
+                <a:latin typeface="Aptos"/>
+              </a:rPr>
+              <a:t>Survey</a:t>
+            </a:r>
+          </a:p>
+        </p:txBody>
+      </p:sp>
+      <p:sp>
+        <p:nvSpPr>
+          <p:cNvPr id="50" name="TextBox 49"/>
+          <p:cNvSpPr txBox="1"/>
+          <p:nvPr/>
+        </p:nvSpPr>
+        <p:spPr>
+          <a:xfrm>
+            <a:off x="4544568" y="5276088"/>
+            <a:ext cx="1188720" cy="219456"/>
+          </a:xfrm>
+          <a:prstGeom prst="rect">
+            <a:avLst/>
+          </a:prstGeom>
+          <a:noFill/>
+        </p:spPr>
+        <p:txBody>
+          <a:bodyPr wrap="square">
+            <a:spAutoFit/>
+          </a:bodyPr>
+          <a:lstStyle/>
+          <a:p>
+            <a:r>
+              <a:rPr sz="750" b="0" i="0">
+                <a:solidFill>
+                  <a:srgbClr val="5A6973"/>
+                </a:solidFill>
+                <a:latin typeface="Aptos"/>
+              </a:rPr>
+              <a:t>data before design</a:t>
+            </a:r>
+          </a:p>
+        </p:txBody>
+      </p:sp>
+      <p:sp>
+        <p:nvSpPr>
+          <p:cNvPr id="51" name="TextBox 50"/>
+          <p:cNvSpPr txBox="1"/>
+          <p:nvPr/>
+        </p:nvSpPr>
+        <p:spPr>
+          <a:xfrm>
+            <a:off x="594360" y="6446520"/>
+            <a:ext cx="7315200" cy="201168"/>
+          </a:xfrm>
+          <a:prstGeom prst="rect">
+            <a:avLst/>
+          </a:prstGeom>
+          <a:noFill/>
+        </p:spPr>
+        <p:txBody>
+          <a:bodyPr wrap="square">
+            <a:spAutoFit/>
+          </a:bodyPr>
+          <a:lstStyle/>
+          <a:p>
+            <a:r>
+              <a:rPr sz="900" b="0" i="0">
+                <a:solidFill>
+                  <a:srgbClr val="78828C"/>
+                </a:solidFill>
+                <a:latin typeface="Aptos"/>
+              </a:rPr>
+              <a:t>Air Conditioning · Chapter 1 · Topic 1.1</a:t>
+            </a:r>
+          </a:p>
+        </p:txBody>
+      </p:sp>
+      <p:sp>
+        <p:nvSpPr>
+          <p:cNvPr id="52" name="TextBox 51"/>
+          <p:cNvSpPr txBox="1"/>
+          <p:nvPr/>
+        </p:nvSpPr>
+        <p:spPr>
+          <a:xfrm>
+            <a:off x="11292840" y="6446520"/>
+            <a:ext cx="502920" cy="201168"/>
+          </a:xfrm>
+          <a:prstGeom prst="rect">
+            <a:avLst/>
+          </a:prstGeom>
+          <a:noFill/>
+        </p:spPr>
+        <p:txBody>
+          <a:bodyPr wrap="square">
+            <a:spAutoFit/>
+          </a:bodyPr>
+          <a:lstStyle/>
+          <a:p>
+            <a:pPr algn="r"/>
+            <a:r>
+              <a:rPr sz="900" b="0" i="0">
+                <a:solidFill>
+                  <a:srgbClr val="78828C"/>
+                </a:solidFill>
+                <a:latin typeface="Aptos"/>
+              </a:rPr>
+              <a:t>1</a:t>
+            </a:r>
+          </a:p>
+        </p:txBody>
+      </p:sp>
     </p:spTree>
   </p:cSld>
   <p:clrMapOvr>

</xml_diff>

<commit_message>
Use generated infographic on topic 1.1 cover
</commit_message>
<xml_diff>
--- a/05_Outputs/Air Conditioning/English Slides/Air Con Chapter 1 Topic 1.1 - Visual Lecture Deck CLEAN with TA Figures.pptx
+++ b/05_Outputs/Air Conditioning/English Slides/Air Con Chapter 1 Topic 1.1 - Visual Lecture Deck CLEAN with TA Figures.pptx
@@ -3110,16 +3110,83 @@
         <p:nvPr/>
       </p:nvGrpSpPr>
       <p:grpSpPr/>
-      <p:sp>
-        <p:nvSpPr>
-          <p:cNvPr id="2" name="Rectangle 1"/>
+      <p:pic>
+        <p:nvPicPr>
+          <p:cNvPr id="2" name="Picture 1" descr="conditioned-space-engineering-infographic.png"/>
+          <p:cNvPicPr>
+            <a:picLocks noChangeAspect="1"/>
+          </p:cNvPicPr>
+          <p:nvPr/>
+        </p:nvPicPr>
+        <p:blipFill>
+          <a:blip r:embed="rId2"/>
+          <a:stretch>
+            <a:fillRect/>
+          </a:stretch>
+        </p:blipFill>
+        <p:spPr>
+          <a:xfrm>
+            <a:off x="1107556" y="941832"/>
+            <a:ext cx="9992127" cy="5623560"/>
+          </a:xfrm>
+          <a:prstGeom prst="rect">
+            <a:avLst/>
+          </a:prstGeom>
+        </p:spPr>
+      </p:pic>
+      <p:sp>
+        <p:nvSpPr>
+          <p:cNvPr id="3" name="Rectangle 2"/>
           <p:cNvSpPr/>
           <p:nvPr/>
         </p:nvSpPr>
         <p:spPr>
           <a:xfrm>
             <a:off x="0" y="0"/>
-            <a:ext cx="12191999" cy="182880"/>
+            <a:ext cx="12191999" cy="749808"/>
+          </a:xfrm>
+          <a:prstGeom prst="rect">
+            <a:avLst/>
+          </a:prstGeom>
+          <a:solidFill>
+            <a:srgbClr val="F8FAFC"/>
+          </a:solidFill>
+          <a:ln>
+            <a:noFill/>
+          </a:ln>
+        </p:spPr>
+        <p:style>
+          <a:lnRef idx="1">
+            <a:schemeClr val="accent1"/>
+          </a:lnRef>
+          <a:fillRef idx="3">
+            <a:schemeClr val="accent1"/>
+          </a:fillRef>
+          <a:effectRef idx="2">
+            <a:schemeClr val="accent1"/>
+          </a:effectRef>
+          <a:fontRef idx="minor">
+            <a:schemeClr val="lt1"/>
+          </a:fontRef>
+        </p:style>
+        <p:txBody>
+          <a:bodyPr rtlCol="0" anchor="ctr"/>
+          <a:lstStyle/>
+          <a:p>
+            <a:pPr algn="ctr"/>
+          </a:p>
+        </p:txBody>
+      </p:sp>
+      <p:sp>
+        <p:nvSpPr>
+          <p:cNvPr id="4" name="Rectangle 3"/>
+          <p:cNvSpPr/>
+          <p:nvPr/>
+        </p:nvSpPr>
+        <p:spPr>
+          <a:xfrm>
+            <a:off x="0" y="0"/>
+            <a:ext cx="12191999" cy="164592"/>
           </a:xfrm>
           <a:prstGeom prst="rect">
             <a:avLst/>
@@ -3155,114 +3222,28 @@
       </p:sp>
       <p:sp>
         <p:nvSpPr>
-          <p:cNvPr id="3" name="Right Triangle 2"/>
-          <p:cNvSpPr/>
-          <p:nvPr/>
-        </p:nvSpPr>
-        <p:spPr>
-          <a:xfrm>
-            <a:off x="8778240" y="182880"/>
-            <a:ext cx="3429000" cy="2194560"/>
-          </a:xfrm>
-          <a:prstGeom prst="rtTriangle">
-            <a:avLst/>
-          </a:prstGeom>
-          <a:solidFill>
-            <a:srgbClr val="E7F4F7"/>
-          </a:solidFill>
-          <a:ln>
-            <a:noFill/>
-          </a:ln>
-        </p:spPr>
-        <p:style>
-          <a:lnRef idx="1">
-            <a:schemeClr val="accent1"/>
-          </a:lnRef>
-          <a:fillRef idx="3">
-            <a:schemeClr val="accent1"/>
-          </a:fillRef>
-          <a:effectRef idx="2">
-            <a:schemeClr val="accent1"/>
-          </a:effectRef>
-          <a:fontRef idx="minor">
-            <a:schemeClr val="lt1"/>
-          </a:fontRef>
-        </p:style>
-        <p:txBody>
-          <a:bodyPr rtlCol="0" anchor="ctr"/>
-          <a:lstStyle/>
-          <a:p>
-            <a:pPr algn="ctr"/>
-          </a:p>
-        </p:txBody>
-      </p:sp>
-      <p:sp>
-        <p:nvSpPr>
-          <p:cNvPr id="4" name="Right Triangle 3"/>
-          <p:cNvSpPr/>
-          <p:nvPr/>
-        </p:nvSpPr>
-        <p:spPr>
-          <a:xfrm>
-            <a:off x="9646920" y="4160520"/>
-            <a:ext cx="2560320" cy="2514600"/>
-          </a:xfrm>
-          <a:prstGeom prst="rtTriangle">
-            <a:avLst/>
-          </a:prstGeom>
-          <a:solidFill>
-            <a:srgbClr val="FFEFE6"/>
-          </a:solidFill>
-          <a:ln>
-            <a:noFill/>
-          </a:ln>
-        </p:spPr>
-        <p:style>
-          <a:lnRef idx="1">
-            <a:schemeClr val="accent1"/>
-          </a:lnRef>
-          <a:fillRef idx="3">
-            <a:schemeClr val="accent1"/>
-          </a:fillRef>
-          <a:effectRef idx="2">
-            <a:schemeClr val="accent1"/>
-          </a:effectRef>
-          <a:fontRef idx="minor">
-            <a:schemeClr val="lt1"/>
-          </a:fontRef>
-        </p:style>
-        <p:txBody>
-          <a:bodyPr rtlCol="0" anchor="ctr"/>
-          <a:lstStyle/>
-          <a:p>
-            <a:pPr algn="ctr"/>
-          </a:p>
-        </p:txBody>
-      </p:sp>
-      <p:sp>
-        <p:nvSpPr>
           <p:cNvPr id="5" name="TextBox 4"/>
           <p:cNvSpPr txBox="1"/>
           <p:nvPr/>
         </p:nvSpPr>
         <p:spPr>
           <a:xfrm>
-            <a:off x="621792" y="749808"/>
-            <a:ext cx="5394960" cy="320040"/>
-          </a:xfrm>
-          <a:prstGeom prst="rect">
-            <a:avLst/>
-          </a:prstGeom>
-          <a:noFill/>
-        </p:spPr>
-        <p:txBody>
-          <a:bodyPr wrap="square">
-            <a:spAutoFit/>
-          </a:bodyPr>
-          <a:lstStyle/>
-          <a:p>
-            <a:r>
-              <a:rPr sz="1300" b="1" i="0">
+            <a:off x="502920" y="256032"/>
+            <a:ext cx="5394960" cy="274320"/>
+          </a:xfrm>
+          <a:prstGeom prst="rect">
+            <a:avLst/>
+          </a:prstGeom>
+          <a:noFill/>
+        </p:spPr>
+        <p:txBody>
+          <a:bodyPr wrap="square">
+            <a:spAutoFit/>
+          </a:bodyPr>
+          <a:lstStyle/>
+          <a:p>
+            <a:r>
+              <a:rPr sz="1050" b="1">
                 <a:solidFill>
                   <a:srgbClr val="2A9D8F"/>
                 </a:solidFill>
@@ -3281,22 +3262,22 @@
         </p:nvSpPr>
         <p:spPr>
           <a:xfrm>
-            <a:off x="594360" y="1170432"/>
-            <a:ext cx="5760720" cy="868680"/>
-          </a:xfrm>
-          <a:prstGeom prst="rect">
-            <a:avLst/>
-          </a:prstGeom>
-          <a:noFill/>
-        </p:spPr>
-        <p:txBody>
-          <a:bodyPr wrap="square">
-            <a:spAutoFit/>
-          </a:bodyPr>
-          <a:lstStyle/>
-          <a:p>
-            <a:r>
-              <a:rPr sz="3700" b="1" i="0">
+            <a:off x="502920" y="438912"/>
+            <a:ext cx="6035040" cy="320040"/>
+          </a:xfrm>
+          <a:prstGeom prst="rect">
+            <a:avLst/>
+          </a:prstGeom>
+          <a:noFill/>
+        </p:spPr>
+        <p:txBody>
+          <a:bodyPr wrap="square">
+            <a:spAutoFit/>
+          </a:bodyPr>
+          <a:lstStyle/>
+          <a:p>
+            <a:r>
+              <a:rPr sz="1800" b="1">
                 <a:solidFill>
                   <a:srgbClr val="11374B"/>
                 </a:solidFill>
@@ -3315,22 +3296,23 @@
         </p:nvSpPr>
         <p:spPr>
           <a:xfrm>
-            <a:off x="621792" y="1975104"/>
-            <a:ext cx="5669280" cy="384048"/>
-          </a:xfrm>
-          <a:prstGeom prst="rect">
-            <a:avLst/>
-          </a:prstGeom>
-          <a:noFill/>
-        </p:spPr>
-        <p:txBody>
-          <a:bodyPr wrap="square">
-            <a:spAutoFit/>
-          </a:bodyPr>
-          <a:lstStyle/>
-          <a:p>
-            <a:r>
-              <a:rPr sz="1800" b="0" i="0">
+            <a:off x="6400800" y="438912"/>
+            <a:ext cx="5257800" cy="274320"/>
+          </a:xfrm>
+          <a:prstGeom prst="rect">
+            <a:avLst/>
+          </a:prstGeom>
+          <a:noFill/>
+        </p:spPr>
+        <p:txBody>
+          <a:bodyPr wrap="square">
+            <a:spAutoFit/>
+          </a:bodyPr>
+          <a:lstStyle/>
+          <a:p>
+            <a:pPr algn="r"/>
+            <a:r>
+              <a:rPr sz="1200" b="0">
                 <a:solidFill>
                   <a:srgbClr val="5A6973"/>
                 </a:solidFill>
@@ -3349,1622 +3331,22 @@
         </p:nvSpPr>
         <p:spPr>
           <a:xfrm>
-            <a:off x="640080" y="2578608"/>
-            <a:ext cx="5257800" cy="749808"/>
-          </a:xfrm>
-          <a:prstGeom prst="rect">
-            <a:avLst/>
-          </a:prstGeom>
-          <a:noFill/>
-        </p:spPr>
-        <p:txBody>
-          <a:bodyPr wrap="square">
-            <a:spAutoFit/>
-          </a:bodyPr>
-          <a:lstStyle/>
-          <a:p>
-            <a:r>
-              <a:rPr sz="2000" b="1" i="0">
-                <a:solidFill>
-                  <a:srgbClr val="232D37"/>
-                </a:solidFill>
-                <a:latin typeface="Aptos"/>
-              </a:rPr>
-              <a:t>Air conditioning is not simply cooling. It is the simultaneous control of the indoor environment.</a:t>
-            </a:r>
-          </a:p>
-        </p:txBody>
-      </p:sp>
-      <p:sp>
-        <p:nvSpPr>
-          <p:cNvPr id="9" name="Rounded Rectangle 8"/>
-          <p:cNvSpPr/>
-          <p:nvPr/>
-        </p:nvSpPr>
-        <p:spPr>
-          <a:xfrm>
-            <a:off x="658368" y="3749039"/>
-            <a:ext cx="5074920" cy="658368"/>
-          </a:xfrm>
-          <a:prstGeom prst="roundRect">
-            <a:avLst/>
-          </a:prstGeom>
-          <a:solidFill>
-            <a:srgbClr val="E6F4F7"/>
-          </a:solidFill>
-          <a:ln w="12700">
-            <a:solidFill>
-              <a:srgbClr val="B9D9E0"/>
-            </a:solidFill>
-          </a:ln>
-        </p:spPr>
-        <p:style>
-          <a:lnRef idx="1">
-            <a:schemeClr val="accent1"/>
-          </a:lnRef>
-          <a:fillRef idx="3">
-            <a:schemeClr val="accent1"/>
-          </a:fillRef>
-          <a:effectRef idx="2">
-            <a:schemeClr val="accent1"/>
-          </a:effectRef>
-          <a:fontRef idx="minor">
-            <a:schemeClr val="lt1"/>
-          </a:fontRef>
-        </p:style>
-        <p:txBody>
-          <a:bodyPr rtlCol="0" anchor="ctr"/>
-          <a:lstStyle/>
-          <a:p>
-            <a:pPr algn="ctr"/>
-          </a:p>
-        </p:txBody>
-      </p:sp>
-      <p:sp>
-        <p:nvSpPr>
-          <p:cNvPr id="10" name="TextBox 9"/>
-          <p:cNvSpPr txBox="1"/>
-          <p:nvPr/>
-        </p:nvSpPr>
-        <p:spPr>
-          <a:xfrm>
-            <a:off x="914400" y="3931920"/>
-            <a:ext cx="4572000" cy="228600"/>
-          </a:xfrm>
-          <a:prstGeom prst="rect">
-            <a:avLst/>
-          </a:prstGeom>
-          <a:noFill/>
-        </p:spPr>
-        <p:txBody>
-          <a:bodyPr wrap="square">
-            <a:spAutoFit/>
-          </a:bodyPr>
-          <a:lstStyle/>
-          <a:p>
-            <a:pPr algn="ctr"/>
-            <a:r>
-              <a:rPr sz="1400" b="1" i="0">
-                <a:solidFill>
-                  <a:srgbClr val="11374B"/>
-                </a:solidFill>
-                <a:latin typeface="Aptos"/>
-              </a:rPr>
-              <a:t>Teaching focus: cooling-mode AC for Thailand</a:t>
-            </a:r>
-          </a:p>
-        </p:txBody>
-      </p:sp>
-      <p:sp>
-        <p:nvSpPr>
-          <p:cNvPr id="11" name="Rounded Rectangle 10"/>
-          <p:cNvSpPr/>
-          <p:nvPr/>
-        </p:nvSpPr>
-        <p:spPr>
-          <a:xfrm>
-            <a:off x="6400800" y="1051560"/>
-            <a:ext cx="4983480" cy="4434840"/>
-          </a:xfrm>
-          <a:prstGeom prst="roundRect">
-            <a:avLst/>
-          </a:prstGeom>
-          <a:solidFill>
-            <a:srgbClr val="FFFFFF"/>
-          </a:solidFill>
-          <a:ln w="12700">
-            <a:solidFill>
-              <a:srgbClr val="DCE2E8"/>
-            </a:solidFill>
-          </a:ln>
-        </p:spPr>
-        <p:style>
-          <a:lnRef idx="1">
-            <a:schemeClr val="accent1"/>
-          </a:lnRef>
-          <a:fillRef idx="3">
-            <a:schemeClr val="accent1"/>
-          </a:fillRef>
-          <a:effectRef idx="2">
-            <a:schemeClr val="accent1"/>
-          </a:effectRef>
-          <a:fontRef idx="minor">
-            <a:schemeClr val="lt1"/>
-          </a:fontRef>
-        </p:style>
-        <p:txBody>
-          <a:bodyPr rtlCol="0" anchor="ctr"/>
-          <a:lstStyle/>
-          <a:p>
-            <a:pPr algn="ctr"/>
-          </a:p>
-        </p:txBody>
-      </p:sp>
-      <p:sp>
-        <p:nvSpPr>
-          <p:cNvPr id="12" name="Rounded Rectangle 11"/>
-          <p:cNvSpPr/>
-          <p:nvPr/>
-        </p:nvSpPr>
-        <p:spPr>
-          <a:xfrm>
-            <a:off x="7178040" y="2057400"/>
-            <a:ext cx="3429000" cy="2057400"/>
-          </a:xfrm>
-          <a:prstGeom prst="roundRect">
-            <a:avLst/>
-          </a:prstGeom>
-          <a:solidFill>
-            <a:srgbClr val="ECF7F9"/>
-          </a:solidFill>
-          <a:ln w="12700">
-            <a:solidFill>
-              <a:srgbClr val="B2D2DB"/>
-            </a:solidFill>
-          </a:ln>
-        </p:spPr>
-        <p:style>
-          <a:lnRef idx="1">
-            <a:schemeClr val="accent1"/>
-          </a:lnRef>
-          <a:fillRef idx="3">
-            <a:schemeClr val="accent1"/>
-          </a:fillRef>
-          <a:effectRef idx="2">
-            <a:schemeClr val="accent1"/>
-          </a:effectRef>
-          <a:fontRef idx="minor">
-            <a:schemeClr val="lt1"/>
-          </a:fontRef>
-        </p:style>
-        <p:txBody>
-          <a:bodyPr rtlCol="0" anchor="ctr"/>
-          <a:lstStyle/>
-          <a:p>
-            <a:pPr algn="ctr"/>
-          </a:p>
-        </p:txBody>
-      </p:sp>
-      <p:sp>
-        <p:nvSpPr>
-          <p:cNvPr id="13" name="TextBox 12"/>
-          <p:cNvSpPr txBox="1"/>
-          <p:nvPr/>
-        </p:nvSpPr>
-        <p:spPr>
-          <a:xfrm>
-            <a:off x="7516368" y="2697480"/>
-            <a:ext cx="2743200" cy="320040"/>
-          </a:xfrm>
-          <a:prstGeom prst="rect">
-            <a:avLst/>
-          </a:prstGeom>
-          <a:noFill/>
-        </p:spPr>
-        <p:txBody>
-          <a:bodyPr wrap="square">
-            <a:spAutoFit/>
-          </a:bodyPr>
-          <a:lstStyle/>
-          <a:p>
-            <a:pPr algn="ctr"/>
-            <a:r>
-              <a:rPr sz="2300" b="1" i="0">
-                <a:solidFill>
-                  <a:srgbClr val="11374B"/>
-                </a:solidFill>
-                <a:latin typeface="Aptos"/>
-              </a:rPr>
-              <a:t>Conditioned Space</a:t>
-            </a:r>
-          </a:p>
-        </p:txBody>
-      </p:sp>
-      <p:sp>
-        <p:nvSpPr>
-          <p:cNvPr id="14" name="TextBox 13"/>
-          <p:cNvSpPr txBox="1"/>
-          <p:nvPr/>
-        </p:nvSpPr>
-        <p:spPr>
-          <a:xfrm>
-            <a:off x="7616952" y="3145536"/>
-            <a:ext cx="2514600" cy="274320"/>
-          </a:xfrm>
-          <a:prstGeom prst="rect">
-            <a:avLst/>
-          </a:prstGeom>
-          <a:noFill/>
-        </p:spPr>
-        <p:txBody>
-          <a:bodyPr wrap="square">
-            <a:spAutoFit/>
-          </a:bodyPr>
-          <a:lstStyle/>
-          <a:p>
-            <a:pPr algn="ctr"/>
-            <a:r>
-              <a:rPr sz="1200" b="0" i="0">
-                <a:solidFill>
-                  <a:srgbClr val="5A6973"/>
-                </a:solidFill>
-                <a:latin typeface="Aptos"/>
-              </a:rPr>
-              <a:t>controlled indoor air</a:t>
-            </a:r>
-          </a:p>
-        </p:txBody>
-      </p:sp>
-      <p:cxnSp>
-        <p:nvCxnSpPr>
-          <p:cNvPr id="15" name="Connector 14"/>
-          <p:cNvCxnSpPr/>
-          <p:nvPr/>
-        </p:nvCxnSpPr>
-        <p:spPr>
-          <a:xfrm>
-            <a:off x="6812280" y="1828800"/>
-            <a:ext cx="4160520" cy="0"/>
-          </a:xfrm>
-          <a:prstGeom prst="line">
-            <a:avLst/>
-          </a:prstGeom>
-          <a:ln w="22860">
-            <a:solidFill>
-              <a:srgbClr val="2A9D8F"/>
-            </a:solidFill>
-          </a:ln>
-        </p:spPr>
-        <p:style>
-          <a:lnRef idx="2">
-            <a:schemeClr val="accent1"/>
-          </a:lnRef>
-          <a:fillRef idx="0">
-            <a:schemeClr val="accent1"/>
-          </a:fillRef>
-          <a:effectRef idx="1">
-            <a:schemeClr val="accent1"/>
-          </a:effectRef>
-          <a:fontRef idx="minor">
-            <a:schemeClr val="tx1"/>
-          </a:fontRef>
-        </p:style>
-      </p:cxnSp>
-      <p:cxnSp>
-        <p:nvCxnSpPr>
-          <p:cNvPr id="16" name="Connector 15"/>
-          <p:cNvCxnSpPr/>
-          <p:nvPr/>
-        </p:nvCxnSpPr>
-        <p:spPr>
-          <a:xfrm>
-            <a:off x="6812280" y="2148840"/>
-            <a:ext cx="4160520" cy="0"/>
-          </a:xfrm>
-          <a:prstGeom prst="line">
-            <a:avLst/>
-          </a:prstGeom>
-          <a:ln w="22860">
-            <a:solidFill>
-              <a:srgbClr val="2A9D8F"/>
-            </a:solidFill>
-          </a:ln>
-        </p:spPr>
-        <p:style>
-          <a:lnRef idx="2">
-            <a:schemeClr val="accent1"/>
-          </a:lnRef>
-          <a:fillRef idx="0">
-            <a:schemeClr val="accent1"/>
-          </a:fillRef>
-          <a:effectRef idx="1">
-            <a:schemeClr val="accent1"/>
-          </a:effectRef>
-          <a:fontRef idx="minor">
-            <a:schemeClr val="tx1"/>
-          </a:fontRef>
-        </p:style>
-      </p:cxnSp>
-      <p:cxnSp>
-        <p:nvCxnSpPr>
-          <p:cNvPr id="17" name="Connector 16"/>
-          <p:cNvCxnSpPr/>
-          <p:nvPr/>
-        </p:nvCxnSpPr>
-        <p:spPr>
-          <a:xfrm>
-            <a:off x="6812280" y="4389120"/>
-            <a:ext cx="4160520" cy="0"/>
-          </a:xfrm>
-          <a:prstGeom prst="line">
-            <a:avLst/>
-          </a:prstGeom>
-          <a:ln w="22860">
-            <a:solidFill>
-              <a:srgbClr val="2A9D8F"/>
-            </a:solidFill>
-          </a:ln>
-        </p:spPr>
-        <p:style>
-          <a:lnRef idx="2">
-            <a:schemeClr val="accent1"/>
-          </a:lnRef>
-          <a:fillRef idx="0">
-            <a:schemeClr val="accent1"/>
-          </a:fillRef>
-          <a:effectRef idx="1">
-            <a:schemeClr val="accent1"/>
-          </a:effectRef>
-          <a:fontRef idx="minor">
-            <a:schemeClr val="tx1"/>
-          </a:fontRef>
-        </p:style>
-      </p:cxnSp>
-      <p:cxnSp>
-        <p:nvCxnSpPr>
-          <p:cNvPr id="18" name="Connector 17"/>
-          <p:cNvCxnSpPr/>
-          <p:nvPr/>
-        </p:nvCxnSpPr>
-        <p:spPr>
-          <a:xfrm>
-            <a:off x="6812280" y="4709160"/>
-            <a:ext cx="4160520" cy="0"/>
-          </a:xfrm>
-          <a:prstGeom prst="line">
-            <a:avLst/>
-          </a:prstGeom>
-          <a:ln w="22860">
-            <a:solidFill>
-              <a:srgbClr val="2A9D8F"/>
-            </a:solidFill>
-          </a:ln>
-        </p:spPr>
-        <p:style>
-          <a:lnRef idx="2">
-            <a:schemeClr val="accent1"/>
-          </a:lnRef>
-          <a:fillRef idx="0">
-            <a:schemeClr val="accent1"/>
-          </a:fillRef>
-          <a:effectRef idx="1">
-            <a:schemeClr val="accent1"/>
-          </a:effectRef>
-          <a:fontRef idx="minor">
-            <a:schemeClr val="tx1"/>
-          </a:fontRef>
-        </p:style>
-      </p:cxnSp>
-      <p:sp>
-        <p:nvSpPr>
-          <p:cNvPr id="19" name="Rectangle 18"/>
-          <p:cNvSpPr/>
-          <p:nvPr/>
-        </p:nvSpPr>
-        <p:spPr>
-          <a:xfrm>
-            <a:off x="6656832" y="1828800"/>
-            <a:ext cx="228600" cy="2880360"/>
-          </a:xfrm>
-          <a:prstGeom prst="rect">
-            <a:avLst/>
-          </a:prstGeom>
-          <a:solidFill>
-            <a:srgbClr val="2A9D8F"/>
-          </a:solidFill>
-          <a:ln>
-            <a:noFill/>
-          </a:ln>
-        </p:spPr>
-        <p:style>
-          <a:lnRef idx="1">
-            <a:schemeClr val="accent1"/>
-          </a:lnRef>
-          <a:fillRef idx="3">
-            <a:schemeClr val="accent1"/>
-          </a:fillRef>
-          <a:effectRef idx="2">
-            <a:schemeClr val="accent1"/>
-          </a:effectRef>
-          <a:fontRef idx="minor">
-            <a:schemeClr val="lt1"/>
-          </a:fontRef>
-        </p:style>
-        <p:txBody>
-          <a:bodyPr rtlCol="0" anchor="ctr"/>
-          <a:lstStyle/>
-          <a:p>
-            <a:pPr algn="ctr"/>
-          </a:p>
-        </p:txBody>
-      </p:sp>
-      <p:sp>
-        <p:nvSpPr>
-          <p:cNvPr id="20" name="Rectangle 19"/>
-          <p:cNvSpPr/>
-          <p:nvPr/>
-        </p:nvSpPr>
-        <p:spPr>
-          <a:xfrm>
-            <a:off x="10917936" y="1828800"/>
-            <a:ext cx="228600" cy="2880360"/>
-          </a:xfrm>
-          <a:prstGeom prst="rect">
-            <a:avLst/>
-          </a:prstGeom>
-          <a:solidFill>
-            <a:srgbClr val="457B9D"/>
-          </a:solidFill>
-          <a:ln>
-            <a:noFill/>
-          </a:ln>
-        </p:spPr>
-        <p:style>
-          <a:lnRef idx="1">
-            <a:schemeClr val="accent1"/>
-          </a:lnRef>
-          <a:fillRef idx="3">
-            <a:schemeClr val="accent1"/>
-          </a:fillRef>
-          <a:effectRef idx="2">
-            <a:schemeClr val="accent1"/>
-          </a:effectRef>
-          <a:fontRef idx="minor">
-            <a:schemeClr val="lt1"/>
-          </a:fontRef>
-        </p:style>
-        <p:txBody>
-          <a:bodyPr rtlCol="0" anchor="ctr"/>
-          <a:lstStyle/>
-          <a:p>
-            <a:pPr algn="ctr"/>
-          </a:p>
-        </p:txBody>
-      </p:sp>
-      <p:sp>
-        <p:nvSpPr>
-          <p:cNvPr id="21" name="TextBox 20"/>
-          <p:cNvSpPr txBox="1"/>
-          <p:nvPr/>
-        </p:nvSpPr>
-        <p:spPr>
-          <a:xfrm>
-            <a:off x="6446520" y="4956048"/>
-            <a:ext cx="685800" cy="201168"/>
-          </a:xfrm>
-          <a:prstGeom prst="rect">
-            <a:avLst/>
-          </a:prstGeom>
-          <a:noFill/>
-        </p:spPr>
-        <p:txBody>
-          <a:bodyPr wrap="square">
-            <a:spAutoFit/>
-          </a:bodyPr>
-          <a:lstStyle/>
-          <a:p>
-            <a:pPr algn="ctr"/>
-            <a:r>
-              <a:rPr sz="800" b="1" i="0">
-                <a:solidFill>
-                  <a:srgbClr val="2A9D8F"/>
-                </a:solidFill>
-                <a:latin typeface="Aptos"/>
-              </a:rPr>
-              <a:t>Supply</a:t>
-            </a:r>
-          </a:p>
-        </p:txBody>
-      </p:sp>
-      <p:sp>
-        <p:nvSpPr>
-          <p:cNvPr id="22" name="TextBox 21"/>
-          <p:cNvSpPr txBox="1"/>
-          <p:nvPr/>
-        </p:nvSpPr>
-        <p:spPr>
-          <a:xfrm>
-            <a:off x="10698480" y="4956048"/>
-            <a:ext cx="685800" cy="201168"/>
-          </a:xfrm>
-          <a:prstGeom prst="rect">
-            <a:avLst/>
-          </a:prstGeom>
-          <a:noFill/>
-        </p:spPr>
-        <p:txBody>
-          <a:bodyPr wrap="square">
-            <a:spAutoFit/>
-          </a:bodyPr>
-          <a:lstStyle/>
-          <a:p>
-            <a:pPr algn="ctr"/>
-            <a:r>
-              <a:rPr sz="800" b="1" i="0">
-                <a:solidFill>
-                  <a:srgbClr val="457B9D"/>
-                </a:solidFill>
-                <a:latin typeface="Aptos"/>
-              </a:rPr>
-              <a:t>Return</a:t>
-            </a:r>
-          </a:p>
-        </p:txBody>
-      </p:sp>
-      <p:sp>
-        <p:nvSpPr>
-          <p:cNvPr id="23" name="Oval 22"/>
-          <p:cNvSpPr/>
-          <p:nvPr/>
-        </p:nvSpPr>
-        <p:spPr>
-          <a:xfrm>
-            <a:off x="5989320" y="1325880"/>
-            <a:ext cx="749808" cy="749808"/>
-          </a:xfrm>
-          <a:prstGeom prst="ellipse">
-            <a:avLst/>
-          </a:prstGeom>
-          <a:solidFill>
-            <a:srgbClr val="E76F51"/>
-          </a:solidFill>
-          <a:ln>
-            <a:noFill/>
-          </a:ln>
-        </p:spPr>
-        <p:style>
-          <a:lnRef idx="1">
-            <a:schemeClr val="accent1"/>
-          </a:lnRef>
-          <a:fillRef idx="3">
-            <a:schemeClr val="accent1"/>
-          </a:fillRef>
-          <a:effectRef idx="2">
-            <a:schemeClr val="accent1"/>
-          </a:effectRef>
-          <a:fontRef idx="minor">
-            <a:schemeClr val="lt1"/>
-          </a:fontRef>
-        </p:style>
-        <p:txBody>
-          <a:bodyPr rtlCol="0" anchor="ctr"/>
-          <a:lstStyle/>
-          <a:p>
-            <a:pPr algn="ctr"/>
-          </a:p>
-        </p:txBody>
-      </p:sp>
-      <p:sp>
-        <p:nvSpPr>
-          <p:cNvPr id="24" name="TextBox 23"/>
-          <p:cNvSpPr txBox="1"/>
-          <p:nvPr/>
-        </p:nvSpPr>
-        <p:spPr>
-          <a:xfrm>
-            <a:off x="5989320" y="1536192"/>
-            <a:ext cx="749808" cy="201168"/>
-          </a:xfrm>
-          <a:prstGeom prst="rect">
-            <a:avLst/>
-          </a:prstGeom>
-          <a:noFill/>
-        </p:spPr>
-        <p:txBody>
-          <a:bodyPr wrap="square">
-            <a:spAutoFit/>
-          </a:bodyPr>
-          <a:lstStyle/>
-          <a:p>
-            <a:pPr algn="ctr"/>
-            <a:r>
-              <a:rPr sz="1300" b="1" i="0">
-                <a:solidFill>
-                  <a:srgbClr val="FFFFFF"/>
-                </a:solidFill>
-                <a:latin typeface="Aptos"/>
-              </a:rPr>
-              <a:t>T</a:t>
-            </a:r>
-          </a:p>
-        </p:txBody>
-      </p:sp>
-      <p:sp>
-        <p:nvSpPr>
-          <p:cNvPr id="25" name="TextBox 24"/>
-          <p:cNvSpPr txBox="1"/>
-          <p:nvPr/>
-        </p:nvSpPr>
-        <p:spPr>
-          <a:xfrm>
-            <a:off x="5605272" y="2130552"/>
-            <a:ext cx="1554480" cy="237744"/>
-          </a:xfrm>
-          <a:prstGeom prst="rect">
-            <a:avLst/>
-          </a:prstGeom>
-          <a:noFill/>
-        </p:spPr>
-        <p:txBody>
-          <a:bodyPr wrap="square">
-            <a:spAutoFit/>
-          </a:bodyPr>
-          <a:lstStyle/>
-          <a:p>
-            <a:pPr algn="ctr"/>
-            <a:r>
-              <a:rPr sz="950" b="1" i="0">
-                <a:solidFill>
-                  <a:srgbClr val="E76F51"/>
-                </a:solidFill>
-                <a:latin typeface="Aptos"/>
-              </a:rPr>
-              <a:t>Temperature</a:t>
-            </a:r>
-          </a:p>
-        </p:txBody>
-      </p:sp>
-      <p:cxnSp>
-        <p:nvCxnSpPr>
-          <p:cNvPr id="26" name="Connector 25"/>
-          <p:cNvCxnSpPr/>
-          <p:nvPr/>
-        </p:nvCxnSpPr>
-        <p:spPr>
-          <a:xfrm>
-            <a:off x="6364224" y="1700784"/>
-            <a:ext cx="2523744" cy="1389888"/>
-          </a:xfrm>
-          <a:prstGeom prst="line">
-            <a:avLst/>
-          </a:prstGeom>
-          <a:ln w="16510">
-            <a:solidFill>
-              <a:srgbClr val="E76F51"/>
-            </a:solidFill>
-          </a:ln>
-        </p:spPr>
-        <p:style>
-          <a:lnRef idx="2">
-            <a:schemeClr val="accent1"/>
-          </a:lnRef>
-          <a:fillRef idx="0">
-            <a:schemeClr val="accent1"/>
-          </a:fillRef>
-          <a:effectRef idx="1">
-            <a:schemeClr val="accent1"/>
-          </a:effectRef>
-          <a:fontRef idx="minor">
-            <a:schemeClr val="tx1"/>
-          </a:fontRef>
-        </p:style>
-      </p:cxnSp>
-      <p:sp>
-        <p:nvSpPr>
-          <p:cNvPr id="27" name="Oval 26"/>
-          <p:cNvSpPr/>
-          <p:nvPr/>
-        </p:nvSpPr>
-        <p:spPr>
-          <a:xfrm>
-            <a:off x="10927080" y="1325880"/>
-            <a:ext cx="749808" cy="749808"/>
-          </a:xfrm>
-          <a:prstGeom prst="ellipse">
-            <a:avLst/>
-          </a:prstGeom>
-          <a:solidFill>
-            <a:srgbClr val="457B9D"/>
-          </a:solidFill>
-          <a:ln>
-            <a:noFill/>
-          </a:ln>
-        </p:spPr>
-        <p:style>
-          <a:lnRef idx="1">
-            <a:schemeClr val="accent1"/>
-          </a:lnRef>
-          <a:fillRef idx="3">
-            <a:schemeClr val="accent1"/>
-          </a:fillRef>
-          <a:effectRef idx="2">
-            <a:schemeClr val="accent1"/>
-          </a:effectRef>
-          <a:fontRef idx="minor">
-            <a:schemeClr val="lt1"/>
-          </a:fontRef>
-        </p:style>
-        <p:txBody>
-          <a:bodyPr rtlCol="0" anchor="ctr"/>
-          <a:lstStyle/>
-          <a:p>
-            <a:pPr algn="ctr"/>
-          </a:p>
-        </p:txBody>
-      </p:sp>
-      <p:sp>
-        <p:nvSpPr>
-          <p:cNvPr id="28" name="TextBox 27"/>
-          <p:cNvSpPr txBox="1"/>
-          <p:nvPr/>
-        </p:nvSpPr>
-        <p:spPr>
-          <a:xfrm>
-            <a:off x="10927080" y="1536192"/>
-            <a:ext cx="749808" cy="201168"/>
-          </a:xfrm>
-          <a:prstGeom prst="rect">
-            <a:avLst/>
-          </a:prstGeom>
-          <a:noFill/>
-        </p:spPr>
-        <p:txBody>
-          <a:bodyPr wrap="square">
-            <a:spAutoFit/>
-          </a:bodyPr>
-          <a:lstStyle/>
-          <a:p>
-            <a:pPr algn="ctr"/>
-            <a:r>
-              <a:rPr sz="1300" b="1" i="0">
-                <a:solidFill>
-                  <a:srgbClr val="FFFFFF"/>
-                </a:solidFill>
-                <a:latin typeface="Aptos"/>
-              </a:rPr>
-              <a:t>RH</a:t>
-            </a:r>
-          </a:p>
-        </p:txBody>
-      </p:sp>
-      <p:sp>
-        <p:nvSpPr>
-          <p:cNvPr id="29" name="TextBox 28"/>
-          <p:cNvSpPr txBox="1"/>
-          <p:nvPr/>
-        </p:nvSpPr>
-        <p:spPr>
-          <a:xfrm>
-            <a:off x="10543032" y="2130552"/>
-            <a:ext cx="1554480" cy="237744"/>
-          </a:xfrm>
-          <a:prstGeom prst="rect">
-            <a:avLst/>
-          </a:prstGeom>
-          <a:noFill/>
-        </p:spPr>
-        <p:txBody>
-          <a:bodyPr wrap="square">
-            <a:spAutoFit/>
-          </a:bodyPr>
-          <a:lstStyle/>
-          <a:p>
-            <a:pPr algn="ctr"/>
-            <a:r>
-              <a:rPr sz="950" b="1" i="0">
-                <a:solidFill>
-                  <a:srgbClr val="457B9D"/>
-                </a:solidFill>
-                <a:latin typeface="Aptos"/>
-              </a:rPr>
-              <a:t>Humidity</a:t>
-            </a:r>
-          </a:p>
-        </p:txBody>
-      </p:sp>
-      <p:cxnSp>
-        <p:nvCxnSpPr>
-          <p:cNvPr id="30" name="Connector 29"/>
-          <p:cNvCxnSpPr/>
-          <p:nvPr/>
-        </p:nvCxnSpPr>
-        <p:spPr>
-          <a:xfrm flipH="1">
-            <a:off x="8887968" y="1700784"/>
-            <a:ext cx="2414016" cy="1389888"/>
-          </a:xfrm>
-          <a:prstGeom prst="line">
-            <a:avLst/>
-          </a:prstGeom>
-          <a:ln w="16510">
-            <a:solidFill>
-              <a:srgbClr val="457B9D"/>
-            </a:solidFill>
-          </a:ln>
-        </p:spPr>
-        <p:style>
-          <a:lnRef idx="2">
-            <a:schemeClr val="accent1"/>
-          </a:lnRef>
-          <a:fillRef idx="0">
-            <a:schemeClr val="accent1"/>
-          </a:fillRef>
-          <a:effectRef idx="1">
-            <a:schemeClr val="accent1"/>
-          </a:effectRef>
-          <a:fontRef idx="minor">
-            <a:schemeClr val="tx1"/>
-          </a:fontRef>
-        </p:style>
-      </p:cxnSp>
-      <p:sp>
-        <p:nvSpPr>
-          <p:cNvPr id="31" name="Oval 30"/>
-          <p:cNvSpPr/>
-          <p:nvPr/>
-        </p:nvSpPr>
-        <p:spPr>
-          <a:xfrm>
-            <a:off x="5989320" y="4709160"/>
-            <a:ext cx="749808" cy="749808"/>
-          </a:xfrm>
-          <a:prstGeom prst="ellipse">
-            <a:avLst/>
-          </a:prstGeom>
-          <a:solidFill>
-            <a:srgbClr val="2A9D8F"/>
-          </a:solidFill>
-          <a:ln>
-            <a:noFill/>
-          </a:ln>
-        </p:spPr>
-        <p:style>
-          <a:lnRef idx="1">
-            <a:schemeClr val="accent1"/>
-          </a:lnRef>
-          <a:fillRef idx="3">
-            <a:schemeClr val="accent1"/>
-          </a:fillRef>
-          <a:effectRef idx="2">
-            <a:schemeClr val="accent1"/>
-          </a:effectRef>
-          <a:fontRef idx="minor">
-            <a:schemeClr val="lt1"/>
-          </a:fontRef>
-        </p:style>
-        <p:txBody>
-          <a:bodyPr rtlCol="0" anchor="ctr"/>
-          <a:lstStyle/>
-          <a:p>
-            <a:pPr algn="ctr"/>
-          </a:p>
-        </p:txBody>
-      </p:sp>
-      <p:sp>
-        <p:nvSpPr>
-          <p:cNvPr id="32" name="TextBox 31"/>
-          <p:cNvSpPr txBox="1"/>
-          <p:nvPr/>
-        </p:nvSpPr>
-        <p:spPr>
-          <a:xfrm>
-            <a:off x="5989320" y="4919472"/>
-            <a:ext cx="749808" cy="201168"/>
-          </a:xfrm>
-          <a:prstGeom prst="rect">
-            <a:avLst/>
-          </a:prstGeom>
-          <a:noFill/>
-        </p:spPr>
-        <p:txBody>
-          <a:bodyPr wrap="square">
-            <a:spAutoFit/>
-          </a:bodyPr>
-          <a:lstStyle/>
-          <a:p>
-            <a:pPr algn="ctr"/>
-            <a:r>
-              <a:rPr sz="1300" b="1" i="0">
-                <a:solidFill>
-                  <a:srgbClr val="FFFFFF"/>
-                </a:solidFill>
-                <a:latin typeface="Aptos"/>
-              </a:rPr>
-              <a:t>↻</a:t>
-            </a:r>
-          </a:p>
-        </p:txBody>
-      </p:sp>
-      <p:sp>
-        <p:nvSpPr>
-          <p:cNvPr id="33" name="TextBox 32"/>
-          <p:cNvSpPr txBox="1"/>
-          <p:nvPr/>
-        </p:nvSpPr>
-        <p:spPr>
-          <a:xfrm>
-            <a:off x="5605272" y="5513832"/>
-            <a:ext cx="1554480" cy="237744"/>
-          </a:xfrm>
-          <a:prstGeom prst="rect">
-            <a:avLst/>
-          </a:prstGeom>
-          <a:noFill/>
-        </p:spPr>
-        <p:txBody>
-          <a:bodyPr wrap="square">
-            <a:spAutoFit/>
-          </a:bodyPr>
-          <a:lstStyle/>
-          <a:p>
-            <a:pPr algn="ctr"/>
-            <a:r>
-              <a:rPr sz="950" b="1" i="0">
-                <a:solidFill>
-                  <a:srgbClr val="2A9D8F"/>
-                </a:solidFill>
-                <a:latin typeface="Aptos"/>
-              </a:rPr>
-              <a:t>Air circulation</a:t>
-            </a:r>
-          </a:p>
-        </p:txBody>
-      </p:sp>
-      <p:cxnSp>
-        <p:nvCxnSpPr>
-          <p:cNvPr id="34" name="Connector 33"/>
-          <p:cNvCxnSpPr/>
-          <p:nvPr/>
-        </p:nvCxnSpPr>
-        <p:spPr>
-          <a:xfrm flipV="1">
-            <a:off x="6364224" y="3090672"/>
-            <a:ext cx="2523744" cy="1993392"/>
-          </a:xfrm>
-          <a:prstGeom prst="line">
-            <a:avLst/>
-          </a:prstGeom>
-          <a:ln w="16510">
-            <a:solidFill>
-              <a:srgbClr val="2A9D8F"/>
-            </a:solidFill>
-          </a:ln>
-        </p:spPr>
-        <p:style>
-          <a:lnRef idx="2">
-            <a:schemeClr val="accent1"/>
-          </a:lnRef>
-          <a:fillRef idx="0">
-            <a:schemeClr val="accent1"/>
-          </a:fillRef>
-          <a:effectRef idx="1">
-            <a:schemeClr val="accent1"/>
-          </a:effectRef>
-          <a:fontRef idx="minor">
-            <a:schemeClr val="tx1"/>
-          </a:fontRef>
-        </p:style>
-      </p:cxnSp>
-      <p:sp>
-        <p:nvSpPr>
-          <p:cNvPr id="35" name="Oval 34"/>
-          <p:cNvSpPr/>
-          <p:nvPr/>
-        </p:nvSpPr>
-        <p:spPr>
-          <a:xfrm>
-            <a:off x="10927080" y="4709160"/>
-            <a:ext cx="749808" cy="749808"/>
-          </a:xfrm>
-          <a:prstGeom prst="ellipse">
-            <a:avLst/>
-          </a:prstGeom>
-          <a:solidFill>
-            <a:srgbClr val="4CAF50"/>
-          </a:solidFill>
-          <a:ln>
-            <a:noFill/>
-          </a:ln>
-        </p:spPr>
-        <p:style>
-          <a:lnRef idx="1">
-            <a:schemeClr val="accent1"/>
-          </a:lnRef>
-          <a:fillRef idx="3">
-            <a:schemeClr val="accent1"/>
-          </a:fillRef>
-          <a:effectRef idx="2">
-            <a:schemeClr val="accent1"/>
-          </a:effectRef>
-          <a:fontRef idx="minor">
-            <a:schemeClr val="lt1"/>
-          </a:fontRef>
-        </p:style>
-        <p:txBody>
-          <a:bodyPr rtlCol="0" anchor="ctr"/>
-          <a:lstStyle/>
-          <a:p>
-            <a:pPr algn="ctr"/>
-          </a:p>
-        </p:txBody>
-      </p:sp>
-      <p:sp>
-        <p:nvSpPr>
-          <p:cNvPr id="36" name="TextBox 35"/>
-          <p:cNvSpPr txBox="1"/>
-          <p:nvPr/>
-        </p:nvSpPr>
-        <p:spPr>
-          <a:xfrm>
-            <a:off x="10927080" y="4919472"/>
-            <a:ext cx="749808" cy="201168"/>
-          </a:xfrm>
-          <a:prstGeom prst="rect">
-            <a:avLst/>
-          </a:prstGeom>
-          <a:noFill/>
-        </p:spPr>
-        <p:txBody>
-          <a:bodyPr wrap="square">
-            <a:spAutoFit/>
-          </a:bodyPr>
-          <a:lstStyle/>
-          <a:p>
-            <a:pPr algn="ctr"/>
-            <a:r>
-              <a:rPr sz="1300" b="1" i="0">
-                <a:solidFill>
-                  <a:srgbClr val="FFFFFF"/>
-                </a:solidFill>
-                <a:latin typeface="Aptos"/>
-              </a:rPr>
-              <a:t>●</a:t>
-            </a:r>
-          </a:p>
-        </p:txBody>
-      </p:sp>
-      <p:sp>
-        <p:nvSpPr>
-          <p:cNvPr id="37" name="TextBox 36"/>
-          <p:cNvSpPr txBox="1"/>
-          <p:nvPr/>
-        </p:nvSpPr>
-        <p:spPr>
-          <a:xfrm>
-            <a:off x="10543032" y="5513832"/>
-            <a:ext cx="1554480" cy="237744"/>
-          </a:xfrm>
-          <a:prstGeom prst="rect">
-            <a:avLst/>
-          </a:prstGeom>
-          <a:noFill/>
-        </p:spPr>
-        <p:txBody>
-          <a:bodyPr wrap="square">
-            <a:spAutoFit/>
-          </a:bodyPr>
-          <a:lstStyle/>
-          <a:p>
-            <a:pPr algn="ctr"/>
-            <a:r>
-              <a:rPr sz="950" b="1" i="0">
-                <a:solidFill>
-                  <a:srgbClr val="4CAF50"/>
-                </a:solidFill>
-                <a:latin typeface="Aptos"/>
-              </a:rPr>
-              <a:t>Air cleanliness</a:t>
-            </a:r>
-          </a:p>
-        </p:txBody>
-      </p:sp>
-      <p:cxnSp>
-        <p:nvCxnSpPr>
-          <p:cNvPr id="38" name="Connector 37"/>
-          <p:cNvCxnSpPr/>
-          <p:nvPr/>
-        </p:nvCxnSpPr>
-        <p:spPr>
-          <a:xfrm flipH="1" flipV="1">
-            <a:off x="8887968" y="3090672"/>
-            <a:ext cx="2414016" cy="1993392"/>
-          </a:xfrm>
-          <a:prstGeom prst="line">
-            <a:avLst/>
-          </a:prstGeom>
-          <a:ln w="16510">
-            <a:solidFill>
-              <a:srgbClr val="4CAF50"/>
-            </a:solidFill>
-          </a:ln>
-        </p:spPr>
-        <p:style>
-          <a:lnRef idx="2">
-            <a:schemeClr val="accent1"/>
-          </a:lnRef>
-          <a:fillRef idx="0">
-            <a:schemeClr val="accent1"/>
-          </a:fillRef>
-          <a:effectRef idx="1">
-            <a:schemeClr val="accent1"/>
-          </a:effectRef>
-          <a:fontRef idx="minor">
-            <a:schemeClr val="tx1"/>
-          </a:fontRef>
-        </p:style>
-      </p:cxnSp>
-      <p:sp>
-        <p:nvSpPr>
-          <p:cNvPr id="39" name="Oval 38"/>
-          <p:cNvSpPr/>
-          <p:nvPr/>
-        </p:nvSpPr>
-        <p:spPr>
-          <a:xfrm>
-            <a:off x="685800" y="5074920"/>
-            <a:ext cx="384048" cy="384048"/>
-          </a:xfrm>
-          <a:prstGeom prst="ellipse">
-            <a:avLst/>
-          </a:prstGeom>
-          <a:solidFill>
-            <a:srgbClr val="2A9D8F"/>
-          </a:solidFill>
-          <a:ln>
-            <a:noFill/>
-          </a:ln>
-        </p:spPr>
-        <p:style>
-          <a:lnRef idx="1">
-            <a:schemeClr val="accent1"/>
-          </a:lnRef>
-          <a:fillRef idx="3">
-            <a:schemeClr val="accent1"/>
-          </a:fillRef>
-          <a:effectRef idx="2">
-            <a:schemeClr val="accent1"/>
-          </a:effectRef>
-          <a:fontRef idx="minor">
-            <a:schemeClr val="lt1"/>
-          </a:fontRef>
-        </p:style>
-        <p:txBody>
-          <a:bodyPr rtlCol="0" anchor="ctr"/>
-          <a:lstStyle/>
-          <a:p>
-            <a:pPr algn="ctr"/>
-          </a:p>
-        </p:txBody>
-      </p:sp>
-      <p:sp>
-        <p:nvSpPr>
-          <p:cNvPr id="40" name="TextBox 39"/>
-          <p:cNvSpPr txBox="1"/>
-          <p:nvPr/>
-        </p:nvSpPr>
-        <p:spPr>
-          <a:xfrm>
-            <a:off x="685800" y="5184648"/>
-            <a:ext cx="384048" cy="100584"/>
-          </a:xfrm>
-          <a:prstGeom prst="rect">
-            <a:avLst/>
-          </a:prstGeom>
-          <a:noFill/>
-        </p:spPr>
-        <p:txBody>
-          <a:bodyPr wrap="square">
-            <a:spAutoFit/>
-          </a:bodyPr>
-          <a:lstStyle/>
-          <a:p>
-            <a:pPr algn="ctr"/>
-            <a:r>
-              <a:rPr sz="800" b="1" i="0">
-                <a:solidFill>
-                  <a:srgbClr val="FFFFFF"/>
-                </a:solidFill>
-                <a:latin typeface="Aptos"/>
-              </a:rPr>
-              <a:t>1</a:t>
-            </a:r>
-          </a:p>
-        </p:txBody>
-      </p:sp>
-      <p:sp>
-        <p:nvSpPr>
-          <p:cNvPr id="41" name="TextBox 40"/>
-          <p:cNvSpPr txBox="1"/>
-          <p:nvPr/>
-        </p:nvSpPr>
-        <p:spPr>
-          <a:xfrm>
-            <a:off x="1161288" y="5001768"/>
-            <a:ext cx="1097280" cy="219456"/>
-          </a:xfrm>
-          <a:prstGeom prst="rect">
-            <a:avLst/>
-          </a:prstGeom>
-          <a:noFill/>
-        </p:spPr>
-        <p:txBody>
-          <a:bodyPr wrap="square">
-            <a:spAutoFit/>
-          </a:bodyPr>
-          <a:lstStyle/>
-          <a:p>
-            <a:r>
-              <a:rPr sz="1100" b="1" i="0">
-                <a:solidFill>
-                  <a:srgbClr val="232D37"/>
-                </a:solidFill>
-                <a:latin typeface="Aptos"/>
-              </a:rPr>
-              <a:t>Comfort</a:t>
-            </a:r>
-          </a:p>
-        </p:txBody>
-      </p:sp>
-      <p:sp>
-        <p:nvSpPr>
-          <p:cNvPr id="42" name="TextBox 41"/>
-          <p:cNvSpPr txBox="1"/>
-          <p:nvPr/>
-        </p:nvSpPr>
-        <p:spPr>
-          <a:xfrm>
-            <a:off x="1161288" y="5276088"/>
-            <a:ext cx="1188720" cy="219456"/>
-          </a:xfrm>
-          <a:prstGeom prst="rect">
-            <a:avLst/>
-          </a:prstGeom>
-          <a:noFill/>
-        </p:spPr>
-        <p:txBody>
-          <a:bodyPr wrap="square">
-            <a:spAutoFit/>
-          </a:bodyPr>
-          <a:lstStyle/>
-          <a:p>
-            <a:r>
-              <a:rPr sz="750" b="0" i="0">
-                <a:solidFill>
-                  <a:srgbClr val="5A6973"/>
-                </a:solidFill>
-                <a:latin typeface="Aptos"/>
-              </a:rPr>
-              <a:t>human thermal comfort</a:t>
-            </a:r>
-          </a:p>
-        </p:txBody>
-      </p:sp>
-      <p:sp>
-        <p:nvSpPr>
-          <p:cNvPr id="43" name="Oval 42"/>
-          <p:cNvSpPr/>
-          <p:nvPr/>
-        </p:nvSpPr>
-        <p:spPr>
-          <a:xfrm>
-            <a:off x="2377440" y="5074920"/>
-            <a:ext cx="384048" cy="384048"/>
-          </a:xfrm>
-          <a:prstGeom prst="ellipse">
-            <a:avLst/>
-          </a:prstGeom>
-          <a:solidFill>
-            <a:srgbClr val="457B9D"/>
-          </a:solidFill>
-          <a:ln>
-            <a:noFill/>
-          </a:ln>
-        </p:spPr>
-        <p:style>
-          <a:lnRef idx="1">
-            <a:schemeClr val="accent1"/>
-          </a:lnRef>
-          <a:fillRef idx="3">
-            <a:schemeClr val="accent1"/>
-          </a:fillRef>
-          <a:effectRef idx="2">
-            <a:schemeClr val="accent1"/>
-          </a:effectRef>
-          <a:fontRef idx="minor">
-            <a:schemeClr val="lt1"/>
-          </a:fontRef>
-        </p:style>
-        <p:txBody>
-          <a:bodyPr rtlCol="0" anchor="ctr"/>
-          <a:lstStyle/>
-          <a:p>
-            <a:pPr algn="ctr"/>
-          </a:p>
-        </p:txBody>
-      </p:sp>
-      <p:sp>
-        <p:nvSpPr>
-          <p:cNvPr id="44" name="TextBox 43"/>
-          <p:cNvSpPr txBox="1"/>
-          <p:nvPr/>
-        </p:nvSpPr>
-        <p:spPr>
-          <a:xfrm>
-            <a:off x="2377440" y="5184648"/>
-            <a:ext cx="384048" cy="100584"/>
-          </a:xfrm>
-          <a:prstGeom prst="rect">
-            <a:avLst/>
-          </a:prstGeom>
-          <a:noFill/>
-        </p:spPr>
-        <p:txBody>
-          <a:bodyPr wrap="square">
-            <a:spAutoFit/>
-          </a:bodyPr>
-          <a:lstStyle/>
-          <a:p>
-            <a:pPr algn="ctr"/>
-            <a:r>
-              <a:rPr sz="800" b="1" i="0">
-                <a:solidFill>
-                  <a:srgbClr val="FFFFFF"/>
-                </a:solidFill>
-                <a:latin typeface="Aptos"/>
-              </a:rPr>
-              <a:t>2</a:t>
-            </a:r>
-          </a:p>
-        </p:txBody>
-      </p:sp>
-      <p:sp>
-        <p:nvSpPr>
-          <p:cNvPr id="45" name="TextBox 44"/>
-          <p:cNvSpPr txBox="1"/>
-          <p:nvPr/>
-        </p:nvSpPr>
-        <p:spPr>
-          <a:xfrm>
-            <a:off x="2852928" y="5001768"/>
-            <a:ext cx="1097280" cy="219456"/>
-          </a:xfrm>
-          <a:prstGeom prst="rect">
-            <a:avLst/>
-          </a:prstGeom>
-          <a:noFill/>
-        </p:spPr>
-        <p:txBody>
-          <a:bodyPr wrap="square">
-            <a:spAutoFit/>
-          </a:bodyPr>
-          <a:lstStyle/>
-          <a:p>
-            <a:r>
-              <a:rPr sz="1100" b="1" i="0">
-                <a:solidFill>
-                  <a:srgbClr val="232D37"/>
-                </a:solidFill>
-                <a:latin typeface="Aptos"/>
-              </a:rPr>
-              <a:t>Process</a:t>
-            </a:r>
-          </a:p>
-        </p:txBody>
-      </p:sp>
-      <p:sp>
-        <p:nvSpPr>
-          <p:cNvPr id="46" name="TextBox 45"/>
-          <p:cNvSpPr txBox="1"/>
-          <p:nvPr/>
-        </p:nvSpPr>
-        <p:spPr>
-          <a:xfrm>
-            <a:off x="2852928" y="5276088"/>
-            <a:ext cx="1188720" cy="219456"/>
-          </a:xfrm>
-          <a:prstGeom prst="rect">
-            <a:avLst/>
-          </a:prstGeom>
-          <a:noFill/>
-        </p:spPr>
-        <p:txBody>
-          <a:bodyPr wrap="square">
-            <a:spAutoFit/>
-          </a:bodyPr>
-          <a:lstStyle/>
-          <a:p>
-            <a:r>
-              <a:rPr sz="750" b="0" i="0">
-                <a:solidFill>
-                  <a:srgbClr val="5A6973"/>
-                </a:solidFill>
-                <a:latin typeface="Aptos"/>
-              </a:rPr>
-              <a:t>material / product need</a:t>
-            </a:r>
-          </a:p>
-        </p:txBody>
-      </p:sp>
-      <p:sp>
-        <p:nvSpPr>
-          <p:cNvPr id="47" name="Oval 46"/>
-          <p:cNvSpPr/>
-          <p:nvPr/>
-        </p:nvSpPr>
-        <p:spPr>
-          <a:xfrm>
-            <a:off x="4069080" y="5074920"/>
-            <a:ext cx="384048" cy="384048"/>
-          </a:xfrm>
-          <a:prstGeom prst="ellipse">
-            <a:avLst/>
-          </a:prstGeom>
-          <a:solidFill>
-            <a:srgbClr val="E76F51"/>
-          </a:solidFill>
-          <a:ln>
-            <a:noFill/>
-          </a:ln>
-        </p:spPr>
-        <p:style>
-          <a:lnRef idx="1">
-            <a:schemeClr val="accent1"/>
-          </a:lnRef>
-          <a:fillRef idx="3">
-            <a:schemeClr val="accent1"/>
-          </a:fillRef>
-          <a:effectRef idx="2">
-            <a:schemeClr val="accent1"/>
-          </a:effectRef>
-          <a:fontRef idx="minor">
-            <a:schemeClr val="lt1"/>
-          </a:fontRef>
-        </p:style>
-        <p:txBody>
-          <a:bodyPr rtlCol="0" anchor="ctr"/>
-          <a:lstStyle/>
-          <a:p>
-            <a:pPr algn="ctr"/>
-          </a:p>
-        </p:txBody>
-      </p:sp>
-      <p:sp>
-        <p:nvSpPr>
-          <p:cNvPr id="48" name="TextBox 47"/>
-          <p:cNvSpPr txBox="1"/>
-          <p:nvPr/>
-        </p:nvSpPr>
-        <p:spPr>
-          <a:xfrm>
-            <a:off x="4069080" y="5184648"/>
-            <a:ext cx="384048" cy="100584"/>
-          </a:xfrm>
-          <a:prstGeom prst="rect">
-            <a:avLst/>
-          </a:prstGeom>
-          <a:noFill/>
-        </p:spPr>
-        <p:txBody>
-          <a:bodyPr wrap="square">
-            <a:spAutoFit/>
-          </a:bodyPr>
-          <a:lstStyle/>
-          <a:p>
-            <a:pPr algn="ctr"/>
-            <a:r>
-              <a:rPr sz="800" b="1" i="0">
-                <a:solidFill>
-                  <a:srgbClr val="FFFFFF"/>
-                </a:solidFill>
-                <a:latin typeface="Aptos"/>
-              </a:rPr>
-              <a:t>3</a:t>
-            </a:r>
-          </a:p>
-        </p:txBody>
-      </p:sp>
-      <p:sp>
-        <p:nvSpPr>
-          <p:cNvPr id="49" name="TextBox 48"/>
-          <p:cNvSpPr txBox="1"/>
-          <p:nvPr/>
-        </p:nvSpPr>
-        <p:spPr>
-          <a:xfrm>
-            <a:off x="4544568" y="5001768"/>
-            <a:ext cx="1097280" cy="219456"/>
-          </a:xfrm>
-          <a:prstGeom prst="rect">
-            <a:avLst/>
-          </a:prstGeom>
-          <a:noFill/>
-        </p:spPr>
-        <p:txBody>
-          <a:bodyPr wrap="square">
-            <a:spAutoFit/>
-          </a:bodyPr>
-          <a:lstStyle/>
-          <a:p>
-            <a:r>
-              <a:rPr sz="1100" b="1" i="0">
-                <a:solidFill>
-                  <a:srgbClr val="232D37"/>
-                </a:solidFill>
-                <a:latin typeface="Aptos"/>
-              </a:rPr>
-              <a:t>Survey</a:t>
-            </a:r>
-          </a:p>
-        </p:txBody>
-      </p:sp>
-      <p:sp>
-        <p:nvSpPr>
-          <p:cNvPr id="50" name="TextBox 49"/>
-          <p:cNvSpPr txBox="1"/>
-          <p:nvPr/>
-        </p:nvSpPr>
-        <p:spPr>
-          <a:xfrm>
-            <a:off x="4544568" y="5276088"/>
-            <a:ext cx="1188720" cy="219456"/>
-          </a:xfrm>
-          <a:prstGeom prst="rect">
-            <a:avLst/>
-          </a:prstGeom>
-          <a:noFill/>
-        </p:spPr>
-        <p:txBody>
-          <a:bodyPr wrap="square">
-            <a:spAutoFit/>
-          </a:bodyPr>
-          <a:lstStyle/>
-          <a:p>
-            <a:r>
-              <a:rPr sz="750" b="0" i="0">
-                <a:solidFill>
-                  <a:srgbClr val="5A6973"/>
-                </a:solidFill>
-                <a:latin typeface="Aptos"/>
-              </a:rPr>
-              <a:t>data before design</a:t>
-            </a:r>
-          </a:p>
-        </p:txBody>
-      </p:sp>
-      <p:sp>
-        <p:nvSpPr>
-          <p:cNvPr id="51" name="TextBox 50"/>
-          <p:cNvSpPr txBox="1"/>
-          <p:nvPr/>
-        </p:nvSpPr>
-        <p:spPr>
-          <a:xfrm>
-            <a:off x="594360" y="6446520"/>
-            <a:ext cx="7315200" cy="201168"/>
-          </a:xfrm>
-          <a:prstGeom prst="rect">
-            <a:avLst/>
-          </a:prstGeom>
-          <a:noFill/>
-        </p:spPr>
-        <p:txBody>
-          <a:bodyPr wrap="square">
-            <a:spAutoFit/>
-          </a:bodyPr>
-          <a:lstStyle/>
-          <a:p>
-            <a:r>
-              <a:rPr sz="900" b="0" i="0">
+            <a:off x="502920" y="6473952"/>
+            <a:ext cx="7315200" cy="182880"/>
+          </a:xfrm>
+          <a:prstGeom prst="rect">
+            <a:avLst/>
+          </a:prstGeom>
+          <a:noFill/>
+        </p:spPr>
+        <p:txBody>
+          <a:bodyPr wrap="square">
+            <a:spAutoFit/>
+          </a:bodyPr>
+          <a:lstStyle/>
+          <a:p>
+            <a:r>
+              <a:rPr sz="850" b="0">
                 <a:solidFill>
                   <a:srgbClr val="78828C"/>
                 </a:solidFill>
@@ -4977,14 +3359,14 @@
       </p:sp>
       <p:sp>
         <p:nvSpPr>
-          <p:cNvPr id="52" name="TextBox 51"/>
-          <p:cNvSpPr txBox="1"/>
-          <p:nvPr/>
-        </p:nvSpPr>
-        <p:spPr>
-          <a:xfrm>
-            <a:off x="11292840" y="6446520"/>
-            <a:ext cx="502920" cy="201168"/>
+          <p:cNvPr id="9" name="TextBox 8"/>
+          <p:cNvSpPr txBox="1"/>
+          <p:nvPr/>
+        </p:nvSpPr>
+        <p:spPr>
+          <a:xfrm>
+            <a:off x="11292840" y="6473952"/>
+            <a:ext cx="502920" cy="182880"/>
           </a:xfrm>
           <a:prstGeom prst="rect">
             <a:avLst/>
@@ -4999,7 +3381,7 @@
           <a:p>
             <a:pPr algn="r"/>
             <a:r>
-              <a:rPr sz="900" b="0" i="0">
+              <a:rPr sz="850" b="0">
                 <a:solidFill>
                   <a:srgbClr val="78828C"/>
                 </a:solidFill>

</xml_diff>

<commit_message>
Use comparison infographic on topic 1.1 slide 2
</commit_message>
<xml_diff>
--- a/05_Outputs/Air Conditioning/English Slides/Air Con Chapter 1 Topic 1.1 - Visual Lecture Deck CLEAN with TA Figures.pptx
+++ b/05_Outputs/Air Conditioning/English Slides/Air Con Chapter 1 Topic 1.1 - Visual Lecture Deck CLEAN with TA Figures.pptx
@@ -7736,16 +7736,83 @@
         <p:nvPr/>
       </p:nvGrpSpPr>
       <p:grpSpPr/>
-      <p:sp>
-        <p:nvSpPr>
-          <p:cNvPr id="2" name="Rectangle 1"/>
+      <p:pic>
+        <p:nvPicPr>
+          <p:cNvPr id="2" name="Picture 1" descr="cooling-only-vs-air-conditioning-infographic.png"/>
+          <p:cNvPicPr>
+            <a:picLocks noChangeAspect="1"/>
+          </p:cNvPicPr>
+          <p:nvPr/>
+        </p:nvPicPr>
+        <p:blipFill>
+          <a:blip r:embed="rId2"/>
+          <a:stretch>
+            <a:fillRect/>
+          </a:stretch>
+        </p:blipFill>
+        <p:spPr>
+          <a:xfrm>
+            <a:off x="772159" y="758952"/>
+            <a:ext cx="10647680" cy="5989320"/>
+          </a:xfrm>
+          <a:prstGeom prst="rect">
+            <a:avLst/>
+          </a:prstGeom>
+        </p:spPr>
+      </p:pic>
+      <p:sp>
+        <p:nvSpPr>
+          <p:cNvPr id="3" name="Rectangle 2"/>
           <p:cNvSpPr/>
           <p:nvPr/>
         </p:nvSpPr>
         <p:spPr>
           <a:xfrm>
             <a:off x="0" y="0"/>
-            <a:ext cx="12191999" cy="201168"/>
+            <a:ext cx="12191999" cy="749808"/>
+          </a:xfrm>
+          <a:prstGeom prst="rect">
+            <a:avLst/>
+          </a:prstGeom>
+          <a:solidFill>
+            <a:srgbClr val="F8FAFC"/>
+          </a:solidFill>
+          <a:ln>
+            <a:noFill/>
+          </a:ln>
+        </p:spPr>
+        <p:style>
+          <a:lnRef idx="1">
+            <a:schemeClr val="accent1"/>
+          </a:lnRef>
+          <a:fillRef idx="3">
+            <a:schemeClr val="accent1"/>
+          </a:fillRef>
+          <a:effectRef idx="2">
+            <a:schemeClr val="accent1"/>
+          </a:effectRef>
+          <a:fontRef idx="minor">
+            <a:schemeClr val="lt1"/>
+          </a:fontRef>
+        </p:style>
+        <p:txBody>
+          <a:bodyPr rtlCol="0" anchor="ctr"/>
+          <a:lstStyle/>
+          <a:p>
+            <a:pPr algn="ctr"/>
+          </a:p>
+        </p:txBody>
+      </p:sp>
+      <p:sp>
+        <p:nvSpPr>
+          <p:cNvPr id="4" name="Rectangle 3"/>
+          <p:cNvSpPr/>
+          <p:nvPr/>
+        </p:nvSpPr>
+        <p:spPr>
+          <a:xfrm>
+            <a:off x="0" y="0"/>
+            <a:ext cx="12191999" cy="164592"/>
           </a:xfrm>
           <a:prstGeom prst="rect">
             <a:avLst/>
@@ -7781,62 +7848,62 @@
       </p:sp>
       <p:sp>
         <p:nvSpPr>
-          <p:cNvPr id="3" name="TextBox 2"/>
-          <p:cNvSpPr txBox="1"/>
-          <p:nvPr/>
-        </p:nvSpPr>
-        <p:spPr>
-          <a:xfrm>
-            <a:off x="502920" y="457200"/>
-            <a:ext cx="11064240" cy="640080"/>
-          </a:xfrm>
-          <a:prstGeom prst="rect">
-            <a:avLst/>
-          </a:prstGeom>
-          <a:noFill/>
-        </p:spPr>
-        <p:txBody>
-          <a:bodyPr wrap="square">
-            <a:spAutoFit/>
-          </a:bodyPr>
-          <a:lstStyle/>
-          <a:p>
-            <a:r>
-              <a:rPr sz="3000" b="1" i="0">
+          <p:cNvPr id="5" name="TextBox 4"/>
+          <p:cNvSpPr txBox="1"/>
+          <p:nvPr/>
+        </p:nvSpPr>
+        <p:spPr>
+          <a:xfrm>
+            <a:off x="502920" y="256032"/>
+            <a:ext cx="5394960" cy="274320"/>
+          </a:xfrm>
+          <a:prstGeom prst="rect">
+            <a:avLst/>
+          </a:prstGeom>
+          <a:noFill/>
+        </p:spPr>
+        <p:txBody>
+          <a:bodyPr wrap="square">
+            <a:spAutoFit/>
+          </a:bodyPr>
+          <a:lstStyle/>
+          <a:p>
+            <a:r>
+              <a:rPr sz="1200" b="1">
                 <a:solidFill>
                   <a:srgbClr val="11374B"/>
                 </a:solidFill>
                 <a:latin typeface="Aptos"/>
               </a:rPr>
-              <a:t>Cooling alone is not air conditioning</a:t>
-            </a:r>
-          </a:p>
-        </p:txBody>
-      </p:sp>
-      <p:sp>
-        <p:nvSpPr>
-          <p:cNvPr id="4" name="TextBox 3"/>
-          <p:cNvSpPr txBox="1"/>
-          <p:nvPr/>
-        </p:nvSpPr>
-        <p:spPr>
-          <a:xfrm>
-            <a:off x="530352" y="1060704"/>
-            <a:ext cx="10972800" cy="365760"/>
-          </a:xfrm>
-          <a:prstGeom prst="rect">
-            <a:avLst/>
-          </a:prstGeom>
-          <a:noFill/>
-        </p:spPr>
-        <p:txBody>
-          <a:bodyPr wrap="square">
-            <a:spAutoFit/>
-          </a:bodyPr>
-          <a:lstStyle/>
-          <a:p>
-            <a:r>
-              <a:rPr sz="1400" b="0" i="0">
+              <a:t>1.1 | Cooling only is not air conditioning</a:t>
+            </a:r>
+          </a:p>
+        </p:txBody>
+      </p:sp>
+      <p:sp>
+        <p:nvSpPr>
+          <p:cNvPr id="6" name="TextBox 5"/>
+          <p:cNvSpPr txBox="1"/>
+          <p:nvPr/>
+        </p:nvSpPr>
+        <p:spPr>
+          <a:xfrm>
+            <a:off x="502920" y="475488"/>
+            <a:ext cx="6766560" cy="256032"/>
+          </a:xfrm>
+          <a:prstGeom prst="rect">
+            <a:avLst/>
+          </a:prstGeom>
+          <a:noFill/>
+        </p:spPr>
+        <p:txBody>
+          <a:bodyPr wrap="square">
+            <a:spAutoFit/>
+          </a:bodyPr>
+          <a:lstStyle/>
+          <a:p>
+            <a:r>
+              <a:rPr sz="1150" b="0">
                 <a:solidFill>
                   <a:srgbClr val="5A6973"/>
                 </a:solidFill>
@@ -7849,14 +7916,48 @@
       </p:sp>
       <p:sp>
         <p:nvSpPr>
-          <p:cNvPr id="5" name="TextBox 4"/>
-          <p:cNvSpPr txBox="1"/>
-          <p:nvPr/>
-        </p:nvSpPr>
-        <p:spPr>
-          <a:xfrm>
-            <a:off x="11292840" y="502920"/>
-            <a:ext cx="548640" cy="274320"/>
+          <p:cNvPr id="7" name="TextBox 6"/>
+          <p:cNvSpPr txBox="1"/>
+          <p:nvPr/>
+        </p:nvSpPr>
+        <p:spPr>
+          <a:xfrm>
+            <a:off x="502920" y="6473952"/>
+            <a:ext cx="7315200" cy="182880"/>
+          </a:xfrm>
+          <a:prstGeom prst="rect">
+            <a:avLst/>
+          </a:prstGeom>
+          <a:noFill/>
+        </p:spPr>
+        <p:txBody>
+          <a:bodyPr wrap="square">
+            <a:spAutoFit/>
+          </a:bodyPr>
+          <a:lstStyle/>
+          <a:p>
+            <a:r>
+              <a:rPr sz="850" b="0">
+                <a:solidFill>
+                  <a:srgbClr val="78828C"/>
+                </a:solidFill>
+                <a:latin typeface="Aptos"/>
+              </a:rPr>
+              <a:t>Air Conditioning · Chapter 1 · Topic 1.1</a:t>
+            </a:r>
+          </a:p>
+        </p:txBody>
+      </p:sp>
+      <p:sp>
+        <p:nvSpPr>
+          <p:cNvPr id="8" name="TextBox 7"/>
+          <p:cNvSpPr txBox="1"/>
+          <p:nvPr/>
+        </p:nvSpPr>
+        <p:spPr>
+          <a:xfrm>
+            <a:off x="11292840" y="6473952"/>
+            <a:ext cx="502920" cy="182880"/>
           </a:xfrm>
           <a:prstGeom prst="rect">
             <a:avLst/>
@@ -7871,669 +7972,13 @@
           <a:p>
             <a:pPr algn="r"/>
             <a:r>
-              <a:rPr sz="1100" b="0" i="0">
+              <a:rPr sz="850" b="0">
                 <a:solidFill>
                   <a:srgbClr val="78828C"/>
                 </a:solidFill>
                 <a:latin typeface="Aptos"/>
               </a:rPr>
               <a:t>2</a:t>
-            </a:r>
-          </a:p>
-        </p:txBody>
-      </p:sp>
-      <p:sp>
-        <p:nvSpPr>
-          <p:cNvPr id="6" name="TextBox 5"/>
-          <p:cNvSpPr txBox="1"/>
-          <p:nvPr/>
-        </p:nvSpPr>
-        <p:spPr>
-          <a:xfrm>
-            <a:off x="365760" y="6446520"/>
-            <a:ext cx="8229600" cy="228600"/>
-          </a:xfrm>
-          <a:prstGeom prst="rect">
-            <a:avLst/>
-          </a:prstGeom>
-          <a:noFill/>
-        </p:spPr>
-        <p:txBody>
-          <a:bodyPr wrap="square">
-            <a:spAutoFit/>
-          </a:bodyPr>
-          <a:lstStyle/>
-          <a:p>
-            <a:r>
-              <a:rPr sz="900" b="0" i="0">
-                <a:solidFill>
-                  <a:srgbClr val="78828C"/>
-                </a:solidFill>
-                <a:latin typeface="Aptos"/>
-              </a:rPr>
-              <a:t>Air Conditioning · Chapter 1 · Topic 1.1</a:t>
-            </a:r>
-          </a:p>
-        </p:txBody>
-      </p:sp>
-      <p:sp>
-        <p:nvSpPr>
-          <p:cNvPr id="7" name="TextBox 6"/>
-          <p:cNvSpPr txBox="1"/>
-          <p:nvPr/>
-        </p:nvSpPr>
-        <p:spPr>
-          <a:xfrm>
-            <a:off x="11292840" y="6446520"/>
-            <a:ext cx="502920" cy="228600"/>
-          </a:xfrm>
-          <a:prstGeom prst="rect">
-            <a:avLst/>
-          </a:prstGeom>
-          <a:noFill/>
-        </p:spPr>
-        <p:txBody>
-          <a:bodyPr wrap="square">
-            <a:spAutoFit/>
-          </a:bodyPr>
-          <a:lstStyle/>
-          <a:p>
-            <a:pPr algn="r"/>
-            <a:r>
-              <a:rPr sz="900" b="0" i="0">
-                <a:solidFill>
-                  <a:srgbClr val="78828C"/>
-                </a:solidFill>
-                <a:latin typeface="Aptos"/>
-              </a:rPr>
-              <a:t>2</a:t>
-            </a:r>
-          </a:p>
-        </p:txBody>
-      </p:sp>
-      <p:sp>
-        <p:nvSpPr>
-          <p:cNvPr id="8" name="Rounded Rectangle 7"/>
-          <p:cNvSpPr/>
-          <p:nvPr/>
-        </p:nvSpPr>
-        <p:spPr>
-          <a:xfrm>
-            <a:off x="731520" y="1691640"/>
-            <a:ext cx="5166360" cy="4343400"/>
-          </a:xfrm>
-          <a:prstGeom prst="roundRect">
-            <a:avLst/>
-          </a:prstGeom>
-          <a:solidFill>
-            <a:srgbClr val="FFFFFF"/>
-          </a:solidFill>
-          <a:ln w="12700">
-            <a:solidFill>
-              <a:srgbClr val="DCE2E8"/>
-            </a:solidFill>
-          </a:ln>
-        </p:spPr>
-        <p:style>
-          <a:lnRef idx="1">
-            <a:schemeClr val="accent1"/>
-          </a:lnRef>
-          <a:fillRef idx="3">
-            <a:schemeClr val="accent1"/>
-          </a:fillRef>
-          <a:effectRef idx="2">
-            <a:schemeClr val="accent1"/>
-          </a:effectRef>
-          <a:fontRef idx="minor">
-            <a:schemeClr val="lt1"/>
-          </a:fontRef>
-        </p:style>
-        <p:txBody>
-          <a:bodyPr rtlCol="0" anchor="ctr"/>
-          <a:lstStyle/>
-          <a:p>
-            <a:pPr algn="ctr"/>
-          </a:p>
-        </p:txBody>
-      </p:sp>
-      <p:sp>
-        <p:nvSpPr>
-          <p:cNvPr id="9" name="Rounded Rectangle 8"/>
-          <p:cNvSpPr/>
-          <p:nvPr/>
-        </p:nvSpPr>
-        <p:spPr>
-          <a:xfrm>
-            <a:off x="6309360" y="1691640"/>
-            <a:ext cx="5166360" cy="4343400"/>
-          </a:xfrm>
-          <a:prstGeom prst="roundRect">
-            <a:avLst/>
-          </a:prstGeom>
-          <a:solidFill>
-            <a:srgbClr val="FFFFFF"/>
-          </a:solidFill>
-          <a:ln w="12700">
-            <a:solidFill>
-              <a:srgbClr val="DCE2E8"/>
-            </a:solidFill>
-          </a:ln>
-        </p:spPr>
-        <p:style>
-          <a:lnRef idx="1">
-            <a:schemeClr val="accent1"/>
-          </a:lnRef>
-          <a:fillRef idx="3">
-            <a:schemeClr val="accent1"/>
-          </a:fillRef>
-          <a:effectRef idx="2">
-            <a:schemeClr val="accent1"/>
-          </a:effectRef>
-          <a:fontRef idx="minor">
-            <a:schemeClr val="lt1"/>
-          </a:fontRef>
-        </p:style>
-        <p:txBody>
-          <a:bodyPr rtlCol="0" anchor="ctr"/>
-          <a:lstStyle/>
-          <a:p>
-            <a:pPr algn="ctr"/>
-          </a:p>
-        </p:txBody>
-      </p:sp>
-      <p:sp>
-        <p:nvSpPr>
-          <p:cNvPr id="10" name="TextBox 9"/>
-          <p:cNvSpPr txBox="1"/>
-          <p:nvPr/>
-        </p:nvSpPr>
-        <p:spPr>
-          <a:xfrm>
-            <a:off x="1051560" y="1938528"/>
-            <a:ext cx="4480560" cy="320040"/>
-          </a:xfrm>
-          <a:prstGeom prst="rect">
-            <a:avLst/>
-          </a:prstGeom>
-          <a:noFill/>
-        </p:spPr>
-        <p:txBody>
-          <a:bodyPr wrap="square">
-            <a:spAutoFit/>
-          </a:bodyPr>
-          <a:lstStyle/>
-          <a:p>
-            <a:pPr algn="ctr"/>
-            <a:r>
-              <a:rPr sz="2200" b="1" i="0">
-                <a:solidFill>
-                  <a:srgbClr val="457B9D"/>
-                </a:solidFill>
-                <a:latin typeface="Aptos"/>
-              </a:rPr>
-              <a:t>Cooling only</a:t>
-            </a:r>
-          </a:p>
-        </p:txBody>
-      </p:sp>
-      <p:sp>
-        <p:nvSpPr>
-          <p:cNvPr id="11" name="TextBox 10"/>
-          <p:cNvSpPr txBox="1"/>
-          <p:nvPr/>
-        </p:nvSpPr>
-        <p:spPr>
-          <a:xfrm>
-            <a:off x="6629400" y="1938528"/>
-            <a:ext cx="4480560" cy="320040"/>
-          </a:xfrm>
-          <a:prstGeom prst="rect">
-            <a:avLst/>
-          </a:prstGeom>
-          <a:noFill/>
-        </p:spPr>
-        <p:txBody>
-          <a:bodyPr wrap="square">
-            <a:spAutoFit/>
-          </a:bodyPr>
-          <a:lstStyle/>
-          <a:p>
-            <a:pPr algn="ctr"/>
-            <a:r>
-              <a:rPr sz="2200" b="1" i="0">
-                <a:solidFill>
-                  <a:srgbClr val="2A9D8F"/>
-                </a:solidFill>
-                <a:latin typeface="Aptos"/>
-              </a:rPr>
-              <a:t>Air conditioning</a:t>
-            </a:r>
-          </a:p>
-        </p:txBody>
-      </p:sp>
-      <p:sp>
-        <p:nvSpPr>
-          <p:cNvPr id="12" name="Down Arrow 11"/>
-          <p:cNvSpPr/>
-          <p:nvPr/>
-        </p:nvSpPr>
-        <p:spPr>
-          <a:xfrm>
-            <a:off x="2697480" y="2697480"/>
-            <a:ext cx="1143000" cy="1143000"/>
-          </a:xfrm>
-          <a:prstGeom prst="downArrow">
-            <a:avLst/>
-          </a:prstGeom>
-          <a:solidFill>
-            <a:srgbClr val="457B9D"/>
-          </a:solidFill>
-          <a:ln>
-            <a:noFill/>
-          </a:ln>
-        </p:spPr>
-        <p:style>
-          <a:lnRef idx="1">
-            <a:schemeClr val="accent1"/>
-          </a:lnRef>
-          <a:fillRef idx="3">
-            <a:schemeClr val="accent1"/>
-          </a:fillRef>
-          <a:effectRef idx="2">
-            <a:schemeClr val="accent1"/>
-          </a:effectRef>
-          <a:fontRef idx="minor">
-            <a:schemeClr val="lt1"/>
-          </a:fontRef>
-        </p:style>
-        <p:txBody>
-          <a:bodyPr rtlCol="0" anchor="ctr"/>
-          <a:lstStyle/>
-          <a:p>
-            <a:pPr algn="ctr"/>
-          </a:p>
-        </p:txBody>
-      </p:sp>
-      <p:sp>
-        <p:nvSpPr>
-          <p:cNvPr id="13" name="TextBox 12"/>
-          <p:cNvSpPr txBox="1"/>
-          <p:nvPr/>
-        </p:nvSpPr>
-        <p:spPr>
-          <a:xfrm>
-            <a:off x="1234440" y="4160520"/>
-            <a:ext cx="4160520" cy="640080"/>
-          </a:xfrm>
-          <a:prstGeom prst="rect">
-            <a:avLst/>
-          </a:prstGeom>
-          <a:noFill/>
-        </p:spPr>
-        <p:txBody>
-          <a:bodyPr wrap="square">
-            <a:spAutoFit/>
-          </a:bodyPr>
-          <a:lstStyle/>
-          <a:p>
-            <a:pPr algn="ctr"/>
-            <a:r>
-              <a:rPr sz="1900" b="1" i="0">
-                <a:solidFill>
-                  <a:srgbClr val="232D37"/>
-                </a:solidFill>
-                <a:latin typeface="Aptos"/>
-              </a:rPr>
-              <a:t>One variable:
-lower air temperature</a:t>
-            </a:r>
-          </a:p>
-        </p:txBody>
-      </p:sp>
-      <p:sp>
-        <p:nvSpPr>
-          <p:cNvPr id="14" name="Oval 13"/>
-          <p:cNvSpPr/>
-          <p:nvPr/>
-        </p:nvSpPr>
-        <p:spPr>
-          <a:xfrm>
-            <a:off x="6995160" y="2743200"/>
-            <a:ext cx="731520" cy="731520"/>
-          </a:xfrm>
-          <a:prstGeom prst="ellipse">
-            <a:avLst/>
-          </a:prstGeom>
-          <a:solidFill>
-            <a:srgbClr val="E76F51"/>
-          </a:solidFill>
-          <a:ln>
-            <a:noFill/>
-          </a:ln>
-        </p:spPr>
-        <p:style>
-          <a:lnRef idx="1">
-            <a:schemeClr val="accent1"/>
-          </a:lnRef>
-          <a:fillRef idx="3">
-            <a:schemeClr val="accent1"/>
-          </a:fillRef>
-          <a:effectRef idx="2">
-            <a:schemeClr val="accent1"/>
-          </a:effectRef>
-          <a:fontRef idx="minor">
-            <a:schemeClr val="lt1"/>
-          </a:fontRef>
-        </p:style>
-        <p:txBody>
-          <a:bodyPr rtlCol="0" anchor="ctr"/>
-          <a:lstStyle/>
-          <a:p>
-            <a:pPr algn="ctr"/>
-          </a:p>
-        </p:txBody>
-      </p:sp>
-      <p:sp>
-        <p:nvSpPr>
-          <p:cNvPr id="15" name="TextBox 14"/>
-          <p:cNvSpPr txBox="1"/>
-          <p:nvPr/>
-        </p:nvSpPr>
-        <p:spPr>
-          <a:xfrm>
-            <a:off x="6995160" y="2971800"/>
-            <a:ext cx="731520" cy="182880"/>
-          </a:xfrm>
-          <a:prstGeom prst="rect">
-            <a:avLst/>
-          </a:prstGeom>
-          <a:noFill/>
-        </p:spPr>
-        <p:txBody>
-          <a:bodyPr wrap="square">
-            <a:spAutoFit/>
-          </a:bodyPr>
-          <a:lstStyle/>
-          <a:p>
-            <a:pPr algn="ctr"/>
-            <a:r>
-              <a:rPr sz="1000" b="1" i="0">
-                <a:solidFill>
-                  <a:srgbClr val="FFFFFF"/>
-                </a:solidFill>
-                <a:latin typeface="Aptos"/>
-              </a:rPr>
-              <a:t>T</a:t>
-            </a:r>
-          </a:p>
-        </p:txBody>
-      </p:sp>
-      <p:sp>
-        <p:nvSpPr>
-          <p:cNvPr id="16" name="Oval 15"/>
-          <p:cNvSpPr/>
-          <p:nvPr/>
-        </p:nvSpPr>
-        <p:spPr>
-          <a:xfrm>
-            <a:off x="7955280" y="2743200"/>
-            <a:ext cx="731520" cy="731520"/>
-          </a:xfrm>
-          <a:prstGeom prst="ellipse">
-            <a:avLst/>
-          </a:prstGeom>
-          <a:solidFill>
-            <a:srgbClr val="457B9D"/>
-          </a:solidFill>
-          <a:ln>
-            <a:noFill/>
-          </a:ln>
-        </p:spPr>
-        <p:style>
-          <a:lnRef idx="1">
-            <a:schemeClr val="accent1"/>
-          </a:lnRef>
-          <a:fillRef idx="3">
-            <a:schemeClr val="accent1"/>
-          </a:fillRef>
-          <a:effectRef idx="2">
-            <a:schemeClr val="accent1"/>
-          </a:effectRef>
-          <a:fontRef idx="minor">
-            <a:schemeClr val="lt1"/>
-          </a:fontRef>
-        </p:style>
-        <p:txBody>
-          <a:bodyPr rtlCol="0" anchor="ctr"/>
-          <a:lstStyle/>
-          <a:p>
-            <a:pPr algn="ctr"/>
-          </a:p>
-        </p:txBody>
-      </p:sp>
-      <p:sp>
-        <p:nvSpPr>
-          <p:cNvPr id="17" name="TextBox 16"/>
-          <p:cNvSpPr txBox="1"/>
-          <p:nvPr/>
-        </p:nvSpPr>
-        <p:spPr>
-          <a:xfrm>
-            <a:off x="7955280" y="2971800"/>
-            <a:ext cx="731520" cy="182880"/>
-          </a:xfrm>
-          <a:prstGeom prst="rect">
-            <a:avLst/>
-          </a:prstGeom>
-          <a:noFill/>
-        </p:spPr>
-        <p:txBody>
-          <a:bodyPr wrap="square">
-            <a:spAutoFit/>
-          </a:bodyPr>
-          <a:lstStyle/>
-          <a:p>
-            <a:pPr algn="ctr"/>
-            <a:r>
-              <a:rPr sz="1000" b="1" i="0">
-                <a:solidFill>
-                  <a:srgbClr val="FFFFFF"/>
-                </a:solidFill>
-                <a:latin typeface="Aptos"/>
-              </a:rPr>
-              <a:t>RH</a:t>
-            </a:r>
-          </a:p>
-        </p:txBody>
-      </p:sp>
-      <p:sp>
-        <p:nvSpPr>
-          <p:cNvPr id="18" name="Oval 17"/>
-          <p:cNvSpPr/>
-          <p:nvPr/>
-        </p:nvSpPr>
-        <p:spPr>
-          <a:xfrm>
-            <a:off x="8915400" y="2743200"/>
-            <a:ext cx="731520" cy="731520"/>
-          </a:xfrm>
-          <a:prstGeom prst="ellipse">
-            <a:avLst/>
-          </a:prstGeom>
-          <a:solidFill>
-            <a:srgbClr val="2A9D8F"/>
-          </a:solidFill>
-          <a:ln>
-            <a:noFill/>
-          </a:ln>
-        </p:spPr>
-        <p:style>
-          <a:lnRef idx="1">
-            <a:schemeClr val="accent1"/>
-          </a:lnRef>
-          <a:fillRef idx="3">
-            <a:schemeClr val="accent1"/>
-          </a:fillRef>
-          <a:effectRef idx="2">
-            <a:schemeClr val="accent1"/>
-          </a:effectRef>
-          <a:fontRef idx="minor">
-            <a:schemeClr val="lt1"/>
-          </a:fontRef>
-        </p:style>
-        <p:txBody>
-          <a:bodyPr rtlCol="0" anchor="ctr"/>
-          <a:lstStyle/>
-          <a:p>
-            <a:pPr algn="ctr"/>
-          </a:p>
-        </p:txBody>
-      </p:sp>
-      <p:sp>
-        <p:nvSpPr>
-          <p:cNvPr id="19" name="TextBox 18"/>
-          <p:cNvSpPr txBox="1"/>
-          <p:nvPr/>
-        </p:nvSpPr>
-        <p:spPr>
-          <a:xfrm>
-            <a:off x="8915400" y="2971800"/>
-            <a:ext cx="731520" cy="182880"/>
-          </a:xfrm>
-          <a:prstGeom prst="rect">
-            <a:avLst/>
-          </a:prstGeom>
-          <a:noFill/>
-        </p:spPr>
-        <p:txBody>
-          <a:bodyPr wrap="square">
-            <a:spAutoFit/>
-          </a:bodyPr>
-          <a:lstStyle/>
-          <a:p>
-            <a:pPr algn="ctr"/>
-            <a:r>
-              <a:rPr sz="1000" b="1" i="0">
-                <a:solidFill>
-                  <a:srgbClr val="FFFFFF"/>
-                </a:solidFill>
-                <a:latin typeface="Aptos"/>
-              </a:rPr>
-              <a:t>Air</a:t>
-            </a:r>
-          </a:p>
-        </p:txBody>
-      </p:sp>
-      <p:sp>
-        <p:nvSpPr>
-          <p:cNvPr id="20" name="Oval 19"/>
-          <p:cNvSpPr/>
-          <p:nvPr/>
-        </p:nvSpPr>
-        <p:spPr>
-          <a:xfrm>
-            <a:off x="9875520" y="2743200"/>
-            <a:ext cx="731520" cy="731520"/>
-          </a:xfrm>
-          <a:prstGeom prst="ellipse">
-            <a:avLst/>
-          </a:prstGeom>
-          <a:solidFill>
-            <a:srgbClr val="4CAF50"/>
-          </a:solidFill>
-          <a:ln>
-            <a:noFill/>
-          </a:ln>
-        </p:spPr>
-        <p:style>
-          <a:lnRef idx="1">
-            <a:schemeClr val="accent1"/>
-          </a:lnRef>
-          <a:fillRef idx="3">
-            <a:schemeClr val="accent1"/>
-          </a:fillRef>
-          <a:effectRef idx="2">
-            <a:schemeClr val="accent1"/>
-          </a:effectRef>
-          <a:fontRef idx="minor">
-            <a:schemeClr val="lt1"/>
-          </a:fontRef>
-        </p:style>
-        <p:txBody>
-          <a:bodyPr rtlCol="0" anchor="ctr"/>
-          <a:lstStyle/>
-          <a:p>
-            <a:pPr algn="ctr"/>
-          </a:p>
-        </p:txBody>
-      </p:sp>
-      <p:sp>
-        <p:nvSpPr>
-          <p:cNvPr id="21" name="TextBox 20"/>
-          <p:cNvSpPr txBox="1"/>
-          <p:nvPr/>
-        </p:nvSpPr>
-        <p:spPr>
-          <a:xfrm>
-            <a:off x="9875520" y="2971800"/>
-            <a:ext cx="731520" cy="182880"/>
-          </a:xfrm>
-          <a:prstGeom prst="rect">
-            <a:avLst/>
-          </a:prstGeom>
-          <a:noFill/>
-        </p:spPr>
-        <p:txBody>
-          <a:bodyPr wrap="square">
-            <a:spAutoFit/>
-          </a:bodyPr>
-          <a:lstStyle/>
-          <a:p>
-            <a:pPr algn="ctr"/>
-            <a:r>
-              <a:rPr sz="1000" b="1" i="0">
-                <a:solidFill>
-                  <a:srgbClr val="FFFFFF"/>
-                </a:solidFill>
-                <a:latin typeface="Aptos"/>
-              </a:rPr>
-              <a:t>Clean</a:t>
-            </a:r>
-          </a:p>
-        </p:txBody>
-      </p:sp>
-      <p:sp>
-        <p:nvSpPr>
-          <p:cNvPr id="22" name="TextBox 21"/>
-          <p:cNvSpPr txBox="1"/>
-          <p:nvPr/>
-        </p:nvSpPr>
-        <p:spPr>
-          <a:xfrm>
-            <a:off x="6903720" y="4160520"/>
-            <a:ext cx="3840480" cy="640080"/>
-          </a:xfrm>
-          <a:prstGeom prst="rect">
-            <a:avLst/>
-          </a:prstGeom>
-          <a:noFill/>
-        </p:spPr>
-        <p:txBody>
-          <a:bodyPr wrap="square">
-            <a:spAutoFit/>
-          </a:bodyPr>
-          <a:lstStyle/>
-          <a:p>
-            <a:pPr algn="ctr"/>
-            <a:r>
-              <a:rPr sz="1900" b="1" i="0">
-                <a:solidFill>
-                  <a:srgbClr val="232D37"/>
-                </a:solidFill>
-                <a:latin typeface="Aptos"/>
-              </a:rPr>
-              <a:t>Four variables:
-controlled together</a:t>
             </a:r>
           </a:p>
         </p:txBody>

</xml_diff>

<commit_message>
Restore topic 1.1 cover page layout
</commit_message>
<xml_diff>
--- a/05_Outputs/Air Conditioning/English Slides/Air Con Chapter 1 Topic 1.1 - Visual Lecture Deck CLEAN with TA Figures.pptx
+++ b/05_Outputs/Air Conditioning/English Slides/Air Con Chapter 1 Topic 1.1 - Visual Lecture Deck CLEAN with TA Figures.pptx
@@ -3110,9 +3110,888 @@
         <p:nvPr/>
       </p:nvGrpSpPr>
       <p:grpSpPr/>
+      <p:sp>
+        <p:nvSpPr>
+          <p:cNvPr id="2" name="Rectangle 1"/>
+          <p:cNvSpPr/>
+          <p:nvPr/>
+        </p:nvSpPr>
+        <p:spPr>
+          <a:xfrm>
+            <a:off x="0" y="0"/>
+            <a:ext cx="12191999" cy="201168"/>
+          </a:xfrm>
+          <a:prstGeom prst="rect">
+            <a:avLst/>
+          </a:prstGeom>
+          <a:solidFill>
+            <a:srgbClr val="11374B"/>
+          </a:solidFill>
+          <a:ln>
+            <a:noFill/>
+          </a:ln>
+        </p:spPr>
+        <p:style>
+          <a:lnRef idx="1">
+            <a:schemeClr val="accent1"/>
+          </a:lnRef>
+          <a:fillRef idx="3">
+            <a:schemeClr val="accent1"/>
+          </a:fillRef>
+          <a:effectRef idx="2">
+            <a:schemeClr val="accent1"/>
+          </a:effectRef>
+          <a:fontRef idx="minor">
+            <a:schemeClr val="lt1"/>
+          </a:fontRef>
+        </p:style>
+        <p:txBody>
+          <a:bodyPr rtlCol="0" anchor="ctr"/>
+          <a:lstStyle/>
+          <a:p>
+            <a:pPr algn="ctr"/>
+          </a:p>
+        </p:txBody>
+      </p:sp>
+      <p:sp>
+        <p:nvSpPr>
+          <p:cNvPr id="3" name="Right Triangle 2"/>
+          <p:cNvSpPr/>
+          <p:nvPr/>
+        </p:nvSpPr>
+        <p:spPr>
+          <a:xfrm>
+            <a:off x="9098280" y="201168"/>
+            <a:ext cx="3090672" cy="2176272"/>
+          </a:xfrm>
+          <a:prstGeom prst="rtTriangle">
+            <a:avLst/>
+          </a:prstGeom>
+          <a:solidFill>
+            <a:srgbClr val="E6F4F7"/>
+          </a:solidFill>
+          <a:ln>
+            <a:noFill/>
+          </a:ln>
+        </p:spPr>
+        <p:style>
+          <a:lnRef idx="1">
+            <a:schemeClr val="accent1"/>
+          </a:lnRef>
+          <a:fillRef idx="3">
+            <a:schemeClr val="accent1"/>
+          </a:fillRef>
+          <a:effectRef idx="2">
+            <a:schemeClr val="accent1"/>
+          </a:effectRef>
+          <a:fontRef idx="minor">
+            <a:schemeClr val="lt1"/>
+          </a:fontRef>
+        </p:style>
+        <p:txBody>
+          <a:bodyPr rtlCol="0" anchor="ctr"/>
+          <a:lstStyle/>
+          <a:p>
+            <a:pPr algn="ctr"/>
+          </a:p>
+        </p:txBody>
+      </p:sp>
+      <p:sp>
+        <p:nvSpPr>
+          <p:cNvPr id="4" name="Right Triangle 3"/>
+          <p:cNvSpPr/>
+          <p:nvPr/>
+        </p:nvSpPr>
+        <p:spPr>
+          <a:xfrm>
+            <a:off x="9692640" y="4434840"/>
+            <a:ext cx="2496312" cy="2423160"/>
+          </a:xfrm>
+          <a:prstGeom prst="rtTriangle">
+            <a:avLst/>
+          </a:prstGeom>
+          <a:solidFill>
+            <a:srgbClr val="FFEFE6"/>
+          </a:solidFill>
+          <a:ln>
+            <a:noFill/>
+          </a:ln>
+        </p:spPr>
+        <p:style>
+          <a:lnRef idx="1">
+            <a:schemeClr val="accent1"/>
+          </a:lnRef>
+          <a:fillRef idx="3">
+            <a:schemeClr val="accent1"/>
+          </a:fillRef>
+          <a:effectRef idx="2">
+            <a:schemeClr val="accent1"/>
+          </a:effectRef>
+          <a:fontRef idx="minor">
+            <a:schemeClr val="lt1"/>
+          </a:fontRef>
+        </p:style>
+        <p:txBody>
+          <a:bodyPr rtlCol="0" anchor="ctr"/>
+          <a:lstStyle/>
+          <a:p>
+            <a:pPr algn="ctr"/>
+          </a:p>
+        </p:txBody>
+      </p:sp>
+      <p:sp>
+        <p:nvSpPr>
+          <p:cNvPr id="5" name="TextBox 4"/>
+          <p:cNvSpPr txBox="1"/>
+          <p:nvPr/>
+        </p:nvSpPr>
+        <p:spPr>
+          <a:xfrm>
+            <a:off x="594360" y="749808"/>
+            <a:ext cx="5303520" cy="274320"/>
+          </a:xfrm>
+          <a:prstGeom prst="rect">
+            <a:avLst/>
+          </a:prstGeom>
+          <a:noFill/>
+        </p:spPr>
+        <p:txBody>
+          <a:bodyPr wrap="square">
+            <a:spAutoFit/>
+          </a:bodyPr>
+          <a:lstStyle/>
+          <a:p>
+            <a:r>
+              <a:rPr sz="1200" b="1" i="0">
+                <a:solidFill>
+                  <a:srgbClr val="2A9D8F"/>
+                </a:solidFill>
+                <a:latin typeface="Aptos"/>
+              </a:rPr>
+              <a:t>AIR CONDITIONING · CHAPTER 1</a:t>
+            </a:r>
+          </a:p>
+        </p:txBody>
+      </p:sp>
+      <p:sp>
+        <p:nvSpPr>
+          <p:cNvPr id="6" name="TextBox 5"/>
+          <p:cNvSpPr txBox="1"/>
+          <p:nvPr/>
+        </p:nvSpPr>
+        <p:spPr>
+          <a:xfrm>
+            <a:off x="594360" y="1170432"/>
+            <a:ext cx="5349240" cy="868680"/>
+          </a:xfrm>
+          <a:prstGeom prst="rect">
+            <a:avLst/>
+          </a:prstGeom>
+          <a:noFill/>
+        </p:spPr>
+        <p:txBody>
+          <a:bodyPr wrap="square">
+            <a:spAutoFit/>
+          </a:bodyPr>
+          <a:lstStyle/>
+          <a:p>
+            <a:r>
+              <a:rPr sz="3800" b="1" i="0">
+                <a:solidFill>
+                  <a:srgbClr val="11374B"/>
+                </a:solidFill>
+                <a:latin typeface="Aptos"/>
+              </a:rPr>
+              <a:t>1.1 Air
+Conditioning</a:t>
+            </a:r>
+          </a:p>
+        </p:txBody>
+      </p:sp>
+      <p:sp>
+        <p:nvSpPr>
+          <p:cNvPr id="7" name="TextBox 6"/>
+          <p:cNvSpPr txBox="1"/>
+          <p:nvPr/>
+        </p:nvSpPr>
+        <p:spPr>
+          <a:xfrm>
+            <a:off x="621792" y="2331720"/>
+            <a:ext cx="5166360" cy="365760"/>
+          </a:xfrm>
+          <a:prstGeom prst="rect">
+            <a:avLst/>
+          </a:prstGeom>
+          <a:noFill/>
+        </p:spPr>
+        <p:txBody>
+          <a:bodyPr wrap="square">
+            <a:spAutoFit/>
+          </a:bodyPr>
+          <a:lstStyle/>
+          <a:p>
+            <a:r>
+              <a:rPr sz="1800" b="0" i="0">
+                <a:solidFill>
+                  <a:srgbClr val="5A6973"/>
+                </a:solidFill>
+                <a:latin typeface="Aptos"/>
+              </a:rPr>
+              <a:t>Definition, Purpose, and Scope</a:t>
+            </a:r>
+          </a:p>
+        </p:txBody>
+      </p:sp>
+      <p:sp>
+        <p:nvSpPr>
+          <p:cNvPr id="8" name="TextBox 7"/>
+          <p:cNvSpPr txBox="1"/>
+          <p:nvPr/>
+        </p:nvSpPr>
+        <p:spPr>
+          <a:xfrm>
+            <a:off x="640080" y="2971800"/>
+            <a:ext cx="5257800" cy="777240"/>
+          </a:xfrm>
+          <a:prstGeom prst="rect">
+            <a:avLst/>
+          </a:prstGeom>
+          <a:noFill/>
+        </p:spPr>
+        <p:txBody>
+          <a:bodyPr wrap="square">
+            <a:spAutoFit/>
+          </a:bodyPr>
+          <a:lstStyle/>
+          <a:p>
+            <a:r>
+              <a:rPr sz="2000" b="1" i="0">
+                <a:solidFill>
+                  <a:srgbClr val="232D37"/>
+                </a:solidFill>
+                <a:latin typeface="Aptos"/>
+              </a:rPr>
+              <a:t>Air conditioning is not simply cooling. It is the simultaneous control of the indoor environment.</a:t>
+            </a:r>
+          </a:p>
+        </p:txBody>
+      </p:sp>
+      <p:sp>
+        <p:nvSpPr>
+          <p:cNvPr id="9" name="Rounded Rectangle 8"/>
+          <p:cNvSpPr/>
+          <p:nvPr/>
+        </p:nvSpPr>
+        <p:spPr>
+          <a:xfrm>
+            <a:off x="658368" y="4133087"/>
+            <a:ext cx="2212848" cy="393192"/>
+          </a:xfrm>
+          <a:prstGeom prst="roundRect">
+            <a:avLst/>
+          </a:prstGeom>
+          <a:solidFill>
+            <a:srgbClr val="FFFFFF"/>
+          </a:solidFill>
+          <a:ln w="12700">
+            <a:solidFill>
+              <a:srgbClr val="E76F51"/>
+            </a:solidFill>
+          </a:ln>
+        </p:spPr>
+        <p:style>
+          <a:lnRef idx="1">
+            <a:schemeClr val="accent1"/>
+          </a:lnRef>
+          <a:fillRef idx="3">
+            <a:schemeClr val="accent1"/>
+          </a:fillRef>
+          <a:effectRef idx="2">
+            <a:schemeClr val="accent1"/>
+          </a:effectRef>
+          <a:fontRef idx="minor">
+            <a:schemeClr val="lt1"/>
+          </a:fontRef>
+        </p:style>
+        <p:txBody>
+          <a:bodyPr rtlCol="0" anchor="ctr"/>
+          <a:lstStyle/>
+          <a:p>
+            <a:pPr algn="ctr"/>
+          </a:p>
+        </p:txBody>
+      </p:sp>
+      <p:sp>
+        <p:nvSpPr>
+          <p:cNvPr id="10" name="Oval 9"/>
+          <p:cNvSpPr/>
+          <p:nvPr/>
+        </p:nvSpPr>
+        <p:spPr>
+          <a:xfrm>
+            <a:off x="777240" y="4233672"/>
+            <a:ext cx="182880" cy="182880"/>
+          </a:xfrm>
+          <a:prstGeom prst="ellipse">
+            <a:avLst/>
+          </a:prstGeom>
+          <a:solidFill>
+            <a:srgbClr val="E76F51"/>
+          </a:solidFill>
+          <a:ln>
+            <a:noFill/>
+          </a:ln>
+        </p:spPr>
+        <p:style>
+          <a:lnRef idx="1">
+            <a:schemeClr val="accent1"/>
+          </a:lnRef>
+          <a:fillRef idx="3">
+            <a:schemeClr val="accent1"/>
+          </a:fillRef>
+          <a:effectRef idx="2">
+            <a:schemeClr val="accent1"/>
+          </a:effectRef>
+          <a:fontRef idx="minor">
+            <a:schemeClr val="lt1"/>
+          </a:fontRef>
+        </p:style>
+        <p:txBody>
+          <a:bodyPr rtlCol="0" anchor="ctr"/>
+          <a:lstStyle/>
+          <a:p>
+            <a:pPr algn="ctr"/>
+          </a:p>
+        </p:txBody>
+      </p:sp>
+      <p:sp>
+        <p:nvSpPr>
+          <p:cNvPr id="11" name="TextBox 10"/>
+          <p:cNvSpPr txBox="1"/>
+          <p:nvPr/>
+        </p:nvSpPr>
+        <p:spPr>
+          <a:xfrm>
+            <a:off x="1042415" y="4233672"/>
+            <a:ext cx="1664208" cy="146304"/>
+          </a:xfrm>
+          <a:prstGeom prst="rect">
+            <a:avLst/>
+          </a:prstGeom>
+          <a:noFill/>
+        </p:spPr>
+        <p:txBody>
+          <a:bodyPr wrap="square">
+            <a:spAutoFit/>
+          </a:bodyPr>
+          <a:lstStyle/>
+          <a:p>
+            <a:r>
+              <a:rPr sz="850" b="1" i="0">
+                <a:solidFill>
+                  <a:srgbClr val="E76F51"/>
+                </a:solidFill>
+                <a:latin typeface="Aptos"/>
+              </a:rPr>
+              <a:t>Temperature</a:t>
+            </a:r>
+          </a:p>
+        </p:txBody>
+      </p:sp>
+      <p:sp>
+        <p:nvSpPr>
+          <p:cNvPr id="12" name="Rounded Rectangle 11"/>
+          <p:cNvSpPr/>
+          <p:nvPr/>
+        </p:nvSpPr>
+        <p:spPr>
+          <a:xfrm>
+            <a:off x="3145536" y="4133087"/>
+            <a:ext cx="2212848" cy="393192"/>
+          </a:xfrm>
+          <a:prstGeom prst="roundRect">
+            <a:avLst/>
+          </a:prstGeom>
+          <a:solidFill>
+            <a:srgbClr val="FFFFFF"/>
+          </a:solidFill>
+          <a:ln w="12700">
+            <a:solidFill>
+              <a:srgbClr val="457B9D"/>
+            </a:solidFill>
+          </a:ln>
+        </p:spPr>
+        <p:style>
+          <a:lnRef idx="1">
+            <a:schemeClr val="accent1"/>
+          </a:lnRef>
+          <a:fillRef idx="3">
+            <a:schemeClr val="accent1"/>
+          </a:fillRef>
+          <a:effectRef idx="2">
+            <a:schemeClr val="accent1"/>
+          </a:effectRef>
+          <a:fontRef idx="minor">
+            <a:schemeClr val="lt1"/>
+          </a:fontRef>
+        </p:style>
+        <p:txBody>
+          <a:bodyPr rtlCol="0" anchor="ctr"/>
+          <a:lstStyle/>
+          <a:p>
+            <a:pPr algn="ctr"/>
+          </a:p>
+        </p:txBody>
+      </p:sp>
+      <p:sp>
+        <p:nvSpPr>
+          <p:cNvPr id="13" name="Oval 12"/>
+          <p:cNvSpPr/>
+          <p:nvPr/>
+        </p:nvSpPr>
+        <p:spPr>
+          <a:xfrm>
+            <a:off x="3264408" y="4233672"/>
+            <a:ext cx="182880" cy="182880"/>
+          </a:xfrm>
+          <a:prstGeom prst="ellipse">
+            <a:avLst/>
+          </a:prstGeom>
+          <a:solidFill>
+            <a:srgbClr val="457B9D"/>
+          </a:solidFill>
+          <a:ln>
+            <a:noFill/>
+          </a:ln>
+        </p:spPr>
+        <p:style>
+          <a:lnRef idx="1">
+            <a:schemeClr val="accent1"/>
+          </a:lnRef>
+          <a:fillRef idx="3">
+            <a:schemeClr val="accent1"/>
+          </a:fillRef>
+          <a:effectRef idx="2">
+            <a:schemeClr val="accent1"/>
+          </a:effectRef>
+          <a:fontRef idx="minor">
+            <a:schemeClr val="lt1"/>
+          </a:fontRef>
+        </p:style>
+        <p:txBody>
+          <a:bodyPr rtlCol="0" anchor="ctr"/>
+          <a:lstStyle/>
+          <a:p>
+            <a:pPr algn="ctr"/>
+          </a:p>
+        </p:txBody>
+      </p:sp>
+      <p:sp>
+        <p:nvSpPr>
+          <p:cNvPr id="14" name="TextBox 13"/>
+          <p:cNvSpPr txBox="1"/>
+          <p:nvPr/>
+        </p:nvSpPr>
+        <p:spPr>
+          <a:xfrm>
+            <a:off x="3529584" y="4233672"/>
+            <a:ext cx="1664208" cy="146304"/>
+          </a:xfrm>
+          <a:prstGeom prst="rect">
+            <a:avLst/>
+          </a:prstGeom>
+          <a:noFill/>
+        </p:spPr>
+        <p:txBody>
+          <a:bodyPr wrap="square">
+            <a:spAutoFit/>
+          </a:bodyPr>
+          <a:lstStyle/>
+          <a:p>
+            <a:r>
+              <a:rPr sz="850" b="1" i="0">
+                <a:solidFill>
+                  <a:srgbClr val="457B9D"/>
+                </a:solidFill>
+                <a:latin typeface="Aptos"/>
+              </a:rPr>
+              <a:t>Humidity</a:t>
+            </a:r>
+          </a:p>
+        </p:txBody>
+      </p:sp>
+      <p:sp>
+        <p:nvSpPr>
+          <p:cNvPr id="15" name="Rounded Rectangle 14"/>
+          <p:cNvSpPr/>
+          <p:nvPr/>
+        </p:nvSpPr>
+        <p:spPr>
+          <a:xfrm>
+            <a:off x="658368" y="4700016"/>
+            <a:ext cx="2212848" cy="393192"/>
+          </a:xfrm>
+          <a:prstGeom prst="roundRect">
+            <a:avLst/>
+          </a:prstGeom>
+          <a:solidFill>
+            <a:srgbClr val="FFFFFF"/>
+          </a:solidFill>
+          <a:ln w="12700">
+            <a:solidFill>
+              <a:srgbClr val="2A9D8F"/>
+            </a:solidFill>
+          </a:ln>
+        </p:spPr>
+        <p:style>
+          <a:lnRef idx="1">
+            <a:schemeClr val="accent1"/>
+          </a:lnRef>
+          <a:fillRef idx="3">
+            <a:schemeClr val="accent1"/>
+          </a:fillRef>
+          <a:effectRef idx="2">
+            <a:schemeClr val="accent1"/>
+          </a:effectRef>
+          <a:fontRef idx="minor">
+            <a:schemeClr val="lt1"/>
+          </a:fontRef>
+        </p:style>
+        <p:txBody>
+          <a:bodyPr rtlCol="0" anchor="ctr"/>
+          <a:lstStyle/>
+          <a:p>
+            <a:pPr algn="ctr"/>
+          </a:p>
+        </p:txBody>
+      </p:sp>
+      <p:sp>
+        <p:nvSpPr>
+          <p:cNvPr id="16" name="Oval 15"/>
+          <p:cNvSpPr/>
+          <p:nvPr/>
+        </p:nvSpPr>
+        <p:spPr>
+          <a:xfrm>
+            <a:off x="777240" y="4800600"/>
+            <a:ext cx="182880" cy="182880"/>
+          </a:xfrm>
+          <a:prstGeom prst="ellipse">
+            <a:avLst/>
+          </a:prstGeom>
+          <a:solidFill>
+            <a:srgbClr val="2A9D8F"/>
+          </a:solidFill>
+          <a:ln>
+            <a:noFill/>
+          </a:ln>
+        </p:spPr>
+        <p:style>
+          <a:lnRef idx="1">
+            <a:schemeClr val="accent1"/>
+          </a:lnRef>
+          <a:fillRef idx="3">
+            <a:schemeClr val="accent1"/>
+          </a:fillRef>
+          <a:effectRef idx="2">
+            <a:schemeClr val="accent1"/>
+          </a:effectRef>
+          <a:fontRef idx="minor">
+            <a:schemeClr val="lt1"/>
+          </a:fontRef>
+        </p:style>
+        <p:txBody>
+          <a:bodyPr rtlCol="0" anchor="ctr"/>
+          <a:lstStyle/>
+          <a:p>
+            <a:pPr algn="ctr"/>
+          </a:p>
+        </p:txBody>
+      </p:sp>
+      <p:sp>
+        <p:nvSpPr>
+          <p:cNvPr id="17" name="TextBox 16"/>
+          <p:cNvSpPr txBox="1"/>
+          <p:nvPr/>
+        </p:nvSpPr>
+        <p:spPr>
+          <a:xfrm>
+            <a:off x="1042415" y="4800600"/>
+            <a:ext cx="1664208" cy="146304"/>
+          </a:xfrm>
+          <a:prstGeom prst="rect">
+            <a:avLst/>
+          </a:prstGeom>
+          <a:noFill/>
+        </p:spPr>
+        <p:txBody>
+          <a:bodyPr wrap="square">
+            <a:spAutoFit/>
+          </a:bodyPr>
+          <a:lstStyle/>
+          <a:p>
+            <a:r>
+              <a:rPr sz="850" b="1" i="0">
+                <a:solidFill>
+                  <a:srgbClr val="2A9D8F"/>
+                </a:solidFill>
+                <a:latin typeface="Aptos"/>
+              </a:rPr>
+              <a:t>Air circulation</a:t>
+            </a:r>
+          </a:p>
+        </p:txBody>
+      </p:sp>
+      <p:sp>
+        <p:nvSpPr>
+          <p:cNvPr id="18" name="Rounded Rectangle 17"/>
+          <p:cNvSpPr/>
+          <p:nvPr/>
+        </p:nvSpPr>
+        <p:spPr>
+          <a:xfrm>
+            <a:off x="3145536" y="4700016"/>
+            <a:ext cx="2212848" cy="393192"/>
+          </a:xfrm>
+          <a:prstGeom prst="roundRect">
+            <a:avLst/>
+          </a:prstGeom>
+          <a:solidFill>
+            <a:srgbClr val="FFFFFF"/>
+          </a:solidFill>
+          <a:ln w="12700">
+            <a:solidFill>
+              <a:srgbClr val="4CAF50"/>
+            </a:solidFill>
+          </a:ln>
+        </p:spPr>
+        <p:style>
+          <a:lnRef idx="1">
+            <a:schemeClr val="accent1"/>
+          </a:lnRef>
+          <a:fillRef idx="3">
+            <a:schemeClr val="accent1"/>
+          </a:fillRef>
+          <a:effectRef idx="2">
+            <a:schemeClr val="accent1"/>
+          </a:effectRef>
+          <a:fontRef idx="minor">
+            <a:schemeClr val="lt1"/>
+          </a:fontRef>
+        </p:style>
+        <p:txBody>
+          <a:bodyPr rtlCol="0" anchor="ctr"/>
+          <a:lstStyle/>
+          <a:p>
+            <a:pPr algn="ctr"/>
+          </a:p>
+        </p:txBody>
+      </p:sp>
+      <p:sp>
+        <p:nvSpPr>
+          <p:cNvPr id="19" name="Oval 18"/>
+          <p:cNvSpPr/>
+          <p:nvPr/>
+        </p:nvSpPr>
+        <p:spPr>
+          <a:xfrm>
+            <a:off x="3264408" y="4800600"/>
+            <a:ext cx="182880" cy="182880"/>
+          </a:xfrm>
+          <a:prstGeom prst="ellipse">
+            <a:avLst/>
+          </a:prstGeom>
+          <a:solidFill>
+            <a:srgbClr val="4CAF50"/>
+          </a:solidFill>
+          <a:ln>
+            <a:noFill/>
+          </a:ln>
+        </p:spPr>
+        <p:style>
+          <a:lnRef idx="1">
+            <a:schemeClr val="accent1"/>
+          </a:lnRef>
+          <a:fillRef idx="3">
+            <a:schemeClr val="accent1"/>
+          </a:fillRef>
+          <a:effectRef idx="2">
+            <a:schemeClr val="accent1"/>
+          </a:effectRef>
+          <a:fontRef idx="minor">
+            <a:schemeClr val="lt1"/>
+          </a:fontRef>
+        </p:style>
+        <p:txBody>
+          <a:bodyPr rtlCol="0" anchor="ctr"/>
+          <a:lstStyle/>
+          <a:p>
+            <a:pPr algn="ctr"/>
+          </a:p>
+        </p:txBody>
+      </p:sp>
+      <p:sp>
+        <p:nvSpPr>
+          <p:cNvPr id="20" name="TextBox 19"/>
+          <p:cNvSpPr txBox="1"/>
+          <p:nvPr/>
+        </p:nvSpPr>
+        <p:spPr>
+          <a:xfrm>
+            <a:off x="3529584" y="4800600"/>
+            <a:ext cx="1664208" cy="146304"/>
+          </a:xfrm>
+          <a:prstGeom prst="rect">
+            <a:avLst/>
+          </a:prstGeom>
+          <a:noFill/>
+        </p:spPr>
+        <p:txBody>
+          <a:bodyPr wrap="square">
+            <a:spAutoFit/>
+          </a:bodyPr>
+          <a:lstStyle/>
+          <a:p>
+            <a:r>
+              <a:rPr sz="850" b="1" i="0">
+                <a:solidFill>
+                  <a:srgbClr val="4CAF50"/>
+                </a:solidFill>
+                <a:latin typeface="Aptos"/>
+              </a:rPr>
+              <a:t>Air cleanliness</a:t>
+            </a:r>
+          </a:p>
+        </p:txBody>
+      </p:sp>
+      <p:sp>
+        <p:nvSpPr>
+          <p:cNvPr id="21" name="Rounded Rectangle 20"/>
+          <p:cNvSpPr/>
+          <p:nvPr/>
+        </p:nvSpPr>
+        <p:spPr>
+          <a:xfrm>
+            <a:off x="640080" y="5440680"/>
+            <a:ext cx="5074920" cy="457200"/>
+          </a:xfrm>
+          <a:prstGeom prst="roundRect">
+            <a:avLst/>
+          </a:prstGeom>
+          <a:solidFill>
+            <a:srgbClr val="E6F4F7"/>
+          </a:solidFill>
+          <a:ln w="12700">
+            <a:solidFill>
+              <a:srgbClr val="B9D9E0"/>
+            </a:solidFill>
+          </a:ln>
+        </p:spPr>
+        <p:style>
+          <a:lnRef idx="1">
+            <a:schemeClr val="accent1"/>
+          </a:lnRef>
+          <a:fillRef idx="3">
+            <a:schemeClr val="accent1"/>
+          </a:fillRef>
+          <a:effectRef idx="2">
+            <a:schemeClr val="accent1"/>
+          </a:effectRef>
+          <a:fontRef idx="minor">
+            <a:schemeClr val="lt1"/>
+          </a:fontRef>
+        </p:style>
+        <p:txBody>
+          <a:bodyPr rtlCol="0" anchor="ctr"/>
+          <a:lstStyle/>
+          <a:p>
+            <a:pPr algn="ctr"/>
+          </a:p>
+        </p:txBody>
+      </p:sp>
+      <p:sp>
+        <p:nvSpPr>
+          <p:cNvPr id="22" name="TextBox 21"/>
+          <p:cNvSpPr txBox="1"/>
+          <p:nvPr/>
+        </p:nvSpPr>
+        <p:spPr>
+          <a:xfrm>
+            <a:off x="868680" y="5577840"/>
+            <a:ext cx="4617720" cy="146304"/>
+          </a:xfrm>
+          <a:prstGeom prst="rect">
+            <a:avLst/>
+          </a:prstGeom>
+          <a:noFill/>
+        </p:spPr>
+        <p:txBody>
+          <a:bodyPr wrap="square">
+            <a:spAutoFit/>
+          </a:bodyPr>
+          <a:lstStyle/>
+          <a:p>
+            <a:pPr algn="ctr"/>
+            <a:r>
+              <a:rPr sz="1050" b="1" i="0">
+                <a:solidFill>
+                  <a:srgbClr val="11374B"/>
+                </a:solidFill>
+                <a:latin typeface="Aptos"/>
+              </a:rPr>
+              <a:t>Teaching focus: cooling-mode AC for Thailand</a:t>
+            </a:r>
+          </a:p>
+        </p:txBody>
+      </p:sp>
+      <p:sp>
+        <p:nvSpPr>
+          <p:cNvPr id="23" name="Rounded Rectangle 22"/>
+          <p:cNvSpPr/>
+          <p:nvPr/>
+        </p:nvSpPr>
+        <p:spPr>
+          <a:xfrm>
+            <a:off x="6172200" y="932688"/>
+            <a:ext cx="5440680" cy="5349240"/>
+          </a:xfrm>
+          <a:prstGeom prst="roundRect">
+            <a:avLst/>
+          </a:prstGeom>
+          <a:solidFill>
+            <a:srgbClr val="FFFFFF"/>
+          </a:solidFill>
+          <a:ln w="12700">
+            <a:solidFill>
+              <a:srgbClr val="DCE2E8"/>
+            </a:solidFill>
+          </a:ln>
+        </p:spPr>
+        <p:style>
+          <a:lnRef idx="1">
+            <a:schemeClr val="accent1"/>
+          </a:lnRef>
+          <a:fillRef idx="3">
+            <a:schemeClr val="accent1"/>
+          </a:fillRef>
+          <a:effectRef idx="2">
+            <a:schemeClr val="accent1"/>
+          </a:effectRef>
+          <a:fontRef idx="minor">
+            <a:schemeClr val="lt1"/>
+          </a:fontRef>
+        </p:style>
+        <p:txBody>
+          <a:bodyPr rtlCol="0" anchor="ctr"/>
+          <a:lstStyle/>
+          <a:p>
+            <a:pPr algn="ctr"/>
+          </a:p>
+        </p:txBody>
+      </p:sp>
       <p:pic>
         <p:nvPicPr>
-          <p:cNvPr id="2" name="Picture 1" descr="conditioned-space-engineering-infographic.png"/>
+          <p:cNvPr id="24" name="Picture 23" descr="image.png"/>
           <p:cNvPicPr>
             <a:picLocks noChangeAspect="1"/>
           </p:cNvPicPr>
@@ -3126,8 +4005,8 @@
         </p:blipFill>
         <p:spPr>
           <a:xfrm>
-            <a:off x="1107556" y="941832"/>
-            <a:ext cx="9992127" cy="5623560"/>
+            <a:off x="6355080" y="2142651"/>
+            <a:ext cx="5074920" cy="2856160"/>
           </a:xfrm>
           <a:prstGeom prst="rect">
             <a:avLst/>
@@ -3136,202 +4015,13 @@
       </p:pic>
       <p:sp>
         <p:nvSpPr>
-          <p:cNvPr id="3" name="Rectangle 2"/>
-          <p:cNvSpPr/>
-          <p:nvPr/>
-        </p:nvSpPr>
-        <p:spPr>
-          <a:xfrm>
-            <a:off x="0" y="0"/>
-            <a:ext cx="12191999" cy="749808"/>
-          </a:xfrm>
-          <a:prstGeom prst="rect">
-            <a:avLst/>
-          </a:prstGeom>
-          <a:solidFill>
-            <a:srgbClr val="F8FAFC"/>
-          </a:solidFill>
-          <a:ln>
-            <a:noFill/>
-          </a:ln>
-        </p:spPr>
-        <p:style>
-          <a:lnRef idx="1">
-            <a:schemeClr val="accent1"/>
-          </a:lnRef>
-          <a:fillRef idx="3">
-            <a:schemeClr val="accent1"/>
-          </a:fillRef>
-          <a:effectRef idx="2">
-            <a:schemeClr val="accent1"/>
-          </a:effectRef>
-          <a:fontRef idx="minor">
-            <a:schemeClr val="lt1"/>
-          </a:fontRef>
-        </p:style>
-        <p:txBody>
-          <a:bodyPr rtlCol="0" anchor="ctr"/>
-          <a:lstStyle/>
-          <a:p>
-            <a:pPr algn="ctr"/>
-          </a:p>
-        </p:txBody>
-      </p:sp>
-      <p:sp>
-        <p:nvSpPr>
-          <p:cNvPr id="4" name="Rectangle 3"/>
-          <p:cNvSpPr/>
-          <p:nvPr/>
-        </p:nvSpPr>
-        <p:spPr>
-          <a:xfrm>
-            <a:off x="0" y="0"/>
-            <a:ext cx="12191999" cy="164592"/>
-          </a:xfrm>
-          <a:prstGeom prst="rect">
-            <a:avLst/>
-          </a:prstGeom>
-          <a:solidFill>
-            <a:srgbClr val="11374B"/>
-          </a:solidFill>
-          <a:ln>
-            <a:noFill/>
-          </a:ln>
-        </p:spPr>
-        <p:style>
-          <a:lnRef idx="1">
-            <a:schemeClr val="accent1"/>
-          </a:lnRef>
-          <a:fillRef idx="3">
-            <a:schemeClr val="accent1"/>
-          </a:fillRef>
-          <a:effectRef idx="2">
-            <a:schemeClr val="accent1"/>
-          </a:effectRef>
-          <a:fontRef idx="minor">
-            <a:schemeClr val="lt1"/>
-          </a:fontRef>
-        </p:style>
-        <p:txBody>
-          <a:bodyPr rtlCol="0" anchor="ctr"/>
-          <a:lstStyle/>
-          <a:p>
-            <a:pPr algn="ctr"/>
-          </a:p>
-        </p:txBody>
-      </p:sp>
-      <p:sp>
-        <p:nvSpPr>
-          <p:cNvPr id="5" name="TextBox 4"/>
-          <p:cNvSpPr txBox="1"/>
-          <p:nvPr/>
-        </p:nvSpPr>
-        <p:spPr>
-          <a:xfrm>
-            <a:off x="502920" y="256032"/>
-            <a:ext cx="5394960" cy="274320"/>
-          </a:xfrm>
-          <a:prstGeom prst="rect">
-            <a:avLst/>
-          </a:prstGeom>
-          <a:noFill/>
-        </p:spPr>
-        <p:txBody>
-          <a:bodyPr wrap="square">
-            <a:spAutoFit/>
-          </a:bodyPr>
-          <a:lstStyle/>
-          <a:p>
-            <a:r>
-              <a:rPr sz="1050" b="1">
-                <a:solidFill>
-                  <a:srgbClr val="2A9D8F"/>
-                </a:solidFill>
-                <a:latin typeface="Aptos"/>
-              </a:rPr>
-              <a:t>AIR CONDITIONING · CHAPTER 1</a:t>
-            </a:r>
-          </a:p>
-        </p:txBody>
-      </p:sp>
-      <p:sp>
-        <p:nvSpPr>
-          <p:cNvPr id="6" name="TextBox 5"/>
-          <p:cNvSpPr txBox="1"/>
-          <p:nvPr/>
-        </p:nvSpPr>
-        <p:spPr>
-          <a:xfrm>
-            <a:off x="502920" y="438912"/>
-            <a:ext cx="6035040" cy="320040"/>
-          </a:xfrm>
-          <a:prstGeom prst="rect">
-            <a:avLst/>
-          </a:prstGeom>
-          <a:noFill/>
-        </p:spPr>
-        <p:txBody>
-          <a:bodyPr wrap="square">
-            <a:spAutoFit/>
-          </a:bodyPr>
-          <a:lstStyle/>
-          <a:p>
-            <a:r>
-              <a:rPr sz="1800" b="1">
-                <a:solidFill>
-                  <a:srgbClr val="11374B"/>
-                </a:solidFill>
-                <a:latin typeface="Aptos"/>
-              </a:rPr>
-              <a:t>1.1 Air Conditioning</a:t>
-            </a:r>
-          </a:p>
-        </p:txBody>
-      </p:sp>
-      <p:sp>
-        <p:nvSpPr>
-          <p:cNvPr id="7" name="TextBox 6"/>
-          <p:cNvSpPr txBox="1"/>
-          <p:nvPr/>
-        </p:nvSpPr>
-        <p:spPr>
-          <a:xfrm>
-            <a:off x="6400800" y="438912"/>
-            <a:ext cx="5257800" cy="274320"/>
-          </a:xfrm>
-          <a:prstGeom prst="rect">
-            <a:avLst/>
-          </a:prstGeom>
-          <a:noFill/>
-        </p:spPr>
-        <p:txBody>
-          <a:bodyPr wrap="square">
-            <a:spAutoFit/>
-          </a:bodyPr>
-          <a:lstStyle/>
-          <a:p>
-            <a:pPr algn="r"/>
-            <a:r>
-              <a:rPr sz="1200" b="0">
-                <a:solidFill>
-                  <a:srgbClr val="5A6973"/>
-                </a:solidFill>
-                <a:latin typeface="Aptos"/>
-              </a:rPr>
-              <a:t>Definition, Purpose, and Scope</a:t>
-            </a:r>
-          </a:p>
-        </p:txBody>
-      </p:sp>
-      <p:sp>
-        <p:nvSpPr>
-          <p:cNvPr id="8" name="TextBox 7"/>
-          <p:cNvSpPr txBox="1"/>
-          <p:nvPr/>
-        </p:nvSpPr>
-        <p:spPr>
-          <a:xfrm>
-            <a:off x="502920" y="6473952"/>
+          <p:cNvPr id="25" name="TextBox 24"/>
+          <p:cNvSpPr txBox="1"/>
+          <p:nvPr/>
+        </p:nvSpPr>
+        <p:spPr>
+          <a:xfrm>
+            <a:off x="594360" y="6446520"/>
             <a:ext cx="7315200" cy="182880"/>
           </a:xfrm>
           <a:prstGeom prst="rect">
@@ -3346,7 +4036,7 @@
           <a:lstStyle/>
           <a:p>
             <a:r>
-              <a:rPr sz="850" b="0">
+              <a:rPr sz="850" b="0" i="0">
                 <a:solidFill>
                   <a:srgbClr val="78828C"/>
                 </a:solidFill>
@@ -3359,13 +4049,13 @@
       </p:sp>
       <p:sp>
         <p:nvSpPr>
-          <p:cNvPr id="9" name="TextBox 8"/>
-          <p:cNvSpPr txBox="1"/>
-          <p:nvPr/>
-        </p:nvSpPr>
-        <p:spPr>
-          <a:xfrm>
-            <a:off x="11292840" y="6473952"/>
+          <p:cNvPr id="26" name="TextBox 25"/>
+          <p:cNvSpPr txBox="1"/>
+          <p:nvPr/>
+        </p:nvSpPr>
+        <p:spPr>
+          <a:xfrm>
+            <a:off x="11292840" y="6446520"/>
             <a:ext cx="502920" cy="182880"/>
           </a:xfrm>
           <a:prstGeom prst="rect">
@@ -3381,7 +4071,7 @@
           <a:p>
             <a:pPr algn="r"/>
             <a:r>
-              <a:rPr sz="850" b="0">
+              <a:rPr sz="850" b="0" i="0">
                 <a:solidFill>
                   <a:srgbClr val="78828C"/>
                 </a:solidFill>

</xml_diff>